<commit_message>
docs: refactor materials into learner-first OS lab kit
</commit_message>
<xml_diff>
--- a/slides/final_defense_ppt.pptx
+++ b/slides/final_defense_ppt.pptx
@@ -6673,7 +6673,7 @@
                 <a:ea typeface="Microsoft YaHei"/>
                 <a:cs typeface="Microsoft YaHei"/>
               </a:rPr>
-              <a:t>• 分阶段实验体系覆盖 syscall、proc、pagetable、file/fd table。</a:t>
+              <a:t>• 分阶段实验体系覆盖 syscall、proc、pagetable、file/fd table，进阶 memstat/fdinfo 补上 copyout + struct ABI。</a:t>
             </a:r>
             <a:endParaRPr lang="zh-CN" sz="1200"/>
           </a:p>
@@ -6688,6 +6688,21 @@
                 <a:ea typeface="Microsoft YaHei"/>
                 <a:cs typeface="Microsoft YaHei"/>
               </a:rPr>
+              <a:t>• 可直接开课：每个 lab 有学生任务书（必做/选做/rubric），配教师指南、评分标准、troubleshooting。</a:t>
+            </a:r>
+            <a:endParaRPr lang="zh-CN" sz="1200"/>
+          </a:p>
+          <a:p>
+            <a:pPr algn="l"/>
+            <a:r>
+              <a:rPr lang="zh-CN" sz="1200">
+                <a:solidFill>
+                  <a:srgbClr val="FFFFFF"/>
+                </a:solidFill>
+                <a:latin typeface="Microsoft YaHei"/>
+                <a:ea typeface="Microsoft YaHei"/>
+                <a:cs typeface="Microsoft YaHei"/>
+              </a:rPr>
               <a:t>• clean-baseline patch workflow 便于教学、审查和复现。</a:t>
             </a:r>
             <a:endParaRPr lang="zh-CN" sz="1200"/>
@@ -6703,22 +6718,7 @@
                 <a:ea typeface="Microsoft YaHei"/>
                 <a:cs typeface="Microsoft YaHei"/>
               </a:rPr>
-              <a:t>• full/quick teammate verification 降低队友复现门槛。</a:t>
-            </a:r>
-            <a:endParaRPr lang="zh-CN" sz="1200"/>
-          </a:p>
-          <a:p>
-            <a:pPr algn="l"/>
-            <a:r>
-              <a:rPr lang="zh-CN" sz="1200">
-                <a:solidFill>
-                  <a:srgbClr val="FFFFFF"/>
-                </a:solidFill>
-                <a:latin typeface="Microsoft YaHei"/>
-                <a:ea typeface="Microsoft YaHei"/>
-                <a:cs typeface="Microsoft YaHei"/>
-              </a:rPr>
-              <a:t>• QEMU timeout/cleanup 改善真实复现体验。</a:t>
+              <a:t>• full/quick teammate verification 降低队友复现门槛；QEMU timeout/cleanup 处理真实卡点。</a:t>
             </a:r>
             <a:endParaRPr lang="zh-CN" sz="1200"/>
           </a:p>
@@ -7325,7 +7325,7 @@
                 <a:ea typeface="Microsoft YaHei"/>
                 <a:cs typeface="Microsoft YaHei"/>
               </a:rPr>
-              <a:t>• `pgcount()` 不是完整内存管理；`fcount()` / `fdcount()` 不是完整文件系统。</a:t>
+              <a:t>• `pgcount()`/`memstat()` 不是完整内存管理；`fcount()`/`fdcount()`/`fdinfo()` 不是完整文件系统。</a:t>
             </a:r>
             <a:endParaRPr lang="zh-CN" sz="1200"/>
           </a:p>
@@ -7355,7 +7355,7 @@
                 <a:ea typeface="Microsoft YaHei"/>
                 <a:cs typeface="Microsoft YaHei"/>
               </a:rPr>
-              <a:t>• timeout/QEMU 输出捕获不是长期稳定性测试。</a:t>
+              <a:t>• timeout/QEMU 输出捕获不是长期稳定性测试；`0001-0009` 队友复现与新视频为 TBD。</a:t>
             </a:r>
             <a:endParaRPr lang="zh-CN" sz="1200"/>
           </a:p>
@@ -7385,7 +7385,7 @@
                 <a:ea typeface="Microsoft YaHei"/>
                 <a:cs typeface="Microsoft YaHei"/>
               </a:rPr>
-              <a:t>• 总结：可教、可复现、可验证、可扩展。</a:t>
+              <a:t>• 总结：学生能看懂、老师能布置、助教能验收、评委能复现。</a:t>
             </a:r>
             <a:endParaRPr lang="zh-CN" sz="1200"/>
           </a:p>
@@ -8170,7 +8170,7 @@
                 <a:ea typeface="Microsoft YaHei"/>
                 <a:cs typeface="Microsoft YaHei"/>
               </a:rPr>
-              <a:t>• 本项目按“可教、可复现、可验收、可扩展”组织材料。</a:t>
+              <a:t>• 材料组织目标：学生能看懂、老师能布置、助教能验收、评委能复现。</a:t>
             </a:r>
             <a:endParaRPr lang="zh-CN" sz="1200"/>
           </a:p>

</xml_diff>

<commit_message>
docs: polish final materials and add external asset link
</commit_message>
<xml_diff>
--- a/slides/final_defense_ppt.pptx
+++ b/slides/final_defense_ppt.pptx
@@ -197,7 +197,7 @@
                 <a:ea typeface="Microsoft YaHei"/>
                 <a:cs typeface="Microsoft YaHei"/>
               </a:rPr>
-              <a:t>开场先明确本项目是教学型功能挑战项目，主线是课程实验体系和可复现验证，不是内核实现赛道的 LTP 覆盖项目。</a:t>
+              <a:t>开场用一句话讲清定位：九个 syscall 只是素材，真正的工作是把它们组织成学生能学、老师能布置、助教能验收、评委能复现的课程实验包；本项目不是内核实现赛道的 LTP 覆盖项目。</a:t>
             </a:r>
             <a:endParaRPr lang="zh-CN" sz="1200"/>
           </a:p>
@@ -2768,7 +2768,7 @@
                 <a:ea typeface="Microsoft YaHei"/>
                 <a:cs typeface="Microsoft YaHei"/>
               </a:rPr>
-              <a:t>面向中国海洋大学操作系统课程的 xv6-riscv 分阶段实验指导、参考实现与可复现验证体系。</a:t>
+              <a:t>我们不只是给 xv6 加了九个系统调用，而是把它们整理成了一个可学习、可复现、可验收的 OS 入门实验包。</a:t>
             </a:r>
             <a:endParaRPr lang="zh-CN" sz="1600"/>
           </a:p>
@@ -5399,7 +5399,22 @@
                 <a:ea typeface="Microsoft YaHei"/>
                 <a:cs typeface="Microsoft YaHei"/>
               </a:rPr>
-              <a:t>• 中央索引：`submissions/evidence_manifest.md`。</a:t>
+              <a:t>• 外部资产包已上传百度网盘（目录 `proj54_submission_assets`，链接+提取码见 evidence manifest）；大文件不入 Git。</a:t>
+            </a:r>
+            <a:endParaRPr lang="zh-CN" sz="1200"/>
+          </a:p>
+          <a:p>
+            <a:pPr algn="l"/>
+            <a:r>
+              <a:rPr lang="zh-CN" sz="1200">
+                <a:solidFill>
+                  <a:srgbClr val="FFFFFF"/>
+                </a:solidFill>
+                <a:latin typeface="Microsoft YaHei"/>
+                <a:ea typeface="Microsoft YaHei"/>
+                <a:cs typeface="Microsoft YaHei"/>
+              </a:rPr>
+              <a:t>• 中央索引：`submissions/evidence_manifest.md`；哈希核验：`scripts/check-evidence-sha256.sh`（实测 14/14 matched）。</a:t>
             </a:r>
             <a:endParaRPr lang="zh-CN" sz="1200"/>
           </a:p>

</xml_diff>

<commit_message>
docs: polish final submission materials in Chinese
</commit_message>
<xml_diff>
--- a/slides/final_defense_ppt.pptx
+++ b/slides/final_defense_ppt.pptx
@@ -205,9 +205,9 @@
             </a:lvl1pPr>
           </a:lstStyle>
           <a:p>
-            <a:fld id="{AF336372-A25F-4368-8962-B4BF27106C7A}" type="datetimeFigureOut">
+            <a:fld id="{C2ABF5E0-78E1-4E4D-BDD0-4F95DAA118F3}" type="datetimeFigureOut">
               <a:rPr lang="zh-CN" altLang="en-US" smtClean="0"/>
-              <a:t>2026/6/11</a:t>
+              <a:t>2026/6/12</a:t>
             </a:fld>
             <a:endParaRPr lang="zh-CN" altLang="en-US"/>
           </a:p>
@@ -363,7 +363,7 @@
             </a:lvl1pPr>
           </a:lstStyle>
           <a:p>
-            <a:fld id="{67EA2E30-806A-480E-8F92-6D6AC26C6F2A}" type="slidenum">
+            <a:fld id="{9D156092-2602-402C-B385-CF82125146A4}" type="slidenum">
               <a:rPr lang="zh-CN" altLang="en-US" smtClean="0"/>
               <a:t>‹#›</a:t>
             </a:fld>
@@ -374,7 +374,7 @@
     </p:spTree>
     <p:extLst>
       <p:ext uri="{BB962C8B-B14F-4D97-AF65-F5344CB8AC3E}">
-        <p14:creationId xmlns:p14="http://schemas.microsoft.com/office/powerpoint/2010/main" val="3352667995"/>
+        <p14:creationId xmlns:p14="http://schemas.microsoft.com/office/powerpoint/2010/main" val="756933248"/>
       </p:ext>
     </p:extLst>
   </p:cSld>
@@ -563,7 +563,7 @@
           <a:bodyPr/>
           <a:lstStyle/>
           <a:p>
-            <a:fld id="{67EA2E30-806A-480E-8F92-6D6AC26C6F2A}" type="slidenum">
+            <a:fld id="{9D156092-2602-402C-B385-CF82125146A4}" type="slidenum">
               <a:rPr lang="zh-CN" altLang="en-US" smtClean="0"/>
               <a:t>1</a:t>
             </a:fld>
@@ -574,7 +574,7 @@
     </p:spTree>
     <p:extLst>
       <p:ext uri="{BB962C8B-B14F-4D97-AF65-F5344CB8AC3E}">
-        <p14:creationId xmlns:p14="http://schemas.microsoft.com/office/powerpoint/2010/main" val="3812064456"/>
+        <p14:creationId xmlns:p14="http://schemas.microsoft.com/office/powerpoint/2010/main" val="1837030318"/>
       </p:ext>
     </p:extLst>
   </p:cSld>
@@ -664,7 +664,7 @@
           <a:bodyPr/>
           <a:lstStyle/>
           <a:p>
-            <a:fld id="{67EA2E30-806A-480E-8F92-6D6AC26C6F2A}" type="slidenum">
+            <a:fld id="{9D156092-2602-402C-B385-CF82125146A4}" type="slidenum">
               <a:rPr lang="zh-CN" altLang="en-US" smtClean="0"/>
               <a:t>10</a:t>
             </a:fld>
@@ -675,7 +675,7 @@
     </p:spTree>
     <p:extLst>
       <p:ext uri="{BB962C8B-B14F-4D97-AF65-F5344CB8AC3E}">
-        <p14:creationId xmlns:p14="http://schemas.microsoft.com/office/powerpoint/2010/main" val="315538144"/>
+        <p14:creationId xmlns:p14="http://schemas.microsoft.com/office/powerpoint/2010/main" val="4168280465"/>
       </p:ext>
     </p:extLst>
   </p:cSld>
@@ -756,7 +756,7 @@
           <a:bodyPr/>
           <a:lstStyle/>
           <a:p>
-            <a:fld id="{67EA2E30-806A-480E-8F92-6D6AC26C6F2A}" type="slidenum">
+            <a:fld id="{9D156092-2602-402C-B385-CF82125146A4}" type="slidenum">
               <a:rPr lang="zh-CN" altLang="en-US" smtClean="0"/>
               <a:t>11</a:t>
             </a:fld>
@@ -767,7 +767,7 @@
     </p:spTree>
     <p:extLst>
       <p:ext uri="{BB962C8B-B14F-4D97-AF65-F5344CB8AC3E}">
-        <p14:creationId xmlns:p14="http://schemas.microsoft.com/office/powerpoint/2010/main" val="3376125628"/>
+        <p14:creationId xmlns:p14="http://schemas.microsoft.com/office/powerpoint/2010/main" val="1869545704"/>
       </p:ext>
     </p:extLst>
   </p:cSld>
@@ -1046,7 +1046,7 @@
           <a:bodyPr/>
           <a:lstStyle/>
           <a:p>
-            <a:fld id="{67EA2E30-806A-480E-8F92-6D6AC26C6F2A}" type="slidenum">
+            <a:fld id="{9D156092-2602-402C-B385-CF82125146A4}" type="slidenum">
               <a:rPr lang="zh-CN" altLang="en-US" smtClean="0"/>
               <a:t>12</a:t>
             </a:fld>
@@ -1057,7 +1057,7 @@
     </p:spTree>
     <p:extLst>
       <p:ext uri="{BB962C8B-B14F-4D97-AF65-F5344CB8AC3E}">
-        <p14:creationId xmlns:p14="http://schemas.microsoft.com/office/powerpoint/2010/main" val="1099837776"/>
+        <p14:creationId xmlns:p14="http://schemas.microsoft.com/office/powerpoint/2010/main" val="2177446586"/>
       </p:ext>
     </p:extLst>
   </p:cSld>
@@ -1156,7 +1156,7 @@
           <a:bodyPr/>
           <a:lstStyle/>
           <a:p>
-            <a:fld id="{67EA2E30-806A-480E-8F92-6D6AC26C6F2A}" type="slidenum">
+            <a:fld id="{9D156092-2602-402C-B385-CF82125146A4}" type="slidenum">
               <a:rPr lang="zh-CN" altLang="en-US" smtClean="0"/>
               <a:t>13</a:t>
             </a:fld>
@@ -1167,7 +1167,7 @@
     </p:spTree>
     <p:extLst>
       <p:ext uri="{BB962C8B-B14F-4D97-AF65-F5344CB8AC3E}">
-        <p14:creationId xmlns:p14="http://schemas.microsoft.com/office/powerpoint/2010/main" val="3129303203"/>
+        <p14:creationId xmlns:p14="http://schemas.microsoft.com/office/powerpoint/2010/main" val="41771717"/>
       </p:ext>
     </p:extLst>
   </p:cSld>
@@ -1248,7 +1248,7 @@
           <a:bodyPr/>
           <a:lstStyle/>
           <a:p>
-            <a:fld id="{67EA2E30-806A-480E-8F92-6D6AC26C6F2A}" type="slidenum">
+            <a:fld id="{9D156092-2602-402C-B385-CF82125146A4}" type="slidenum">
               <a:rPr lang="zh-CN" altLang="en-US" smtClean="0"/>
               <a:t>14</a:t>
             </a:fld>
@@ -1259,7 +1259,7 @@
     </p:spTree>
     <p:extLst>
       <p:ext uri="{BB962C8B-B14F-4D97-AF65-F5344CB8AC3E}">
-        <p14:creationId xmlns:p14="http://schemas.microsoft.com/office/powerpoint/2010/main" val="2572412798"/>
+        <p14:creationId xmlns:p14="http://schemas.microsoft.com/office/powerpoint/2010/main" val="305685712"/>
       </p:ext>
     </p:extLst>
   </p:cSld>
@@ -1340,7 +1340,7 @@
           <a:bodyPr/>
           <a:lstStyle/>
           <a:p>
-            <a:fld id="{67EA2E30-806A-480E-8F92-6D6AC26C6F2A}" type="slidenum">
+            <a:fld id="{9D156092-2602-402C-B385-CF82125146A4}" type="slidenum">
               <a:rPr lang="zh-CN" altLang="en-US" smtClean="0"/>
               <a:t>15</a:t>
             </a:fld>
@@ -1351,7 +1351,7 @@
     </p:spTree>
     <p:extLst>
       <p:ext uri="{BB962C8B-B14F-4D97-AF65-F5344CB8AC3E}">
-        <p14:creationId xmlns:p14="http://schemas.microsoft.com/office/powerpoint/2010/main" val="4160256957"/>
+        <p14:creationId xmlns:p14="http://schemas.microsoft.com/office/powerpoint/2010/main" val="32151509"/>
       </p:ext>
     </p:extLst>
   </p:cSld>
@@ -1432,7 +1432,7 @@
           <a:bodyPr/>
           <a:lstStyle/>
           <a:p>
-            <a:fld id="{67EA2E30-806A-480E-8F92-6D6AC26C6F2A}" type="slidenum">
+            <a:fld id="{9D156092-2602-402C-B385-CF82125146A4}" type="slidenum">
               <a:rPr lang="zh-CN" altLang="en-US" smtClean="0"/>
               <a:t>16</a:t>
             </a:fld>
@@ -1443,7 +1443,7 @@
     </p:spTree>
     <p:extLst>
       <p:ext uri="{BB962C8B-B14F-4D97-AF65-F5344CB8AC3E}">
-        <p14:creationId xmlns:p14="http://schemas.microsoft.com/office/powerpoint/2010/main" val="1906727641"/>
+        <p14:creationId xmlns:p14="http://schemas.microsoft.com/office/powerpoint/2010/main" val="1733448763"/>
       </p:ext>
     </p:extLst>
   </p:cSld>
@@ -1542,7 +1542,7 @@
           <a:bodyPr/>
           <a:lstStyle/>
           <a:p>
-            <a:fld id="{67EA2E30-806A-480E-8F92-6D6AC26C6F2A}" type="slidenum">
+            <a:fld id="{9D156092-2602-402C-B385-CF82125146A4}" type="slidenum">
               <a:rPr lang="zh-CN" altLang="en-US" smtClean="0"/>
               <a:t>2</a:t>
             </a:fld>
@@ -1553,7 +1553,7 @@
     </p:spTree>
     <p:extLst>
       <p:ext uri="{BB962C8B-B14F-4D97-AF65-F5344CB8AC3E}">
-        <p14:creationId xmlns:p14="http://schemas.microsoft.com/office/powerpoint/2010/main" val="273412898"/>
+        <p14:creationId xmlns:p14="http://schemas.microsoft.com/office/powerpoint/2010/main" val="2835260925"/>
       </p:ext>
     </p:extLst>
   </p:cSld>
@@ -1652,7 +1652,7 @@
           <a:bodyPr/>
           <a:lstStyle/>
           <a:p>
-            <a:fld id="{67EA2E30-806A-480E-8F92-6D6AC26C6F2A}" type="slidenum">
+            <a:fld id="{9D156092-2602-402C-B385-CF82125146A4}" type="slidenum">
               <a:rPr lang="zh-CN" altLang="en-US" smtClean="0"/>
               <a:t>3</a:t>
             </a:fld>
@@ -1663,7 +1663,7 @@
     </p:spTree>
     <p:extLst>
       <p:ext uri="{BB962C8B-B14F-4D97-AF65-F5344CB8AC3E}">
-        <p14:creationId xmlns:p14="http://schemas.microsoft.com/office/powerpoint/2010/main" val="485578811"/>
+        <p14:creationId xmlns:p14="http://schemas.microsoft.com/office/powerpoint/2010/main" val="1706824230"/>
       </p:ext>
     </p:extLst>
   </p:cSld>
@@ -1834,7 +1834,7 @@
           <a:bodyPr/>
           <a:lstStyle/>
           <a:p>
-            <a:fld id="{67EA2E30-806A-480E-8F92-6D6AC26C6F2A}" type="slidenum">
+            <a:fld id="{9D156092-2602-402C-B385-CF82125146A4}" type="slidenum">
               <a:rPr lang="zh-CN" altLang="en-US" smtClean="0"/>
               <a:t>4</a:t>
             </a:fld>
@@ -1845,7 +1845,7 @@
     </p:spTree>
     <p:extLst>
       <p:ext uri="{BB962C8B-B14F-4D97-AF65-F5344CB8AC3E}">
-        <p14:creationId xmlns:p14="http://schemas.microsoft.com/office/powerpoint/2010/main" val="3424282355"/>
+        <p14:creationId xmlns:p14="http://schemas.microsoft.com/office/powerpoint/2010/main" val="887895597"/>
       </p:ext>
     </p:extLst>
   </p:cSld>
@@ -2016,7 +2016,7 @@
           <a:bodyPr/>
           <a:lstStyle/>
           <a:p>
-            <a:fld id="{67EA2E30-806A-480E-8F92-6D6AC26C6F2A}" type="slidenum">
+            <a:fld id="{9D156092-2602-402C-B385-CF82125146A4}" type="slidenum">
               <a:rPr lang="zh-CN" altLang="en-US" smtClean="0"/>
               <a:t>5</a:t>
             </a:fld>
@@ -2027,7 +2027,7 @@
     </p:spTree>
     <p:extLst>
       <p:ext uri="{BB962C8B-B14F-4D97-AF65-F5344CB8AC3E}">
-        <p14:creationId xmlns:p14="http://schemas.microsoft.com/office/powerpoint/2010/main" val="84961849"/>
+        <p14:creationId xmlns:p14="http://schemas.microsoft.com/office/powerpoint/2010/main" val="449126052"/>
       </p:ext>
     </p:extLst>
   </p:cSld>
@@ -2153,7 +2153,7 @@
           <a:bodyPr/>
           <a:lstStyle/>
           <a:p>
-            <a:fld id="{67EA2E30-806A-480E-8F92-6D6AC26C6F2A}" type="slidenum">
+            <a:fld id="{9D156092-2602-402C-B385-CF82125146A4}" type="slidenum">
               <a:rPr lang="zh-CN" altLang="en-US" smtClean="0"/>
               <a:t>6</a:t>
             </a:fld>
@@ -2164,7 +2164,7 @@
     </p:spTree>
     <p:extLst>
       <p:ext uri="{BB962C8B-B14F-4D97-AF65-F5344CB8AC3E}">
-        <p14:creationId xmlns:p14="http://schemas.microsoft.com/office/powerpoint/2010/main" val="1630411214"/>
+        <p14:creationId xmlns:p14="http://schemas.microsoft.com/office/powerpoint/2010/main" val="3328885475"/>
       </p:ext>
     </p:extLst>
   </p:cSld>
@@ -2308,7 +2308,7 @@
           <a:bodyPr/>
           <a:lstStyle/>
           <a:p>
-            <a:fld id="{67EA2E30-806A-480E-8F92-6D6AC26C6F2A}" type="slidenum">
+            <a:fld id="{9D156092-2602-402C-B385-CF82125146A4}" type="slidenum">
               <a:rPr lang="zh-CN" altLang="en-US" smtClean="0"/>
               <a:t>7</a:t>
             </a:fld>
@@ -2319,7 +2319,7 @@
     </p:spTree>
     <p:extLst>
       <p:ext uri="{BB962C8B-B14F-4D97-AF65-F5344CB8AC3E}">
-        <p14:creationId xmlns:p14="http://schemas.microsoft.com/office/powerpoint/2010/main" val="3947409130"/>
+        <p14:creationId xmlns:p14="http://schemas.microsoft.com/office/powerpoint/2010/main" val="1406568178"/>
       </p:ext>
     </p:extLst>
   </p:cSld>
@@ -2472,7 +2472,7 @@
           <a:bodyPr/>
           <a:lstStyle/>
           <a:p>
-            <a:fld id="{67EA2E30-806A-480E-8F92-6D6AC26C6F2A}" type="slidenum">
+            <a:fld id="{9D156092-2602-402C-B385-CF82125146A4}" type="slidenum">
               <a:rPr lang="zh-CN" altLang="en-US" smtClean="0"/>
               <a:t>8</a:t>
             </a:fld>
@@ -2483,7 +2483,7 @@
     </p:spTree>
     <p:extLst>
       <p:ext uri="{BB962C8B-B14F-4D97-AF65-F5344CB8AC3E}">
-        <p14:creationId xmlns:p14="http://schemas.microsoft.com/office/powerpoint/2010/main" val="1531965844"/>
+        <p14:creationId xmlns:p14="http://schemas.microsoft.com/office/powerpoint/2010/main" val="547050917"/>
       </p:ext>
     </p:extLst>
   </p:cSld>
@@ -2690,7 +2690,7 @@
           <a:bodyPr/>
           <a:lstStyle/>
           <a:p>
-            <a:fld id="{67EA2E30-806A-480E-8F92-6D6AC26C6F2A}" type="slidenum">
+            <a:fld id="{9D156092-2602-402C-B385-CF82125146A4}" type="slidenum">
               <a:rPr lang="zh-CN" altLang="en-US" smtClean="0"/>
               <a:t>9</a:t>
             </a:fld>
@@ -2701,7 +2701,7 @@
     </p:spTree>
     <p:extLst>
       <p:ext uri="{BB962C8B-B14F-4D97-AF65-F5344CB8AC3E}">
-        <p14:creationId xmlns:p14="http://schemas.microsoft.com/office/powerpoint/2010/main" val="3622560902"/>
+        <p14:creationId xmlns:p14="http://schemas.microsoft.com/office/powerpoint/2010/main" val="3915929001"/>
       </p:ext>
     </p:extLst>
   </p:cSld>
@@ -2733,7 +2733,7 @@
           <p:cNvPr id="2" name="标题 1">
             <a:extLst>
               <a:ext uri="{FF2B5EF4-FFF2-40B4-BE49-F238E27FC236}">
-                <a16:creationId xmlns:a16="http://schemas.microsoft.com/office/drawing/2014/main" id="{98168855-CCBD-3EB7-D80C-A8CB8074C58C}"/>
+                <a16:creationId xmlns:a16="http://schemas.microsoft.com/office/drawing/2014/main" id="{4DD45E4E-69F7-864C-5552-9C354B87F9FA}"/>
               </a:ext>
             </a:extLst>
           </p:cNvPr>
@@ -2770,7 +2770,7 @@
           <p:cNvPr id="3" name="副标题 2">
             <a:extLst>
               <a:ext uri="{FF2B5EF4-FFF2-40B4-BE49-F238E27FC236}">
-                <a16:creationId xmlns:a16="http://schemas.microsoft.com/office/drawing/2014/main" id="{3BB2D522-4F05-424E-B6AA-71817B21FB49}"/>
+                <a16:creationId xmlns:a16="http://schemas.microsoft.com/office/drawing/2014/main" id="{83D100A4-8BF3-B22E-C8EA-D69CA68A675A}"/>
               </a:ext>
             </a:extLst>
           </p:cNvPr>
@@ -2840,7 +2840,7 @@
           <p:cNvPr id="4" name="日期占位符 3">
             <a:extLst>
               <a:ext uri="{FF2B5EF4-FFF2-40B4-BE49-F238E27FC236}">
-                <a16:creationId xmlns:a16="http://schemas.microsoft.com/office/drawing/2014/main" id="{C3519304-122F-0015-5DA2-84AA9934ACC5}"/>
+                <a16:creationId xmlns:a16="http://schemas.microsoft.com/office/drawing/2014/main" id="{DB4BD521-A760-1988-C6B4-A5E6B6688046}"/>
               </a:ext>
             </a:extLst>
           </p:cNvPr>
@@ -2856,9 +2856,9 @@
           <a:bodyPr/>
           <a:lstStyle/>
           <a:p>
-            <a:fld id="{BCA83E38-FE1A-46D7-AAB8-6C2A5536F75A}" type="datetimeFigureOut">
+            <a:fld id="{97357630-3157-4AFD-A157-330645C89275}" type="datetimeFigureOut">
               <a:rPr lang="zh-CN" altLang="en-US" smtClean="0"/>
-              <a:t>2026/6/11</a:t>
+              <a:t>2026/6/12</a:t>
             </a:fld>
             <a:endParaRPr lang="zh-CN" altLang="en-US"/>
           </a:p>
@@ -2869,7 +2869,7 @@
           <p:cNvPr id="5" name="页脚占位符 4">
             <a:extLst>
               <a:ext uri="{FF2B5EF4-FFF2-40B4-BE49-F238E27FC236}">
-                <a16:creationId xmlns:a16="http://schemas.microsoft.com/office/drawing/2014/main" id="{9B582E84-3D4C-9F5B-C3A9-425DD9D110DF}"/>
+                <a16:creationId xmlns:a16="http://schemas.microsoft.com/office/drawing/2014/main" id="{A9FFAB83-0361-8E0A-5909-3A7D8A11235C}"/>
               </a:ext>
             </a:extLst>
           </p:cNvPr>
@@ -2894,7 +2894,7 @@
           <p:cNvPr id="6" name="灯片编号占位符 5">
             <a:extLst>
               <a:ext uri="{FF2B5EF4-FFF2-40B4-BE49-F238E27FC236}">
-                <a16:creationId xmlns:a16="http://schemas.microsoft.com/office/drawing/2014/main" id="{9C0E8243-5800-BC57-7F8D-D8E904C9C410}"/>
+                <a16:creationId xmlns:a16="http://schemas.microsoft.com/office/drawing/2014/main" id="{35D07592-A57D-631D-5D42-4E453F8F38BC}"/>
               </a:ext>
             </a:extLst>
           </p:cNvPr>
@@ -2910,7 +2910,7 @@
           <a:bodyPr/>
           <a:lstStyle/>
           <a:p>
-            <a:fld id="{9DD4CD2A-584A-455B-ADD7-345520253A92}" type="slidenum">
+            <a:fld id="{1B705F75-E3BA-4423-87D1-0E68AC9F841F}" type="slidenum">
               <a:rPr lang="zh-CN" altLang="en-US" smtClean="0"/>
               <a:t>‹#›</a:t>
             </a:fld>
@@ -2921,7 +2921,7 @@
     </p:spTree>
     <p:extLst>
       <p:ext uri="{BB962C8B-B14F-4D97-AF65-F5344CB8AC3E}">
-        <p14:creationId xmlns:p14="http://schemas.microsoft.com/office/powerpoint/2010/main" val="1783749646"/>
+        <p14:creationId xmlns:p14="http://schemas.microsoft.com/office/powerpoint/2010/main" val="2467312309"/>
       </p:ext>
     </p:extLst>
   </p:cSld>
@@ -2953,7 +2953,7 @@
           <p:cNvPr id="2" name="标题 1">
             <a:extLst>
               <a:ext uri="{FF2B5EF4-FFF2-40B4-BE49-F238E27FC236}">
-                <a16:creationId xmlns:a16="http://schemas.microsoft.com/office/drawing/2014/main" id="{37F16A1B-253D-44E0-ED39-7B37CD389085}"/>
+                <a16:creationId xmlns:a16="http://schemas.microsoft.com/office/drawing/2014/main" id="{4D4A6F04-76F9-EA40-6921-3A43E28957C7}"/>
               </a:ext>
             </a:extLst>
           </p:cNvPr>
@@ -2981,7 +2981,7 @@
           <p:cNvPr id="3" name="竖排文字占位符 2">
             <a:extLst>
               <a:ext uri="{FF2B5EF4-FFF2-40B4-BE49-F238E27FC236}">
-                <a16:creationId xmlns:a16="http://schemas.microsoft.com/office/drawing/2014/main" id="{6DB2CA4A-18F4-78F6-DD47-8A7E613E1766}"/>
+                <a16:creationId xmlns:a16="http://schemas.microsoft.com/office/drawing/2014/main" id="{CC7073BB-A34B-45F6-6290-8B5EB7C9A499}"/>
               </a:ext>
             </a:extLst>
           </p:cNvPr>
@@ -3038,7 +3038,7 @@
           <p:cNvPr id="4" name="日期占位符 3">
             <a:extLst>
               <a:ext uri="{FF2B5EF4-FFF2-40B4-BE49-F238E27FC236}">
-                <a16:creationId xmlns:a16="http://schemas.microsoft.com/office/drawing/2014/main" id="{51BE2741-84F4-6094-41B2-A4700982F7B1}"/>
+                <a16:creationId xmlns:a16="http://schemas.microsoft.com/office/drawing/2014/main" id="{0BA933FA-5FD2-6BB2-CE1B-0ECC79D8AE16}"/>
               </a:ext>
             </a:extLst>
           </p:cNvPr>
@@ -3054,9 +3054,9 @@
           <a:bodyPr/>
           <a:lstStyle/>
           <a:p>
-            <a:fld id="{BCA83E38-FE1A-46D7-AAB8-6C2A5536F75A}" type="datetimeFigureOut">
+            <a:fld id="{97357630-3157-4AFD-A157-330645C89275}" type="datetimeFigureOut">
               <a:rPr lang="zh-CN" altLang="en-US" smtClean="0"/>
-              <a:t>2026/6/11</a:t>
+              <a:t>2026/6/12</a:t>
             </a:fld>
             <a:endParaRPr lang="zh-CN" altLang="en-US"/>
           </a:p>
@@ -3067,7 +3067,7 @@
           <p:cNvPr id="5" name="页脚占位符 4">
             <a:extLst>
               <a:ext uri="{FF2B5EF4-FFF2-40B4-BE49-F238E27FC236}">
-                <a16:creationId xmlns:a16="http://schemas.microsoft.com/office/drawing/2014/main" id="{928A572D-91D3-EC73-D4AD-006B5B3A1CEE}"/>
+                <a16:creationId xmlns:a16="http://schemas.microsoft.com/office/drawing/2014/main" id="{22EEC07C-4F22-A2C5-6BE0-53E7997362DB}"/>
               </a:ext>
             </a:extLst>
           </p:cNvPr>
@@ -3092,7 +3092,7 @@
           <p:cNvPr id="6" name="灯片编号占位符 5">
             <a:extLst>
               <a:ext uri="{FF2B5EF4-FFF2-40B4-BE49-F238E27FC236}">
-                <a16:creationId xmlns:a16="http://schemas.microsoft.com/office/drawing/2014/main" id="{715C5B6F-C95A-E91D-2826-0AB6B47C28E2}"/>
+                <a16:creationId xmlns:a16="http://schemas.microsoft.com/office/drawing/2014/main" id="{EE1D98DB-192D-4DB5-57B4-DA9460742A8F}"/>
               </a:ext>
             </a:extLst>
           </p:cNvPr>
@@ -3108,7 +3108,7 @@
           <a:bodyPr/>
           <a:lstStyle/>
           <a:p>
-            <a:fld id="{9DD4CD2A-584A-455B-ADD7-345520253A92}" type="slidenum">
+            <a:fld id="{1B705F75-E3BA-4423-87D1-0E68AC9F841F}" type="slidenum">
               <a:rPr lang="zh-CN" altLang="en-US" smtClean="0"/>
               <a:t>‹#›</a:t>
             </a:fld>
@@ -3119,7 +3119,7 @@
     </p:spTree>
     <p:extLst>
       <p:ext uri="{BB962C8B-B14F-4D97-AF65-F5344CB8AC3E}">
-        <p14:creationId xmlns:p14="http://schemas.microsoft.com/office/powerpoint/2010/main" val="289763170"/>
+        <p14:creationId xmlns:p14="http://schemas.microsoft.com/office/powerpoint/2010/main" val="106379066"/>
       </p:ext>
     </p:extLst>
   </p:cSld>
@@ -3151,7 +3151,7 @@
           <p:cNvPr id="2" name="竖排标题 1">
             <a:extLst>
               <a:ext uri="{FF2B5EF4-FFF2-40B4-BE49-F238E27FC236}">
-                <a16:creationId xmlns:a16="http://schemas.microsoft.com/office/drawing/2014/main" id="{8B657317-C372-4BE5-D559-5CC42F0248D2}"/>
+                <a16:creationId xmlns:a16="http://schemas.microsoft.com/office/drawing/2014/main" id="{802CE0CF-82ED-5DEF-C202-C802D89CE397}"/>
               </a:ext>
             </a:extLst>
           </p:cNvPr>
@@ -3184,7 +3184,7 @@
           <p:cNvPr id="3" name="竖排文字占位符 2">
             <a:extLst>
               <a:ext uri="{FF2B5EF4-FFF2-40B4-BE49-F238E27FC236}">
-                <a16:creationId xmlns:a16="http://schemas.microsoft.com/office/drawing/2014/main" id="{E62C7B1E-7FEA-D777-8841-DF15CAA1ED7F}"/>
+                <a16:creationId xmlns:a16="http://schemas.microsoft.com/office/drawing/2014/main" id="{05570094-CCF3-BAF3-20FC-FE0ECDF3915C}"/>
               </a:ext>
             </a:extLst>
           </p:cNvPr>
@@ -3246,7 +3246,7 @@
           <p:cNvPr id="4" name="日期占位符 3">
             <a:extLst>
               <a:ext uri="{FF2B5EF4-FFF2-40B4-BE49-F238E27FC236}">
-                <a16:creationId xmlns:a16="http://schemas.microsoft.com/office/drawing/2014/main" id="{A69D10DD-5192-9DB1-5010-66907CED95F1}"/>
+                <a16:creationId xmlns:a16="http://schemas.microsoft.com/office/drawing/2014/main" id="{F848E4AB-1375-24CB-6818-A3CAFA5DED33}"/>
               </a:ext>
             </a:extLst>
           </p:cNvPr>
@@ -3262,9 +3262,9 @@
           <a:bodyPr/>
           <a:lstStyle/>
           <a:p>
-            <a:fld id="{BCA83E38-FE1A-46D7-AAB8-6C2A5536F75A}" type="datetimeFigureOut">
+            <a:fld id="{97357630-3157-4AFD-A157-330645C89275}" type="datetimeFigureOut">
               <a:rPr lang="zh-CN" altLang="en-US" smtClean="0"/>
-              <a:t>2026/6/11</a:t>
+              <a:t>2026/6/12</a:t>
             </a:fld>
             <a:endParaRPr lang="zh-CN" altLang="en-US"/>
           </a:p>
@@ -3275,7 +3275,7 @@
           <p:cNvPr id="5" name="页脚占位符 4">
             <a:extLst>
               <a:ext uri="{FF2B5EF4-FFF2-40B4-BE49-F238E27FC236}">
-                <a16:creationId xmlns:a16="http://schemas.microsoft.com/office/drawing/2014/main" id="{F9A45D31-DA46-97D5-2774-7F71C152AE64}"/>
+                <a16:creationId xmlns:a16="http://schemas.microsoft.com/office/drawing/2014/main" id="{CB564609-9271-C4EA-F7C2-20904C91B23C}"/>
               </a:ext>
             </a:extLst>
           </p:cNvPr>
@@ -3300,7 +3300,7 @@
           <p:cNvPr id="6" name="灯片编号占位符 5">
             <a:extLst>
               <a:ext uri="{FF2B5EF4-FFF2-40B4-BE49-F238E27FC236}">
-                <a16:creationId xmlns:a16="http://schemas.microsoft.com/office/drawing/2014/main" id="{16A9F4D9-47F1-771C-9C8A-0B7EF2C7A3CF}"/>
+                <a16:creationId xmlns:a16="http://schemas.microsoft.com/office/drawing/2014/main" id="{316A6C5D-5393-D096-CF41-4BD3AEA82358}"/>
               </a:ext>
             </a:extLst>
           </p:cNvPr>
@@ -3316,7 +3316,7 @@
           <a:bodyPr/>
           <a:lstStyle/>
           <a:p>
-            <a:fld id="{9DD4CD2A-584A-455B-ADD7-345520253A92}" type="slidenum">
+            <a:fld id="{1B705F75-E3BA-4423-87D1-0E68AC9F841F}" type="slidenum">
               <a:rPr lang="zh-CN" altLang="en-US" smtClean="0"/>
               <a:t>‹#›</a:t>
             </a:fld>
@@ -3327,7 +3327,7 @@
     </p:spTree>
     <p:extLst>
       <p:ext uri="{BB962C8B-B14F-4D97-AF65-F5344CB8AC3E}">
-        <p14:creationId xmlns:p14="http://schemas.microsoft.com/office/powerpoint/2010/main" val="3304785534"/>
+        <p14:creationId xmlns:p14="http://schemas.microsoft.com/office/powerpoint/2010/main" val="857997332"/>
       </p:ext>
     </p:extLst>
   </p:cSld>
@@ -3359,7 +3359,7 @@
           <p:cNvPr id="2" name="标题 1">
             <a:extLst>
               <a:ext uri="{FF2B5EF4-FFF2-40B4-BE49-F238E27FC236}">
-                <a16:creationId xmlns:a16="http://schemas.microsoft.com/office/drawing/2014/main" id="{D740502F-50DE-7058-0790-D128256EF672}"/>
+                <a16:creationId xmlns:a16="http://schemas.microsoft.com/office/drawing/2014/main" id="{B2AA2085-30F1-8C8C-98D8-1378F2BAF524}"/>
               </a:ext>
             </a:extLst>
           </p:cNvPr>
@@ -3387,7 +3387,7 @@
           <p:cNvPr id="3" name="内容占位符 2">
             <a:extLst>
               <a:ext uri="{FF2B5EF4-FFF2-40B4-BE49-F238E27FC236}">
-                <a16:creationId xmlns:a16="http://schemas.microsoft.com/office/drawing/2014/main" id="{FA1796B7-16FC-102C-B7E8-BFA20AE57304}"/>
+                <a16:creationId xmlns:a16="http://schemas.microsoft.com/office/drawing/2014/main" id="{95240413-92E6-6B6F-974D-E06FBAB6ADC5}"/>
               </a:ext>
             </a:extLst>
           </p:cNvPr>
@@ -3444,7 +3444,7 @@
           <p:cNvPr id="4" name="日期占位符 3">
             <a:extLst>
               <a:ext uri="{FF2B5EF4-FFF2-40B4-BE49-F238E27FC236}">
-                <a16:creationId xmlns:a16="http://schemas.microsoft.com/office/drawing/2014/main" id="{2B72B3FF-CD8D-7469-A96A-DDF16645F50B}"/>
+                <a16:creationId xmlns:a16="http://schemas.microsoft.com/office/drawing/2014/main" id="{A197E261-25AA-B074-3A6F-F08DE3FEDF27}"/>
               </a:ext>
             </a:extLst>
           </p:cNvPr>
@@ -3460,9 +3460,9 @@
           <a:bodyPr/>
           <a:lstStyle/>
           <a:p>
-            <a:fld id="{BCA83E38-FE1A-46D7-AAB8-6C2A5536F75A}" type="datetimeFigureOut">
+            <a:fld id="{97357630-3157-4AFD-A157-330645C89275}" type="datetimeFigureOut">
               <a:rPr lang="zh-CN" altLang="en-US" smtClean="0"/>
-              <a:t>2026/6/11</a:t>
+              <a:t>2026/6/12</a:t>
             </a:fld>
             <a:endParaRPr lang="zh-CN" altLang="en-US"/>
           </a:p>
@@ -3473,7 +3473,7 @@
           <p:cNvPr id="5" name="页脚占位符 4">
             <a:extLst>
               <a:ext uri="{FF2B5EF4-FFF2-40B4-BE49-F238E27FC236}">
-                <a16:creationId xmlns:a16="http://schemas.microsoft.com/office/drawing/2014/main" id="{DA521682-7E74-B6E8-5F24-7D4DDA1ED09A}"/>
+                <a16:creationId xmlns:a16="http://schemas.microsoft.com/office/drawing/2014/main" id="{66A1C732-C36E-3130-67E5-FBD888D8124A}"/>
               </a:ext>
             </a:extLst>
           </p:cNvPr>
@@ -3498,7 +3498,7 @@
           <p:cNvPr id="6" name="灯片编号占位符 5">
             <a:extLst>
               <a:ext uri="{FF2B5EF4-FFF2-40B4-BE49-F238E27FC236}">
-                <a16:creationId xmlns:a16="http://schemas.microsoft.com/office/drawing/2014/main" id="{9987F4E5-2835-A365-F15B-6B0C58588F22}"/>
+                <a16:creationId xmlns:a16="http://schemas.microsoft.com/office/drawing/2014/main" id="{3ACFDFD1-9660-C112-9888-43EBA478F3BF}"/>
               </a:ext>
             </a:extLst>
           </p:cNvPr>
@@ -3514,7 +3514,7 @@
           <a:bodyPr/>
           <a:lstStyle/>
           <a:p>
-            <a:fld id="{9DD4CD2A-584A-455B-ADD7-345520253A92}" type="slidenum">
+            <a:fld id="{1B705F75-E3BA-4423-87D1-0E68AC9F841F}" type="slidenum">
               <a:rPr lang="zh-CN" altLang="en-US" smtClean="0"/>
               <a:t>‹#›</a:t>
             </a:fld>
@@ -3525,7 +3525,7 @@
     </p:spTree>
     <p:extLst>
       <p:ext uri="{BB962C8B-B14F-4D97-AF65-F5344CB8AC3E}">
-        <p14:creationId xmlns:p14="http://schemas.microsoft.com/office/powerpoint/2010/main" val="444506625"/>
+        <p14:creationId xmlns:p14="http://schemas.microsoft.com/office/powerpoint/2010/main" val="551990357"/>
       </p:ext>
     </p:extLst>
   </p:cSld>
@@ -3557,7 +3557,7 @@
           <p:cNvPr id="2" name="标题 1">
             <a:extLst>
               <a:ext uri="{FF2B5EF4-FFF2-40B4-BE49-F238E27FC236}">
-                <a16:creationId xmlns:a16="http://schemas.microsoft.com/office/drawing/2014/main" id="{22646FD1-57C7-D061-3E36-B923337977B8}"/>
+                <a16:creationId xmlns:a16="http://schemas.microsoft.com/office/drawing/2014/main" id="{F8C29C5A-A2DC-9646-DD03-3F9ECA102F16}"/>
               </a:ext>
             </a:extLst>
           </p:cNvPr>
@@ -3594,7 +3594,7 @@
           <p:cNvPr id="3" name="文本占位符 2">
             <a:extLst>
               <a:ext uri="{FF2B5EF4-FFF2-40B4-BE49-F238E27FC236}">
-                <a16:creationId xmlns:a16="http://schemas.microsoft.com/office/drawing/2014/main" id="{0FADD52B-B5AA-E297-F330-57333441B5F0}"/>
+                <a16:creationId xmlns:a16="http://schemas.microsoft.com/office/drawing/2014/main" id="{0EC71772-2D98-BDCD-2A24-3289507FA7B3}"/>
               </a:ext>
             </a:extLst>
           </p:cNvPr>
@@ -3719,7 +3719,7 @@
           <p:cNvPr id="4" name="日期占位符 3">
             <a:extLst>
               <a:ext uri="{FF2B5EF4-FFF2-40B4-BE49-F238E27FC236}">
-                <a16:creationId xmlns:a16="http://schemas.microsoft.com/office/drawing/2014/main" id="{C8B57D13-C1B3-A9CA-581B-0642446F3173}"/>
+                <a16:creationId xmlns:a16="http://schemas.microsoft.com/office/drawing/2014/main" id="{A0B449F3-4A09-4A78-1000-7ACCCB499199}"/>
               </a:ext>
             </a:extLst>
           </p:cNvPr>
@@ -3735,9 +3735,9 @@
           <a:bodyPr/>
           <a:lstStyle/>
           <a:p>
-            <a:fld id="{BCA83E38-FE1A-46D7-AAB8-6C2A5536F75A}" type="datetimeFigureOut">
+            <a:fld id="{97357630-3157-4AFD-A157-330645C89275}" type="datetimeFigureOut">
               <a:rPr lang="zh-CN" altLang="en-US" smtClean="0"/>
-              <a:t>2026/6/11</a:t>
+              <a:t>2026/6/12</a:t>
             </a:fld>
             <a:endParaRPr lang="zh-CN" altLang="en-US"/>
           </a:p>
@@ -3748,7 +3748,7 @@
           <p:cNvPr id="5" name="页脚占位符 4">
             <a:extLst>
               <a:ext uri="{FF2B5EF4-FFF2-40B4-BE49-F238E27FC236}">
-                <a16:creationId xmlns:a16="http://schemas.microsoft.com/office/drawing/2014/main" id="{49329875-BFFB-F0A6-48CD-734225E67063}"/>
+                <a16:creationId xmlns:a16="http://schemas.microsoft.com/office/drawing/2014/main" id="{0B6D3865-9381-425B-DA45-A0A4171C871D}"/>
               </a:ext>
             </a:extLst>
           </p:cNvPr>
@@ -3773,7 +3773,7 @@
           <p:cNvPr id="6" name="灯片编号占位符 5">
             <a:extLst>
               <a:ext uri="{FF2B5EF4-FFF2-40B4-BE49-F238E27FC236}">
-                <a16:creationId xmlns:a16="http://schemas.microsoft.com/office/drawing/2014/main" id="{9203AB45-02FF-83D0-6AB0-4AD955296E7C}"/>
+                <a16:creationId xmlns:a16="http://schemas.microsoft.com/office/drawing/2014/main" id="{474AC521-7C86-2CC1-F41A-608180F7FB6F}"/>
               </a:ext>
             </a:extLst>
           </p:cNvPr>
@@ -3789,7 +3789,7 @@
           <a:bodyPr/>
           <a:lstStyle/>
           <a:p>
-            <a:fld id="{9DD4CD2A-584A-455B-ADD7-345520253A92}" type="slidenum">
+            <a:fld id="{1B705F75-E3BA-4423-87D1-0E68AC9F841F}" type="slidenum">
               <a:rPr lang="zh-CN" altLang="en-US" smtClean="0"/>
               <a:t>‹#›</a:t>
             </a:fld>
@@ -3800,7 +3800,7 @@
     </p:spTree>
     <p:extLst>
       <p:ext uri="{BB962C8B-B14F-4D97-AF65-F5344CB8AC3E}">
-        <p14:creationId xmlns:p14="http://schemas.microsoft.com/office/powerpoint/2010/main" val="3693064327"/>
+        <p14:creationId xmlns:p14="http://schemas.microsoft.com/office/powerpoint/2010/main" val="3249072562"/>
       </p:ext>
     </p:extLst>
   </p:cSld>
@@ -3832,7 +3832,7 @@
           <p:cNvPr id="2" name="标题 1">
             <a:extLst>
               <a:ext uri="{FF2B5EF4-FFF2-40B4-BE49-F238E27FC236}">
-                <a16:creationId xmlns:a16="http://schemas.microsoft.com/office/drawing/2014/main" id="{3450C9BA-6644-AEB0-622F-C84A52FF18F3}"/>
+                <a16:creationId xmlns:a16="http://schemas.microsoft.com/office/drawing/2014/main" id="{86C9517F-A9B6-A8A3-8D9F-25417399B149}"/>
               </a:ext>
             </a:extLst>
           </p:cNvPr>
@@ -3860,7 +3860,7 @@
           <p:cNvPr id="3" name="内容占位符 2">
             <a:extLst>
               <a:ext uri="{FF2B5EF4-FFF2-40B4-BE49-F238E27FC236}">
-                <a16:creationId xmlns:a16="http://schemas.microsoft.com/office/drawing/2014/main" id="{4F5BF811-D9FA-24DF-1733-1C5B3A72F9C2}"/>
+                <a16:creationId xmlns:a16="http://schemas.microsoft.com/office/drawing/2014/main" id="{30379A71-AFA5-218A-B0A3-5CC269E98A87}"/>
               </a:ext>
             </a:extLst>
           </p:cNvPr>
@@ -3922,7 +3922,7 @@
           <p:cNvPr id="4" name="内容占位符 3">
             <a:extLst>
               <a:ext uri="{FF2B5EF4-FFF2-40B4-BE49-F238E27FC236}">
-                <a16:creationId xmlns:a16="http://schemas.microsoft.com/office/drawing/2014/main" id="{0C677C67-D1C2-3F4A-D213-5B8B1C5A0533}"/>
+                <a16:creationId xmlns:a16="http://schemas.microsoft.com/office/drawing/2014/main" id="{8F47BF43-CE85-1578-740E-9A09FFFE1C60}"/>
               </a:ext>
             </a:extLst>
           </p:cNvPr>
@@ -3984,7 +3984,7 @@
           <p:cNvPr id="5" name="日期占位符 4">
             <a:extLst>
               <a:ext uri="{FF2B5EF4-FFF2-40B4-BE49-F238E27FC236}">
-                <a16:creationId xmlns:a16="http://schemas.microsoft.com/office/drawing/2014/main" id="{49D88583-ADB0-5152-D43A-BFB2B274DF6A}"/>
+                <a16:creationId xmlns:a16="http://schemas.microsoft.com/office/drawing/2014/main" id="{92FBE537-B737-1B02-280E-7C3EA9FFEAAF}"/>
               </a:ext>
             </a:extLst>
           </p:cNvPr>
@@ -4000,9 +4000,9 @@
           <a:bodyPr/>
           <a:lstStyle/>
           <a:p>
-            <a:fld id="{BCA83E38-FE1A-46D7-AAB8-6C2A5536F75A}" type="datetimeFigureOut">
+            <a:fld id="{97357630-3157-4AFD-A157-330645C89275}" type="datetimeFigureOut">
               <a:rPr lang="zh-CN" altLang="en-US" smtClean="0"/>
-              <a:t>2026/6/11</a:t>
+              <a:t>2026/6/12</a:t>
             </a:fld>
             <a:endParaRPr lang="zh-CN" altLang="en-US"/>
           </a:p>
@@ -4013,7 +4013,7 @@
           <p:cNvPr id="6" name="页脚占位符 5">
             <a:extLst>
               <a:ext uri="{FF2B5EF4-FFF2-40B4-BE49-F238E27FC236}">
-                <a16:creationId xmlns:a16="http://schemas.microsoft.com/office/drawing/2014/main" id="{42169E9D-6C5D-8D26-136E-D90A3520FCC3}"/>
+                <a16:creationId xmlns:a16="http://schemas.microsoft.com/office/drawing/2014/main" id="{7DF26B7E-69E8-38A7-F348-40DD0D242297}"/>
               </a:ext>
             </a:extLst>
           </p:cNvPr>
@@ -4038,7 +4038,7 @@
           <p:cNvPr id="7" name="灯片编号占位符 6">
             <a:extLst>
               <a:ext uri="{FF2B5EF4-FFF2-40B4-BE49-F238E27FC236}">
-                <a16:creationId xmlns:a16="http://schemas.microsoft.com/office/drawing/2014/main" id="{D2C4FF7C-38BC-46C9-5859-9D3AE9CAB797}"/>
+                <a16:creationId xmlns:a16="http://schemas.microsoft.com/office/drawing/2014/main" id="{2A0C0C3E-773E-A60A-F121-80878912267D}"/>
               </a:ext>
             </a:extLst>
           </p:cNvPr>
@@ -4054,7 +4054,7 @@
           <a:bodyPr/>
           <a:lstStyle/>
           <a:p>
-            <a:fld id="{9DD4CD2A-584A-455B-ADD7-345520253A92}" type="slidenum">
+            <a:fld id="{1B705F75-E3BA-4423-87D1-0E68AC9F841F}" type="slidenum">
               <a:rPr lang="zh-CN" altLang="en-US" smtClean="0"/>
               <a:t>‹#›</a:t>
             </a:fld>
@@ -4065,7 +4065,7 @@
     </p:spTree>
     <p:extLst>
       <p:ext uri="{BB962C8B-B14F-4D97-AF65-F5344CB8AC3E}">
-        <p14:creationId xmlns:p14="http://schemas.microsoft.com/office/powerpoint/2010/main" val="4031751101"/>
+        <p14:creationId xmlns:p14="http://schemas.microsoft.com/office/powerpoint/2010/main" val="1479883425"/>
       </p:ext>
     </p:extLst>
   </p:cSld>
@@ -4097,7 +4097,7 @@
           <p:cNvPr id="2" name="标题 1">
             <a:extLst>
               <a:ext uri="{FF2B5EF4-FFF2-40B4-BE49-F238E27FC236}">
-                <a16:creationId xmlns:a16="http://schemas.microsoft.com/office/drawing/2014/main" id="{C006542E-6A76-CBFF-05C9-77863D195026}"/>
+                <a16:creationId xmlns:a16="http://schemas.microsoft.com/office/drawing/2014/main" id="{D8E7D8AA-3D1C-7F59-EF54-D92401D2A7D8}"/>
               </a:ext>
             </a:extLst>
           </p:cNvPr>
@@ -4130,7 +4130,7 @@
           <p:cNvPr id="3" name="文本占位符 2">
             <a:extLst>
               <a:ext uri="{FF2B5EF4-FFF2-40B4-BE49-F238E27FC236}">
-                <a16:creationId xmlns:a16="http://schemas.microsoft.com/office/drawing/2014/main" id="{9435F6B6-04C8-107A-C87B-74B3D7448A8F}"/>
+                <a16:creationId xmlns:a16="http://schemas.microsoft.com/office/drawing/2014/main" id="{4D9B632B-0283-3E9D-47A8-05A159922F91}"/>
               </a:ext>
             </a:extLst>
           </p:cNvPr>
@@ -4201,7 +4201,7 @@
           <p:cNvPr id="4" name="内容占位符 3">
             <a:extLst>
               <a:ext uri="{FF2B5EF4-FFF2-40B4-BE49-F238E27FC236}">
-                <a16:creationId xmlns:a16="http://schemas.microsoft.com/office/drawing/2014/main" id="{DCD014C7-A42D-4143-E048-98CB8A6EE82C}"/>
+                <a16:creationId xmlns:a16="http://schemas.microsoft.com/office/drawing/2014/main" id="{ABBBE7CC-47C0-2132-D0A5-16BB0CEFB7DF}"/>
               </a:ext>
             </a:extLst>
           </p:cNvPr>
@@ -4263,7 +4263,7 @@
           <p:cNvPr id="5" name="文本占位符 4">
             <a:extLst>
               <a:ext uri="{FF2B5EF4-FFF2-40B4-BE49-F238E27FC236}">
-                <a16:creationId xmlns:a16="http://schemas.microsoft.com/office/drawing/2014/main" id="{E76DA2DC-6C50-CB20-C074-7DCE260F33D7}"/>
+                <a16:creationId xmlns:a16="http://schemas.microsoft.com/office/drawing/2014/main" id="{D6E716BA-A253-0E00-2DC5-4B154B33085B}"/>
               </a:ext>
             </a:extLst>
           </p:cNvPr>
@@ -4334,7 +4334,7 @@
           <p:cNvPr id="6" name="内容占位符 5">
             <a:extLst>
               <a:ext uri="{FF2B5EF4-FFF2-40B4-BE49-F238E27FC236}">
-                <a16:creationId xmlns:a16="http://schemas.microsoft.com/office/drawing/2014/main" id="{F476644F-0A9A-7787-D3DE-9599FE9FD141}"/>
+                <a16:creationId xmlns:a16="http://schemas.microsoft.com/office/drawing/2014/main" id="{CB1373DB-7E93-A48C-076A-6F7214BCC3C1}"/>
               </a:ext>
             </a:extLst>
           </p:cNvPr>
@@ -4396,7 +4396,7 @@
           <p:cNvPr id="7" name="日期占位符 6">
             <a:extLst>
               <a:ext uri="{FF2B5EF4-FFF2-40B4-BE49-F238E27FC236}">
-                <a16:creationId xmlns:a16="http://schemas.microsoft.com/office/drawing/2014/main" id="{D6A2D558-BF2B-ECA2-4502-D726B27F08E8}"/>
+                <a16:creationId xmlns:a16="http://schemas.microsoft.com/office/drawing/2014/main" id="{3E6B7AC7-F053-7429-644B-02A8AED4EF7B}"/>
               </a:ext>
             </a:extLst>
           </p:cNvPr>
@@ -4412,9 +4412,9 @@
           <a:bodyPr/>
           <a:lstStyle/>
           <a:p>
-            <a:fld id="{BCA83E38-FE1A-46D7-AAB8-6C2A5536F75A}" type="datetimeFigureOut">
+            <a:fld id="{97357630-3157-4AFD-A157-330645C89275}" type="datetimeFigureOut">
               <a:rPr lang="zh-CN" altLang="en-US" smtClean="0"/>
-              <a:t>2026/6/11</a:t>
+              <a:t>2026/6/12</a:t>
             </a:fld>
             <a:endParaRPr lang="zh-CN" altLang="en-US"/>
           </a:p>
@@ -4425,7 +4425,7 @@
           <p:cNvPr id="8" name="页脚占位符 7">
             <a:extLst>
               <a:ext uri="{FF2B5EF4-FFF2-40B4-BE49-F238E27FC236}">
-                <a16:creationId xmlns:a16="http://schemas.microsoft.com/office/drawing/2014/main" id="{701F9E26-F996-56BC-EBCD-B6F5074DC39B}"/>
+                <a16:creationId xmlns:a16="http://schemas.microsoft.com/office/drawing/2014/main" id="{93F100B4-9412-C0E8-B417-958A14E9246F}"/>
               </a:ext>
             </a:extLst>
           </p:cNvPr>
@@ -4450,7 +4450,7 @@
           <p:cNvPr id="9" name="灯片编号占位符 8">
             <a:extLst>
               <a:ext uri="{FF2B5EF4-FFF2-40B4-BE49-F238E27FC236}">
-                <a16:creationId xmlns:a16="http://schemas.microsoft.com/office/drawing/2014/main" id="{AF38B9D5-7DF3-7806-44A4-E63FD880C50F}"/>
+                <a16:creationId xmlns:a16="http://schemas.microsoft.com/office/drawing/2014/main" id="{7A0C64A0-7E65-388F-7B05-FAE767ED79D8}"/>
               </a:ext>
             </a:extLst>
           </p:cNvPr>
@@ -4466,7 +4466,7 @@
           <a:bodyPr/>
           <a:lstStyle/>
           <a:p>
-            <a:fld id="{9DD4CD2A-584A-455B-ADD7-345520253A92}" type="slidenum">
+            <a:fld id="{1B705F75-E3BA-4423-87D1-0E68AC9F841F}" type="slidenum">
               <a:rPr lang="zh-CN" altLang="en-US" smtClean="0"/>
               <a:t>‹#›</a:t>
             </a:fld>
@@ -4477,7 +4477,7 @@
     </p:spTree>
     <p:extLst>
       <p:ext uri="{BB962C8B-B14F-4D97-AF65-F5344CB8AC3E}">
-        <p14:creationId xmlns:p14="http://schemas.microsoft.com/office/powerpoint/2010/main" val="1634958874"/>
+        <p14:creationId xmlns:p14="http://schemas.microsoft.com/office/powerpoint/2010/main" val="4133617503"/>
       </p:ext>
     </p:extLst>
   </p:cSld>
@@ -4509,7 +4509,7 @@
           <p:cNvPr id="2" name="标题 1">
             <a:extLst>
               <a:ext uri="{FF2B5EF4-FFF2-40B4-BE49-F238E27FC236}">
-                <a16:creationId xmlns:a16="http://schemas.microsoft.com/office/drawing/2014/main" id="{FA08E854-151C-AD04-90CF-92F539BF583E}"/>
+                <a16:creationId xmlns:a16="http://schemas.microsoft.com/office/drawing/2014/main" id="{3CEE394C-8E6A-A0CA-1501-C5B993BD33E2}"/>
               </a:ext>
             </a:extLst>
           </p:cNvPr>
@@ -4537,7 +4537,7 @@
           <p:cNvPr id="3" name="日期占位符 2">
             <a:extLst>
               <a:ext uri="{FF2B5EF4-FFF2-40B4-BE49-F238E27FC236}">
-                <a16:creationId xmlns:a16="http://schemas.microsoft.com/office/drawing/2014/main" id="{9AFF4CCE-CE64-A034-C166-44994D36A0F0}"/>
+                <a16:creationId xmlns:a16="http://schemas.microsoft.com/office/drawing/2014/main" id="{1C72A440-09A3-7FE0-5605-0D6F773201A6}"/>
               </a:ext>
             </a:extLst>
           </p:cNvPr>
@@ -4553,9 +4553,9 @@
           <a:bodyPr/>
           <a:lstStyle/>
           <a:p>
-            <a:fld id="{BCA83E38-FE1A-46D7-AAB8-6C2A5536F75A}" type="datetimeFigureOut">
+            <a:fld id="{97357630-3157-4AFD-A157-330645C89275}" type="datetimeFigureOut">
               <a:rPr lang="zh-CN" altLang="en-US" smtClean="0"/>
-              <a:t>2026/6/11</a:t>
+              <a:t>2026/6/12</a:t>
             </a:fld>
             <a:endParaRPr lang="zh-CN" altLang="en-US"/>
           </a:p>
@@ -4566,7 +4566,7 @@
           <p:cNvPr id="4" name="页脚占位符 3">
             <a:extLst>
               <a:ext uri="{FF2B5EF4-FFF2-40B4-BE49-F238E27FC236}">
-                <a16:creationId xmlns:a16="http://schemas.microsoft.com/office/drawing/2014/main" id="{AF610A60-D7D7-02DD-DF23-250859E9CA9C}"/>
+                <a16:creationId xmlns:a16="http://schemas.microsoft.com/office/drawing/2014/main" id="{00105F6C-5352-F297-62DE-37E0F5FAB86C}"/>
               </a:ext>
             </a:extLst>
           </p:cNvPr>
@@ -4591,7 +4591,7 @@
           <p:cNvPr id="5" name="灯片编号占位符 4">
             <a:extLst>
               <a:ext uri="{FF2B5EF4-FFF2-40B4-BE49-F238E27FC236}">
-                <a16:creationId xmlns:a16="http://schemas.microsoft.com/office/drawing/2014/main" id="{9090A6F3-640D-DEC5-71BE-63C2F58D8F28}"/>
+                <a16:creationId xmlns:a16="http://schemas.microsoft.com/office/drawing/2014/main" id="{79C8C70A-16C0-C6AA-9C6A-0F00F9D9902A}"/>
               </a:ext>
             </a:extLst>
           </p:cNvPr>
@@ -4607,7 +4607,7 @@
           <a:bodyPr/>
           <a:lstStyle/>
           <a:p>
-            <a:fld id="{9DD4CD2A-584A-455B-ADD7-345520253A92}" type="slidenum">
+            <a:fld id="{1B705F75-E3BA-4423-87D1-0E68AC9F841F}" type="slidenum">
               <a:rPr lang="zh-CN" altLang="en-US" smtClean="0"/>
               <a:t>‹#›</a:t>
             </a:fld>
@@ -4618,7 +4618,7 @@
     </p:spTree>
     <p:extLst>
       <p:ext uri="{BB962C8B-B14F-4D97-AF65-F5344CB8AC3E}">
-        <p14:creationId xmlns:p14="http://schemas.microsoft.com/office/powerpoint/2010/main" val="477275844"/>
+        <p14:creationId xmlns:p14="http://schemas.microsoft.com/office/powerpoint/2010/main" val="3162853739"/>
       </p:ext>
     </p:extLst>
   </p:cSld>
@@ -4650,7 +4650,7 @@
           <p:cNvPr id="2" name="日期占位符 1">
             <a:extLst>
               <a:ext uri="{FF2B5EF4-FFF2-40B4-BE49-F238E27FC236}">
-                <a16:creationId xmlns:a16="http://schemas.microsoft.com/office/drawing/2014/main" id="{CA459AA8-BB2F-5F1C-9A45-FBF62F832806}"/>
+                <a16:creationId xmlns:a16="http://schemas.microsoft.com/office/drawing/2014/main" id="{444B5CB2-4BC5-B69A-7591-193E36E0A27F}"/>
               </a:ext>
             </a:extLst>
           </p:cNvPr>
@@ -4666,9 +4666,9 @@
           <a:bodyPr/>
           <a:lstStyle/>
           <a:p>
-            <a:fld id="{BCA83E38-FE1A-46D7-AAB8-6C2A5536F75A}" type="datetimeFigureOut">
+            <a:fld id="{97357630-3157-4AFD-A157-330645C89275}" type="datetimeFigureOut">
               <a:rPr lang="zh-CN" altLang="en-US" smtClean="0"/>
-              <a:t>2026/6/11</a:t>
+              <a:t>2026/6/12</a:t>
             </a:fld>
             <a:endParaRPr lang="zh-CN" altLang="en-US"/>
           </a:p>
@@ -4679,7 +4679,7 @@
           <p:cNvPr id="3" name="页脚占位符 2">
             <a:extLst>
               <a:ext uri="{FF2B5EF4-FFF2-40B4-BE49-F238E27FC236}">
-                <a16:creationId xmlns:a16="http://schemas.microsoft.com/office/drawing/2014/main" id="{EE4B8CF9-356E-99C4-AB53-01A7D0ED3D73}"/>
+                <a16:creationId xmlns:a16="http://schemas.microsoft.com/office/drawing/2014/main" id="{1AC607AC-E253-B545-554D-506DB38A4503}"/>
               </a:ext>
             </a:extLst>
           </p:cNvPr>
@@ -4704,7 +4704,7 @@
           <p:cNvPr id="4" name="灯片编号占位符 3">
             <a:extLst>
               <a:ext uri="{FF2B5EF4-FFF2-40B4-BE49-F238E27FC236}">
-                <a16:creationId xmlns:a16="http://schemas.microsoft.com/office/drawing/2014/main" id="{0A2FA83E-3CBD-EB41-BC7F-663EAB688532}"/>
+                <a16:creationId xmlns:a16="http://schemas.microsoft.com/office/drawing/2014/main" id="{3778CB11-FC4E-1CC2-D908-A74F1537D045}"/>
               </a:ext>
             </a:extLst>
           </p:cNvPr>
@@ -4720,7 +4720,7 @@
           <a:bodyPr/>
           <a:lstStyle/>
           <a:p>
-            <a:fld id="{9DD4CD2A-584A-455B-ADD7-345520253A92}" type="slidenum">
+            <a:fld id="{1B705F75-E3BA-4423-87D1-0E68AC9F841F}" type="slidenum">
               <a:rPr lang="zh-CN" altLang="en-US" smtClean="0"/>
               <a:t>‹#›</a:t>
             </a:fld>
@@ -4731,7 +4731,7 @@
     </p:spTree>
     <p:extLst>
       <p:ext uri="{BB962C8B-B14F-4D97-AF65-F5344CB8AC3E}">
-        <p14:creationId xmlns:p14="http://schemas.microsoft.com/office/powerpoint/2010/main" val="3082109602"/>
+        <p14:creationId xmlns:p14="http://schemas.microsoft.com/office/powerpoint/2010/main" val="3573771627"/>
       </p:ext>
     </p:extLst>
   </p:cSld>
@@ -4763,7 +4763,7 @@
           <p:cNvPr id="2" name="标题 1">
             <a:extLst>
               <a:ext uri="{FF2B5EF4-FFF2-40B4-BE49-F238E27FC236}">
-                <a16:creationId xmlns:a16="http://schemas.microsoft.com/office/drawing/2014/main" id="{03C7CFAF-28E9-6E60-1AB4-A2213DBF029F}"/>
+                <a16:creationId xmlns:a16="http://schemas.microsoft.com/office/drawing/2014/main" id="{9BF864F2-AA0B-06E5-C1CE-D9025F3583F4}"/>
               </a:ext>
             </a:extLst>
           </p:cNvPr>
@@ -4800,7 +4800,7 @@
           <p:cNvPr id="3" name="内容占位符 2">
             <a:extLst>
               <a:ext uri="{FF2B5EF4-FFF2-40B4-BE49-F238E27FC236}">
-                <a16:creationId xmlns:a16="http://schemas.microsoft.com/office/drawing/2014/main" id="{C92D878A-FC8D-146C-4707-1F2DDA37708C}"/>
+                <a16:creationId xmlns:a16="http://schemas.microsoft.com/office/drawing/2014/main" id="{BA88DE06-68CA-73DD-94EB-1169E3ED97B2}"/>
               </a:ext>
             </a:extLst>
           </p:cNvPr>
@@ -4890,7 +4890,7 @@
           <p:cNvPr id="4" name="文本占位符 3">
             <a:extLst>
               <a:ext uri="{FF2B5EF4-FFF2-40B4-BE49-F238E27FC236}">
-                <a16:creationId xmlns:a16="http://schemas.microsoft.com/office/drawing/2014/main" id="{BFEE00CB-4A69-2462-12C0-B688E211990A}"/>
+                <a16:creationId xmlns:a16="http://schemas.microsoft.com/office/drawing/2014/main" id="{F61C5023-5C34-6AD9-79CB-DA95CB93885F}"/>
               </a:ext>
             </a:extLst>
           </p:cNvPr>
@@ -4961,7 +4961,7 @@
           <p:cNvPr id="5" name="日期占位符 4">
             <a:extLst>
               <a:ext uri="{FF2B5EF4-FFF2-40B4-BE49-F238E27FC236}">
-                <a16:creationId xmlns:a16="http://schemas.microsoft.com/office/drawing/2014/main" id="{CB872B19-E67E-ED38-7629-A2ED99C67D30}"/>
+                <a16:creationId xmlns:a16="http://schemas.microsoft.com/office/drawing/2014/main" id="{4BCDAAF3-8129-F6A5-0072-B72DF3487FD8}"/>
               </a:ext>
             </a:extLst>
           </p:cNvPr>
@@ -4977,9 +4977,9 @@
           <a:bodyPr/>
           <a:lstStyle/>
           <a:p>
-            <a:fld id="{BCA83E38-FE1A-46D7-AAB8-6C2A5536F75A}" type="datetimeFigureOut">
+            <a:fld id="{97357630-3157-4AFD-A157-330645C89275}" type="datetimeFigureOut">
               <a:rPr lang="zh-CN" altLang="en-US" smtClean="0"/>
-              <a:t>2026/6/11</a:t>
+              <a:t>2026/6/12</a:t>
             </a:fld>
             <a:endParaRPr lang="zh-CN" altLang="en-US"/>
           </a:p>
@@ -4990,7 +4990,7 @@
           <p:cNvPr id="6" name="页脚占位符 5">
             <a:extLst>
               <a:ext uri="{FF2B5EF4-FFF2-40B4-BE49-F238E27FC236}">
-                <a16:creationId xmlns:a16="http://schemas.microsoft.com/office/drawing/2014/main" id="{0CD388CC-0DE7-EDC7-DF77-A789B131E125}"/>
+                <a16:creationId xmlns:a16="http://schemas.microsoft.com/office/drawing/2014/main" id="{C012BCC4-C0D3-4780-BCA5-6CD766A22C61}"/>
               </a:ext>
             </a:extLst>
           </p:cNvPr>
@@ -5015,7 +5015,7 @@
           <p:cNvPr id="7" name="灯片编号占位符 6">
             <a:extLst>
               <a:ext uri="{FF2B5EF4-FFF2-40B4-BE49-F238E27FC236}">
-                <a16:creationId xmlns:a16="http://schemas.microsoft.com/office/drawing/2014/main" id="{A665F3A8-1810-6DC9-980C-71CF8C761E7F}"/>
+                <a16:creationId xmlns:a16="http://schemas.microsoft.com/office/drawing/2014/main" id="{70FF3E7F-0200-42CF-CD4C-FD9AA608E8C7}"/>
               </a:ext>
             </a:extLst>
           </p:cNvPr>
@@ -5031,7 +5031,7 @@
           <a:bodyPr/>
           <a:lstStyle/>
           <a:p>
-            <a:fld id="{9DD4CD2A-584A-455B-ADD7-345520253A92}" type="slidenum">
+            <a:fld id="{1B705F75-E3BA-4423-87D1-0E68AC9F841F}" type="slidenum">
               <a:rPr lang="zh-CN" altLang="en-US" smtClean="0"/>
               <a:t>‹#›</a:t>
             </a:fld>
@@ -5042,7 +5042,7 @@
     </p:spTree>
     <p:extLst>
       <p:ext uri="{BB962C8B-B14F-4D97-AF65-F5344CB8AC3E}">
-        <p14:creationId xmlns:p14="http://schemas.microsoft.com/office/powerpoint/2010/main" val="4250577993"/>
+        <p14:creationId xmlns:p14="http://schemas.microsoft.com/office/powerpoint/2010/main" val="1000242193"/>
       </p:ext>
     </p:extLst>
   </p:cSld>
@@ -5074,7 +5074,7 @@
           <p:cNvPr id="2" name="标题 1">
             <a:extLst>
               <a:ext uri="{FF2B5EF4-FFF2-40B4-BE49-F238E27FC236}">
-                <a16:creationId xmlns:a16="http://schemas.microsoft.com/office/drawing/2014/main" id="{C7F6CD7A-EC2E-BC85-1B5C-B9DB3DA52BFB}"/>
+                <a16:creationId xmlns:a16="http://schemas.microsoft.com/office/drawing/2014/main" id="{1DFF8282-60F3-1FEE-D2FC-A1415CBACC6C}"/>
               </a:ext>
             </a:extLst>
           </p:cNvPr>
@@ -5111,7 +5111,7 @@
           <p:cNvPr id="3" name="图片占位符 2">
             <a:extLst>
               <a:ext uri="{FF2B5EF4-FFF2-40B4-BE49-F238E27FC236}">
-                <a16:creationId xmlns:a16="http://schemas.microsoft.com/office/drawing/2014/main" id="{47889227-E830-E0D2-829A-6243A73CDE1A}"/>
+                <a16:creationId xmlns:a16="http://schemas.microsoft.com/office/drawing/2014/main" id="{C4FDECB7-7FDD-3CA5-A02E-3BD431DC7A0F}"/>
               </a:ext>
             </a:extLst>
           </p:cNvPr>
@@ -5178,7 +5178,7 @@
           <p:cNvPr id="4" name="文本占位符 3">
             <a:extLst>
               <a:ext uri="{FF2B5EF4-FFF2-40B4-BE49-F238E27FC236}">
-                <a16:creationId xmlns:a16="http://schemas.microsoft.com/office/drawing/2014/main" id="{AFC8818B-A402-D326-0073-12A5577EA954}"/>
+                <a16:creationId xmlns:a16="http://schemas.microsoft.com/office/drawing/2014/main" id="{77093F96-3A01-4117-4046-01AB6DC9E051}"/>
               </a:ext>
             </a:extLst>
           </p:cNvPr>
@@ -5249,7 +5249,7 @@
           <p:cNvPr id="5" name="日期占位符 4">
             <a:extLst>
               <a:ext uri="{FF2B5EF4-FFF2-40B4-BE49-F238E27FC236}">
-                <a16:creationId xmlns:a16="http://schemas.microsoft.com/office/drawing/2014/main" id="{8728CEB8-6243-DA8A-9299-014443CBE3DD}"/>
+                <a16:creationId xmlns:a16="http://schemas.microsoft.com/office/drawing/2014/main" id="{DF5C6EE3-0E29-EB33-0B94-F5CA75D6B517}"/>
               </a:ext>
             </a:extLst>
           </p:cNvPr>
@@ -5265,9 +5265,9 @@
           <a:bodyPr/>
           <a:lstStyle/>
           <a:p>
-            <a:fld id="{BCA83E38-FE1A-46D7-AAB8-6C2A5536F75A}" type="datetimeFigureOut">
+            <a:fld id="{97357630-3157-4AFD-A157-330645C89275}" type="datetimeFigureOut">
               <a:rPr lang="zh-CN" altLang="en-US" smtClean="0"/>
-              <a:t>2026/6/11</a:t>
+              <a:t>2026/6/12</a:t>
             </a:fld>
             <a:endParaRPr lang="zh-CN" altLang="en-US"/>
           </a:p>
@@ -5278,7 +5278,7 @@
           <p:cNvPr id="6" name="页脚占位符 5">
             <a:extLst>
               <a:ext uri="{FF2B5EF4-FFF2-40B4-BE49-F238E27FC236}">
-                <a16:creationId xmlns:a16="http://schemas.microsoft.com/office/drawing/2014/main" id="{4FF5B9E7-0C32-DFB1-C9B7-0AD3F87EA543}"/>
+                <a16:creationId xmlns:a16="http://schemas.microsoft.com/office/drawing/2014/main" id="{C0DE5F07-8921-C5F4-20D3-A47A35AE678D}"/>
               </a:ext>
             </a:extLst>
           </p:cNvPr>
@@ -5303,7 +5303,7 @@
           <p:cNvPr id="7" name="灯片编号占位符 6">
             <a:extLst>
               <a:ext uri="{FF2B5EF4-FFF2-40B4-BE49-F238E27FC236}">
-                <a16:creationId xmlns:a16="http://schemas.microsoft.com/office/drawing/2014/main" id="{51C39A36-EAFF-259A-A15F-0FD643587162}"/>
+                <a16:creationId xmlns:a16="http://schemas.microsoft.com/office/drawing/2014/main" id="{FE408B36-1BA4-B572-D710-1E0BCCC6873E}"/>
               </a:ext>
             </a:extLst>
           </p:cNvPr>
@@ -5319,7 +5319,7 @@
           <a:bodyPr/>
           <a:lstStyle/>
           <a:p>
-            <a:fld id="{9DD4CD2A-584A-455B-ADD7-345520253A92}" type="slidenum">
+            <a:fld id="{1B705F75-E3BA-4423-87D1-0E68AC9F841F}" type="slidenum">
               <a:rPr lang="zh-CN" altLang="en-US" smtClean="0"/>
               <a:t>‹#›</a:t>
             </a:fld>
@@ -5330,7 +5330,7 @@
     </p:spTree>
     <p:extLst>
       <p:ext uri="{BB962C8B-B14F-4D97-AF65-F5344CB8AC3E}">
-        <p14:creationId xmlns:p14="http://schemas.microsoft.com/office/powerpoint/2010/main" val="1042633100"/>
+        <p14:creationId xmlns:p14="http://schemas.microsoft.com/office/powerpoint/2010/main" val="1623298195"/>
       </p:ext>
     </p:extLst>
   </p:cSld>
@@ -5367,7 +5367,7 @@
           <p:cNvPr id="2" name="标题占位符 1">
             <a:extLst>
               <a:ext uri="{FF2B5EF4-FFF2-40B4-BE49-F238E27FC236}">
-                <a16:creationId xmlns:a16="http://schemas.microsoft.com/office/drawing/2014/main" id="{935AA5F3-D0BC-CD24-5DB5-D99DE2F2DD26}"/>
+                <a16:creationId xmlns:a16="http://schemas.microsoft.com/office/drawing/2014/main" id="{68C8C500-69E2-986A-AFD1-5DBF72CB8747}"/>
               </a:ext>
             </a:extLst>
           </p:cNvPr>
@@ -5405,7 +5405,7 @@
           <p:cNvPr id="3" name="文本占位符 2">
             <a:extLst>
               <a:ext uri="{FF2B5EF4-FFF2-40B4-BE49-F238E27FC236}">
-                <a16:creationId xmlns:a16="http://schemas.microsoft.com/office/drawing/2014/main" id="{65CA3D6C-A6CD-DB61-CE47-21D249C8BA2C}"/>
+                <a16:creationId xmlns:a16="http://schemas.microsoft.com/office/drawing/2014/main" id="{C3825D9E-485C-57C0-7A91-2452E12B1E68}"/>
               </a:ext>
             </a:extLst>
           </p:cNvPr>
@@ -5472,7 +5472,7 @@
           <p:cNvPr id="4" name="日期占位符 3">
             <a:extLst>
               <a:ext uri="{FF2B5EF4-FFF2-40B4-BE49-F238E27FC236}">
-                <a16:creationId xmlns:a16="http://schemas.microsoft.com/office/drawing/2014/main" id="{80F21F56-26AD-5596-75DA-459697BDA448}"/>
+                <a16:creationId xmlns:a16="http://schemas.microsoft.com/office/drawing/2014/main" id="{50F6672E-44FC-69BE-FC56-DFE1E87C76CB}"/>
               </a:ext>
             </a:extLst>
           </p:cNvPr>
@@ -5506,9 +5506,9 @@
             </a:lvl1pPr>
           </a:lstStyle>
           <a:p>
-            <a:fld id="{BCA83E38-FE1A-46D7-AAB8-6C2A5536F75A}" type="datetimeFigureOut">
+            <a:fld id="{97357630-3157-4AFD-A157-330645C89275}" type="datetimeFigureOut">
               <a:rPr lang="zh-CN" altLang="en-US" smtClean="0"/>
-              <a:t>2026/6/11</a:t>
+              <a:t>2026/6/12</a:t>
             </a:fld>
             <a:endParaRPr lang="zh-CN" altLang="en-US"/>
           </a:p>
@@ -5519,7 +5519,7 @@
           <p:cNvPr id="5" name="页脚占位符 4">
             <a:extLst>
               <a:ext uri="{FF2B5EF4-FFF2-40B4-BE49-F238E27FC236}">
-                <a16:creationId xmlns:a16="http://schemas.microsoft.com/office/drawing/2014/main" id="{BE4CCA01-DA2B-159F-1509-6DCABB35975D}"/>
+                <a16:creationId xmlns:a16="http://schemas.microsoft.com/office/drawing/2014/main" id="{73AAD3A6-3BD0-CF1D-19CB-C0E8A32CDD1A}"/>
               </a:ext>
             </a:extLst>
           </p:cNvPr>
@@ -5562,7 +5562,7 @@
           <p:cNvPr id="6" name="灯片编号占位符 5">
             <a:extLst>
               <a:ext uri="{FF2B5EF4-FFF2-40B4-BE49-F238E27FC236}">
-                <a16:creationId xmlns:a16="http://schemas.microsoft.com/office/drawing/2014/main" id="{34D67B11-8D72-E64C-A9E9-D9B57050E750}"/>
+                <a16:creationId xmlns:a16="http://schemas.microsoft.com/office/drawing/2014/main" id="{FC0926E5-FE53-162A-36A7-3B8C5E4D87FC}"/>
               </a:ext>
             </a:extLst>
           </p:cNvPr>
@@ -5596,7 +5596,7 @@
             </a:lvl1pPr>
           </a:lstStyle>
           <a:p>
-            <a:fld id="{9DD4CD2A-584A-455B-ADD7-345520253A92}" type="slidenum">
+            <a:fld id="{1B705F75-E3BA-4423-87D1-0E68AC9F841F}" type="slidenum">
               <a:rPr lang="zh-CN" altLang="en-US" smtClean="0"/>
               <a:t>‹#›</a:t>
             </a:fld>
@@ -5607,7 +5607,7 @@
     </p:spTree>
     <p:extLst>
       <p:ext uri="{BB962C8B-B14F-4D97-AF65-F5344CB8AC3E}">
-        <p14:creationId xmlns:p14="http://schemas.microsoft.com/office/powerpoint/2010/main" val="3145690014"/>
+        <p14:creationId xmlns:p14="http://schemas.microsoft.com/office/powerpoint/2010/main" val="3655053208"/>
       </p:ext>
     </p:extLst>
   </p:cSld>
@@ -5930,7 +5930,7 @@
           <p:cNvPr id="2" name="矩形 1">
             <a:extLst>
               <a:ext uri="{FF2B5EF4-FFF2-40B4-BE49-F238E27FC236}">
-                <a16:creationId xmlns:a16="http://schemas.microsoft.com/office/drawing/2014/main" id="{158E8219-6304-CF78-58DD-6B7CD3BC53B2}"/>
+                <a16:creationId xmlns:a16="http://schemas.microsoft.com/office/drawing/2014/main" id="{73F87133-4564-AAC8-393F-31B09E4234E3}"/>
               </a:ext>
             </a:extLst>
           </p:cNvPr>
@@ -5984,7 +5984,7 @@
           <p:cNvPr id="3" name="矩形 2">
             <a:extLst>
               <a:ext uri="{FF2B5EF4-FFF2-40B4-BE49-F238E27FC236}">
-                <a16:creationId xmlns:a16="http://schemas.microsoft.com/office/drawing/2014/main" id="{521D9577-9063-C423-5063-7C765C488049}"/>
+                <a16:creationId xmlns:a16="http://schemas.microsoft.com/office/drawing/2014/main" id="{ADCB6005-0B0F-E016-71F6-DFB41700FCC1}"/>
               </a:ext>
             </a:extLst>
           </p:cNvPr>
@@ -6038,7 +6038,7 @@
           <p:cNvPr id="4" name="矩形 3">
             <a:extLst>
               <a:ext uri="{FF2B5EF4-FFF2-40B4-BE49-F238E27FC236}">
-                <a16:creationId xmlns:a16="http://schemas.microsoft.com/office/drawing/2014/main" id="{7E976E6D-CCE6-7611-D9FB-0D8684F49E5E}"/>
+                <a16:creationId xmlns:a16="http://schemas.microsoft.com/office/drawing/2014/main" id="{DEA8FD87-854E-ED3C-F408-BF2BA717E235}"/>
               </a:ext>
             </a:extLst>
           </p:cNvPr>
@@ -6092,7 +6092,7 @@
           <p:cNvPr id="5" name="文本框 4">
             <a:extLst>
               <a:ext uri="{FF2B5EF4-FFF2-40B4-BE49-F238E27FC236}">
-                <a16:creationId xmlns:a16="http://schemas.microsoft.com/office/drawing/2014/main" id="{2CFCDF9B-D0E0-EA40-226C-EA434F98F3B7}"/>
+                <a16:creationId xmlns:a16="http://schemas.microsoft.com/office/drawing/2014/main" id="{83B37D57-8C13-9348-B2AE-FBF3E55F2CFD}"/>
               </a:ext>
             </a:extLst>
           </p:cNvPr>
@@ -6138,7 +6138,7 @@
           <p:cNvPr id="6" name="文本框 5">
             <a:extLst>
               <a:ext uri="{FF2B5EF4-FFF2-40B4-BE49-F238E27FC236}">
-                <a16:creationId xmlns:a16="http://schemas.microsoft.com/office/drawing/2014/main" id="{93A6CA71-D07B-6DD3-7418-81C41EA19C03}"/>
+                <a16:creationId xmlns:a16="http://schemas.microsoft.com/office/drawing/2014/main" id="{289D4CAE-B483-0615-C79F-D3F8C2747117}"/>
               </a:ext>
             </a:extLst>
           </p:cNvPr>
@@ -6214,7 +6214,7 @@
           <p:cNvPr id="7" name="矩形 6">
             <a:extLst>
               <a:ext uri="{FF2B5EF4-FFF2-40B4-BE49-F238E27FC236}">
-                <a16:creationId xmlns:a16="http://schemas.microsoft.com/office/drawing/2014/main" id="{AC3AC1CD-2195-9B06-02B4-621D8E3D9070}"/>
+                <a16:creationId xmlns:a16="http://schemas.microsoft.com/office/drawing/2014/main" id="{A57931DE-53A1-59C7-3EFE-8904D5881663}"/>
               </a:ext>
             </a:extLst>
           </p:cNvPr>
@@ -6268,7 +6268,7 @@
           <p:cNvPr id="8" name="矩形: 圆角 7">
             <a:extLst>
               <a:ext uri="{FF2B5EF4-FFF2-40B4-BE49-F238E27FC236}">
-                <a16:creationId xmlns:a16="http://schemas.microsoft.com/office/drawing/2014/main" id="{213AE171-B740-8E9F-420A-071DF19C56E2}"/>
+                <a16:creationId xmlns:a16="http://schemas.microsoft.com/office/drawing/2014/main" id="{6C1F8D94-9008-1FC7-192C-6BDC6AD6B56C}"/>
               </a:ext>
             </a:extLst>
           </p:cNvPr>
@@ -6330,7 +6330,7 @@
           <p:cNvPr id="9" name="矩形: 圆角 8">
             <a:extLst>
               <a:ext uri="{FF2B5EF4-FFF2-40B4-BE49-F238E27FC236}">
-                <a16:creationId xmlns:a16="http://schemas.microsoft.com/office/drawing/2014/main" id="{257D383F-6523-E347-8464-76C582B9048A}"/>
+                <a16:creationId xmlns:a16="http://schemas.microsoft.com/office/drawing/2014/main" id="{CD859A34-F16B-C463-2BBD-AC080B37CD62}"/>
               </a:ext>
             </a:extLst>
           </p:cNvPr>
@@ -6392,7 +6392,7 @@
           <p:cNvPr id="10" name="矩形: 圆角 9">
             <a:extLst>
               <a:ext uri="{FF2B5EF4-FFF2-40B4-BE49-F238E27FC236}">
-                <a16:creationId xmlns:a16="http://schemas.microsoft.com/office/drawing/2014/main" id="{7DAC582D-B367-E738-3C28-B6A4F6A16A2C}"/>
+                <a16:creationId xmlns:a16="http://schemas.microsoft.com/office/drawing/2014/main" id="{667A1E5B-A161-D180-22A1-3B5789D04F65}"/>
               </a:ext>
             </a:extLst>
           </p:cNvPr>
@@ -6454,7 +6454,7 @@
           <p:cNvPr id="11" name="矩形: 圆角 10">
             <a:extLst>
               <a:ext uri="{FF2B5EF4-FFF2-40B4-BE49-F238E27FC236}">
-                <a16:creationId xmlns:a16="http://schemas.microsoft.com/office/drawing/2014/main" id="{DDD0C16A-EEA0-F77E-1E4E-524FC5C20731}"/>
+                <a16:creationId xmlns:a16="http://schemas.microsoft.com/office/drawing/2014/main" id="{FC478783-3E80-D5AB-E59B-11036D0E65AA}"/>
               </a:ext>
             </a:extLst>
           </p:cNvPr>
@@ -6522,7 +6522,7 @@
           <p:cNvPr id="12" name="矩形: 圆角 11">
             <a:extLst>
               <a:ext uri="{FF2B5EF4-FFF2-40B4-BE49-F238E27FC236}">
-                <a16:creationId xmlns:a16="http://schemas.microsoft.com/office/drawing/2014/main" id="{DAB55F58-9AB0-48F9-8FB4-7D59B37BBB6F}"/>
+                <a16:creationId xmlns:a16="http://schemas.microsoft.com/office/drawing/2014/main" id="{052DCBE2-36ED-D84A-E71E-14A8DA32A730}"/>
               </a:ext>
             </a:extLst>
           </p:cNvPr>
@@ -6590,7 +6590,7 @@
           <p:cNvPr id="13" name="矩形: 圆角 12">
             <a:extLst>
               <a:ext uri="{FF2B5EF4-FFF2-40B4-BE49-F238E27FC236}">
-                <a16:creationId xmlns:a16="http://schemas.microsoft.com/office/drawing/2014/main" id="{C9B4DBD0-E628-9470-7FE9-13C3CD496B67}"/>
+                <a16:creationId xmlns:a16="http://schemas.microsoft.com/office/drawing/2014/main" id="{581EC485-D496-8A24-68BA-154AB5B89C40}"/>
               </a:ext>
             </a:extLst>
           </p:cNvPr>
@@ -6652,7 +6652,7 @@
           <p:cNvPr id="14" name="文本框 13">
             <a:extLst>
               <a:ext uri="{FF2B5EF4-FFF2-40B4-BE49-F238E27FC236}">
-                <a16:creationId xmlns:a16="http://schemas.microsoft.com/office/drawing/2014/main" id="{26A3D307-20AA-74A7-3F27-8AD88001EC93}"/>
+                <a16:creationId xmlns:a16="http://schemas.microsoft.com/office/drawing/2014/main" id="{4E283B7A-18B9-CAC6-023E-6EA6E3A436FF}"/>
               </a:ext>
             </a:extLst>
           </p:cNvPr>
@@ -6725,7 +6725,7 @@
           <p:cNvPr id="15" name="文本框 14">
             <a:extLst>
               <a:ext uri="{FF2B5EF4-FFF2-40B4-BE49-F238E27FC236}">
-                <a16:creationId xmlns:a16="http://schemas.microsoft.com/office/drawing/2014/main" id="{3B105C53-8882-4E21-E38E-7BE1F5811DF1}"/>
+                <a16:creationId xmlns:a16="http://schemas.microsoft.com/office/drawing/2014/main" id="{5D1CD345-4320-F6AF-77AF-792F831ED7A1}"/>
               </a:ext>
             </a:extLst>
           </p:cNvPr>
@@ -6763,7 +6763,7 @@
     </p:spTree>
     <p:extLst>
       <p:ext uri="{BB962C8B-B14F-4D97-AF65-F5344CB8AC3E}">
-        <p14:creationId xmlns:p14="http://schemas.microsoft.com/office/powerpoint/2010/main" val="2031822557"/>
+        <p14:creationId xmlns:p14="http://schemas.microsoft.com/office/powerpoint/2010/main" val="3990901216"/>
       </p:ext>
     </p:extLst>
   </p:cSld>
@@ -6795,7 +6795,7 @@
           <p:cNvPr id="2" name="矩形 1">
             <a:extLst>
               <a:ext uri="{FF2B5EF4-FFF2-40B4-BE49-F238E27FC236}">
-                <a16:creationId xmlns:a16="http://schemas.microsoft.com/office/drawing/2014/main" id="{9CA33609-6A5E-02BC-49C7-7C926AD95959}"/>
+                <a16:creationId xmlns:a16="http://schemas.microsoft.com/office/drawing/2014/main" id="{8D12E852-83FA-BAF0-3CAB-9015DA6FBC49}"/>
               </a:ext>
             </a:extLst>
           </p:cNvPr>
@@ -6849,7 +6849,7 @@
           <p:cNvPr id="3" name="矩形 2">
             <a:extLst>
               <a:ext uri="{FF2B5EF4-FFF2-40B4-BE49-F238E27FC236}">
-                <a16:creationId xmlns:a16="http://schemas.microsoft.com/office/drawing/2014/main" id="{34AC2457-DB77-F837-77EC-42E7D3D3CA1D}"/>
+                <a16:creationId xmlns:a16="http://schemas.microsoft.com/office/drawing/2014/main" id="{D2F63105-FA9C-7745-D230-810F1FD6AF9E}"/>
               </a:ext>
             </a:extLst>
           </p:cNvPr>
@@ -6903,7 +6903,7 @@
           <p:cNvPr id="4" name="矩形 3">
             <a:extLst>
               <a:ext uri="{FF2B5EF4-FFF2-40B4-BE49-F238E27FC236}">
-                <a16:creationId xmlns:a16="http://schemas.microsoft.com/office/drawing/2014/main" id="{EB9040B7-C64C-F2F0-7DC3-AFB8B6A3DEAF}"/>
+                <a16:creationId xmlns:a16="http://schemas.microsoft.com/office/drawing/2014/main" id="{4106762F-A602-BF0C-2669-F514CF5E3785}"/>
               </a:ext>
             </a:extLst>
           </p:cNvPr>
@@ -6957,7 +6957,7 @@
           <p:cNvPr id="5" name="文本框 4">
             <a:extLst>
               <a:ext uri="{FF2B5EF4-FFF2-40B4-BE49-F238E27FC236}">
-                <a16:creationId xmlns:a16="http://schemas.microsoft.com/office/drawing/2014/main" id="{5E641022-7B63-F707-34FA-901F248E779A}"/>
+                <a16:creationId xmlns:a16="http://schemas.microsoft.com/office/drawing/2014/main" id="{AF45E304-B36E-EA34-FDFD-BE49FA5D0D8A}"/>
               </a:ext>
             </a:extLst>
           </p:cNvPr>
@@ -7006,7 +7006,7 @@
           <p:cNvPr id="6" name="文本框 5">
             <a:extLst>
               <a:ext uri="{FF2B5EF4-FFF2-40B4-BE49-F238E27FC236}">
-                <a16:creationId xmlns:a16="http://schemas.microsoft.com/office/drawing/2014/main" id="{18ECBCC5-2225-8D1F-7B52-B945A7F916E8}"/>
+                <a16:creationId xmlns:a16="http://schemas.microsoft.com/office/drawing/2014/main" id="{EE395C90-942B-6346-B433-802CBB278AB1}"/>
               </a:ext>
             </a:extLst>
           </p:cNvPr>
@@ -7053,7 +7053,7 @@
           <p:cNvPr id="7" name="文本框 6">
             <a:extLst>
               <a:ext uri="{FF2B5EF4-FFF2-40B4-BE49-F238E27FC236}">
-                <a16:creationId xmlns:a16="http://schemas.microsoft.com/office/drawing/2014/main" id="{09469399-8B7E-41A1-2699-0538D9C1C5A7}"/>
+                <a16:creationId xmlns:a16="http://schemas.microsoft.com/office/drawing/2014/main" id="{517B32E6-BBF1-53E2-00F1-88134802CBBE}"/>
               </a:ext>
             </a:extLst>
           </p:cNvPr>
@@ -7120,7 +7120,7 @@
           <p:cNvPr id="8" name="矩形: 圆角 7">
             <a:extLst>
               <a:ext uri="{FF2B5EF4-FFF2-40B4-BE49-F238E27FC236}">
-                <a16:creationId xmlns:a16="http://schemas.microsoft.com/office/drawing/2014/main" id="{9DED6EF3-108E-553F-975B-2E3788360433}"/>
+                <a16:creationId xmlns:a16="http://schemas.microsoft.com/office/drawing/2014/main" id="{883F11F9-A905-4254-8BE5-4623D8258AAF}"/>
               </a:ext>
             </a:extLst>
           </p:cNvPr>
@@ -7182,7 +7182,7 @@
           <p:cNvPr id="9" name="矩形: 圆角 8">
             <a:extLst>
               <a:ext uri="{FF2B5EF4-FFF2-40B4-BE49-F238E27FC236}">
-                <a16:creationId xmlns:a16="http://schemas.microsoft.com/office/drawing/2014/main" id="{461FE7F4-C884-4CA8-F4DC-A45F1736BA96}"/>
+                <a16:creationId xmlns:a16="http://schemas.microsoft.com/office/drawing/2014/main" id="{F56E4925-B696-4934-D6A2-57D4D138752C}"/>
               </a:ext>
             </a:extLst>
           </p:cNvPr>
@@ -7259,7 +7259,7 @@
           <p:cNvPr id="10" name="矩形: 圆角 9">
             <a:extLst>
               <a:ext uri="{FF2B5EF4-FFF2-40B4-BE49-F238E27FC236}">
-                <a16:creationId xmlns:a16="http://schemas.microsoft.com/office/drawing/2014/main" id="{ACD8DD0E-F1C0-FDD8-3587-20DB9D3C3043}"/>
+                <a16:creationId xmlns:a16="http://schemas.microsoft.com/office/drawing/2014/main" id="{F26E7AE8-A1A6-EA7D-E47A-7B1C658D9DA1}"/>
               </a:ext>
             </a:extLst>
           </p:cNvPr>
@@ -7327,7 +7327,7 @@
           <p:cNvPr id="11" name="矩形: 圆角 10">
             <a:extLst>
               <a:ext uri="{FF2B5EF4-FFF2-40B4-BE49-F238E27FC236}">
-                <a16:creationId xmlns:a16="http://schemas.microsoft.com/office/drawing/2014/main" id="{2B959DFC-B1C7-C180-C9DF-D166B25DBC2B}"/>
+                <a16:creationId xmlns:a16="http://schemas.microsoft.com/office/drawing/2014/main" id="{9BC86D8A-7C32-F62D-5082-5D74EAAC8A9B}"/>
               </a:ext>
             </a:extLst>
           </p:cNvPr>
@@ -7395,7 +7395,7 @@
           <p:cNvPr id="12" name="矩形: 圆角 11">
             <a:extLst>
               <a:ext uri="{FF2B5EF4-FFF2-40B4-BE49-F238E27FC236}">
-                <a16:creationId xmlns:a16="http://schemas.microsoft.com/office/drawing/2014/main" id="{85959C21-6C78-2C52-1376-28B6D72E2A5D}"/>
+                <a16:creationId xmlns:a16="http://schemas.microsoft.com/office/drawing/2014/main" id="{14F5E565-E1E7-C92E-E604-DDB308DADBDC}"/>
               </a:ext>
             </a:extLst>
           </p:cNvPr>
@@ -7457,7 +7457,7 @@
           <p:cNvPr id="13" name="矩形: 圆角 12">
             <a:extLst>
               <a:ext uri="{FF2B5EF4-FFF2-40B4-BE49-F238E27FC236}">
-                <a16:creationId xmlns:a16="http://schemas.microsoft.com/office/drawing/2014/main" id="{C26ADCD8-6D2E-ADDF-03BD-DABC7700370D}"/>
+                <a16:creationId xmlns:a16="http://schemas.microsoft.com/office/drawing/2014/main" id="{D4432B60-9120-B31B-4D53-161B8A87AB9B}"/>
               </a:ext>
             </a:extLst>
           </p:cNvPr>
@@ -7519,7 +7519,7 @@
           <p:cNvPr id="14" name="矩形: 圆角 13">
             <a:extLst>
               <a:ext uri="{FF2B5EF4-FFF2-40B4-BE49-F238E27FC236}">
-                <a16:creationId xmlns:a16="http://schemas.microsoft.com/office/drawing/2014/main" id="{1F8CDDEF-8CAD-A4DA-AD88-B0B1D24CCF88}"/>
+                <a16:creationId xmlns:a16="http://schemas.microsoft.com/office/drawing/2014/main" id="{03473E08-1356-1961-1662-F3E867FC96E0}"/>
               </a:ext>
             </a:extLst>
           </p:cNvPr>
@@ -7581,7 +7581,7 @@
           <p:cNvPr id="15" name="矩形: 圆角 14">
             <a:extLst>
               <a:ext uri="{FF2B5EF4-FFF2-40B4-BE49-F238E27FC236}">
-                <a16:creationId xmlns:a16="http://schemas.microsoft.com/office/drawing/2014/main" id="{E32651A2-25E1-58B1-3A01-60401600EC6D}"/>
+                <a16:creationId xmlns:a16="http://schemas.microsoft.com/office/drawing/2014/main" id="{2D2F999F-DEE5-0557-9C04-FD0ACE00C9CA}"/>
               </a:ext>
             </a:extLst>
           </p:cNvPr>
@@ -7652,7 +7652,7 @@
           <p:cNvPr id="16" name="矩形: 圆角 15">
             <a:extLst>
               <a:ext uri="{FF2B5EF4-FFF2-40B4-BE49-F238E27FC236}">
-                <a16:creationId xmlns:a16="http://schemas.microsoft.com/office/drawing/2014/main" id="{6BFD2688-3A2C-F114-FE3E-4F69627559E4}"/>
+                <a16:creationId xmlns:a16="http://schemas.microsoft.com/office/drawing/2014/main" id="{D09F0829-EDE3-8BE3-FE10-63EFD2C34568}"/>
               </a:ext>
             </a:extLst>
           </p:cNvPr>
@@ -7766,7 +7766,7 @@
     </p:spTree>
     <p:extLst>
       <p:ext uri="{BB962C8B-B14F-4D97-AF65-F5344CB8AC3E}">
-        <p14:creationId xmlns:p14="http://schemas.microsoft.com/office/powerpoint/2010/main" val="1718397827"/>
+        <p14:creationId xmlns:p14="http://schemas.microsoft.com/office/powerpoint/2010/main" val="528207282"/>
       </p:ext>
     </p:extLst>
   </p:cSld>
@@ -7798,7 +7798,7 @@
           <p:cNvPr id="2" name="矩形 1">
             <a:extLst>
               <a:ext uri="{FF2B5EF4-FFF2-40B4-BE49-F238E27FC236}">
-                <a16:creationId xmlns:a16="http://schemas.microsoft.com/office/drawing/2014/main" id="{5F7F1F63-11D8-8D4B-DBCE-E4D74C9EC19E}"/>
+                <a16:creationId xmlns:a16="http://schemas.microsoft.com/office/drawing/2014/main" id="{9AC20A2C-67AF-2F16-83A8-E9762A791328}"/>
               </a:ext>
             </a:extLst>
           </p:cNvPr>
@@ -7852,7 +7852,7 @@
           <p:cNvPr id="3" name="矩形 2">
             <a:extLst>
               <a:ext uri="{FF2B5EF4-FFF2-40B4-BE49-F238E27FC236}">
-                <a16:creationId xmlns:a16="http://schemas.microsoft.com/office/drawing/2014/main" id="{E979A9EB-C689-35A1-C4A0-E73816EC6D9B}"/>
+                <a16:creationId xmlns:a16="http://schemas.microsoft.com/office/drawing/2014/main" id="{7E608F58-E63C-0CC8-E6C6-2A3DF789AA7C}"/>
               </a:ext>
             </a:extLst>
           </p:cNvPr>
@@ -7906,7 +7906,7 @@
           <p:cNvPr id="4" name="矩形 3">
             <a:extLst>
               <a:ext uri="{FF2B5EF4-FFF2-40B4-BE49-F238E27FC236}">
-                <a16:creationId xmlns:a16="http://schemas.microsoft.com/office/drawing/2014/main" id="{E11B97D0-A467-03D5-B32B-511825CAE4ED}"/>
+                <a16:creationId xmlns:a16="http://schemas.microsoft.com/office/drawing/2014/main" id="{B678DF6F-9971-4601-430C-759BF609A75E}"/>
               </a:ext>
             </a:extLst>
           </p:cNvPr>
@@ -7960,7 +7960,7 @@
           <p:cNvPr id="5" name="文本框 4">
             <a:extLst>
               <a:ext uri="{FF2B5EF4-FFF2-40B4-BE49-F238E27FC236}">
-                <a16:creationId xmlns:a16="http://schemas.microsoft.com/office/drawing/2014/main" id="{D8C82B6C-B97B-AF0E-85CB-0315FDDD6139}"/>
+                <a16:creationId xmlns:a16="http://schemas.microsoft.com/office/drawing/2014/main" id="{4A9B642C-8829-D0E9-59D4-43E4B72926B9}"/>
               </a:ext>
             </a:extLst>
           </p:cNvPr>
@@ -8000,7 +8000,7 @@
           <p:cNvPr id="6" name="文本框 5">
             <a:extLst>
               <a:ext uri="{FF2B5EF4-FFF2-40B4-BE49-F238E27FC236}">
-                <a16:creationId xmlns:a16="http://schemas.microsoft.com/office/drawing/2014/main" id="{6DC5BA3B-54B4-24F2-F5E1-0FACE2388BC1}"/>
+                <a16:creationId xmlns:a16="http://schemas.microsoft.com/office/drawing/2014/main" id="{74A2E120-F4BB-8AE7-2672-67E2C97F0745}"/>
               </a:ext>
             </a:extLst>
           </p:cNvPr>
@@ -8047,7 +8047,7 @@
           <p:cNvPr id="7" name="文本框 6">
             <a:extLst>
               <a:ext uri="{FF2B5EF4-FFF2-40B4-BE49-F238E27FC236}">
-                <a16:creationId xmlns:a16="http://schemas.microsoft.com/office/drawing/2014/main" id="{F41C2387-8CB2-6906-757B-CCDD24AB4A33}"/>
+                <a16:creationId xmlns:a16="http://schemas.microsoft.com/office/drawing/2014/main" id="{8FE57276-4388-C422-F217-EF5D4EE0382A}"/>
               </a:ext>
             </a:extLst>
           </p:cNvPr>
@@ -8087,7 +8087,7 @@
           <p:cNvPr id="8" name="矩形: 圆角 7">
             <a:extLst>
               <a:ext uri="{FF2B5EF4-FFF2-40B4-BE49-F238E27FC236}">
-                <a16:creationId xmlns:a16="http://schemas.microsoft.com/office/drawing/2014/main" id="{1ACEF9A0-880F-1F84-134E-D39A2887CED0}"/>
+                <a16:creationId xmlns:a16="http://schemas.microsoft.com/office/drawing/2014/main" id="{B8B6446F-F1DA-ADAE-B70F-B3F9FCFFF6FE}"/>
               </a:ext>
             </a:extLst>
           </p:cNvPr>
@@ -8155,7 +8155,7 @@
           <p:cNvPr id="9" name="矩形: 圆角 8">
             <a:extLst>
               <a:ext uri="{FF2B5EF4-FFF2-40B4-BE49-F238E27FC236}">
-                <a16:creationId xmlns:a16="http://schemas.microsoft.com/office/drawing/2014/main" id="{146C6872-6112-3155-FDB1-88FDA7851BBA}"/>
+                <a16:creationId xmlns:a16="http://schemas.microsoft.com/office/drawing/2014/main" id="{6978161E-51E9-84E7-E1AA-5B6D4EF62154}"/>
               </a:ext>
             </a:extLst>
           </p:cNvPr>
@@ -8223,7 +8223,7 @@
           <p:cNvPr id="10" name="矩形: 圆角 9">
             <a:extLst>
               <a:ext uri="{FF2B5EF4-FFF2-40B4-BE49-F238E27FC236}">
-                <a16:creationId xmlns:a16="http://schemas.microsoft.com/office/drawing/2014/main" id="{17ED00E9-6513-5211-43C6-C4A8934A2E01}"/>
+                <a16:creationId xmlns:a16="http://schemas.microsoft.com/office/drawing/2014/main" id="{77BFAEFC-6EB2-EC06-EC8F-2126C2D8A73C}"/>
               </a:ext>
             </a:extLst>
           </p:cNvPr>
@@ -8291,7 +8291,7 @@
           <p:cNvPr id="11" name="矩形: 圆角 10">
             <a:extLst>
               <a:ext uri="{FF2B5EF4-FFF2-40B4-BE49-F238E27FC236}">
-                <a16:creationId xmlns:a16="http://schemas.microsoft.com/office/drawing/2014/main" id="{0CF855A3-B818-672E-F902-BC69FC32F7F3}"/>
+                <a16:creationId xmlns:a16="http://schemas.microsoft.com/office/drawing/2014/main" id="{CA8E3CD7-0692-3758-7CFB-AF78B7C4EE60}"/>
               </a:ext>
             </a:extLst>
           </p:cNvPr>
@@ -8353,7 +8353,7 @@
           <p:cNvPr id="12" name="矩形: 圆角 11">
             <a:extLst>
               <a:ext uri="{FF2B5EF4-FFF2-40B4-BE49-F238E27FC236}">
-                <a16:creationId xmlns:a16="http://schemas.microsoft.com/office/drawing/2014/main" id="{567828AB-6F3A-606B-367D-AC5E7CBFE711}"/>
+                <a16:creationId xmlns:a16="http://schemas.microsoft.com/office/drawing/2014/main" id="{18D8FA3C-3781-83D1-6697-340342DEAA85}"/>
               </a:ext>
             </a:extLst>
           </p:cNvPr>
@@ -8421,7 +8421,7 @@
           <p:cNvPr id="13" name="矩形: 圆角 12">
             <a:extLst>
               <a:ext uri="{FF2B5EF4-FFF2-40B4-BE49-F238E27FC236}">
-                <a16:creationId xmlns:a16="http://schemas.microsoft.com/office/drawing/2014/main" id="{209BA874-5E3B-DAA2-88AB-9DFA57ABB770}"/>
+                <a16:creationId xmlns:a16="http://schemas.microsoft.com/office/drawing/2014/main" id="{C5376E55-F6F4-412C-7CD1-EA19AE1CAE2A}"/>
               </a:ext>
             </a:extLst>
           </p:cNvPr>
@@ -8504,7 +8504,7 @@
           <p:cNvPr id="14" name="矩形: 圆角 13">
             <a:extLst>
               <a:ext uri="{FF2B5EF4-FFF2-40B4-BE49-F238E27FC236}">
-                <a16:creationId xmlns:a16="http://schemas.microsoft.com/office/drawing/2014/main" id="{B19ADA3A-4CBD-D85B-93A4-EAC990B82A19}"/>
+                <a16:creationId xmlns:a16="http://schemas.microsoft.com/office/drawing/2014/main" id="{6EADD580-BA41-4778-F365-3AAC5128970F}"/>
               </a:ext>
             </a:extLst>
           </p:cNvPr>
@@ -8564,7 +8564,7 @@
     </p:spTree>
     <p:extLst>
       <p:ext uri="{BB962C8B-B14F-4D97-AF65-F5344CB8AC3E}">
-        <p14:creationId xmlns:p14="http://schemas.microsoft.com/office/powerpoint/2010/main" val="2145871417"/>
+        <p14:creationId xmlns:p14="http://schemas.microsoft.com/office/powerpoint/2010/main" val="1749795583"/>
       </p:ext>
     </p:extLst>
   </p:cSld>
@@ -8596,7 +8596,7 @@
           <p:cNvPr id="2" name="矩形 1">
             <a:extLst>
               <a:ext uri="{FF2B5EF4-FFF2-40B4-BE49-F238E27FC236}">
-                <a16:creationId xmlns:a16="http://schemas.microsoft.com/office/drawing/2014/main" id="{CEFAD57A-163B-4D67-816E-3E2482AC39E7}"/>
+                <a16:creationId xmlns:a16="http://schemas.microsoft.com/office/drawing/2014/main" id="{82F62F25-5E18-41D7-B54B-7EC1BD77E7A7}"/>
               </a:ext>
             </a:extLst>
           </p:cNvPr>
@@ -8650,7 +8650,7 @@
           <p:cNvPr id="3" name="矩形 2">
             <a:extLst>
               <a:ext uri="{FF2B5EF4-FFF2-40B4-BE49-F238E27FC236}">
-                <a16:creationId xmlns:a16="http://schemas.microsoft.com/office/drawing/2014/main" id="{A85622F5-1711-8B8A-77D0-D75416D35228}"/>
+                <a16:creationId xmlns:a16="http://schemas.microsoft.com/office/drawing/2014/main" id="{1819B53C-B2AE-19B1-9AB1-1AB229B439CB}"/>
               </a:ext>
             </a:extLst>
           </p:cNvPr>
@@ -8704,7 +8704,7 @@
           <p:cNvPr id="4" name="矩形 3">
             <a:extLst>
               <a:ext uri="{FF2B5EF4-FFF2-40B4-BE49-F238E27FC236}">
-                <a16:creationId xmlns:a16="http://schemas.microsoft.com/office/drawing/2014/main" id="{15FBD4E8-4512-D59B-AB67-60D3AA717CB3}"/>
+                <a16:creationId xmlns:a16="http://schemas.microsoft.com/office/drawing/2014/main" id="{74B79F9B-F531-3F8B-3313-4E9FB1F9E42A}"/>
               </a:ext>
             </a:extLst>
           </p:cNvPr>
@@ -8758,7 +8758,7 @@
           <p:cNvPr id="5" name="文本框 4">
             <a:extLst>
               <a:ext uri="{FF2B5EF4-FFF2-40B4-BE49-F238E27FC236}">
-                <a16:creationId xmlns:a16="http://schemas.microsoft.com/office/drawing/2014/main" id="{7BCBE96C-F9A9-4713-2272-E69A2244F28A}"/>
+                <a16:creationId xmlns:a16="http://schemas.microsoft.com/office/drawing/2014/main" id="{F2DF42FB-6CA1-7AD5-743A-8B1FB6D2ECCA}"/>
               </a:ext>
             </a:extLst>
           </p:cNvPr>
@@ -8798,7 +8798,7 @@
           <p:cNvPr id="6" name="文本框 5">
             <a:extLst>
               <a:ext uri="{FF2B5EF4-FFF2-40B4-BE49-F238E27FC236}">
-                <a16:creationId xmlns:a16="http://schemas.microsoft.com/office/drawing/2014/main" id="{4B631D54-CB7E-E8B3-E44C-E6E5B1E1ABA5}"/>
+                <a16:creationId xmlns:a16="http://schemas.microsoft.com/office/drawing/2014/main" id="{665A692B-077E-985A-C026-A6C9F4211337}"/>
               </a:ext>
             </a:extLst>
           </p:cNvPr>
@@ -8845,7 +8845,7 @@
           <p:cNvPr id="7" name="文本框 6">
             <a:extLst>
               <a:ext uri="{FF2B5EF4-FFF2-40B4-BE49-F238E27FC236}">
-                <a16:creationId xmlns:a16="http://schemas.microsoft.com/office/drawing/2014/main" id="{F832F44B-A79E-5FE6-61FF-75CF055FFF38}"/>
+                <a16:creationId xmlns:a16="http://schemas.microsoft.com/office/drawing/2014/main" id="{4C670E7C-B5F1-0C62-C902-B34EA6FA6965}"/>
               </a:ext>
             </a:extLst>
           </p:cNvPr>
@@ -8903,7 +8903,7 @@
           <p:cNvPr id="8" name="矩形: 圆角 7">
             <a:extLst>
               <a:ext uri="{FF2B5EF4-FFF2-40B4-BE49-F238E27FC236}">
-                <a16:creationId xmlns:a16="http://schemas.microsoft.com/office/drawing/2014/main" id="{990332CD-5B21-0E31-E81E-DDCDB4CC0357}"/>
+                <a16:creationId xmlns:a16="http://schemas.microsoft.com/office/drawing/2014/main" id="{F2115A81-EC37-E8F4-DF55-BE6FD1A2515C}"/>
               </a:ext>
             </a:extLst>
           </p:cNvPr>
@@ -8971,7 +8971,7 @@
           <p:cNvPr id="9" name="矩形: 圆角 8">
             <a:extLst>
               <a:ext uri="{FF2B5EF4-FFF2-40B4-BE49-F238E27FC236}">
-                <a16:creationId xmlns:a16="http://schemas.microsoft.com/office/drawing/2014/main" id="{8447CA28-0EB5-5E6A-44F7-6A63C0E2E396}"/>
+                <a16:creationId xmlns:a16="http://schemas.microsoft.com/office/drawing/2014/main" id="{57FD22C1-6D88-90B2-194E-59CAF8C9C85D}"/>
               </a:ext>
             </a:extLst>
           </p:cNvPr>
@@ -9033,7 +9033,7 @@
           <p:cNvPr id="10" name="矩形: 圆角 9">
             <a:extLst>
               <a:ext uri="{FF2B5EF4-FFF2-40B4-BE49-F238E27FC236}">
-                <a16:creationId xmlns:a16="http://schemas.microsoft.com/office/drawing/2014/main" id="{67FFE6F3-0A82-F201-3C1D-499BD8C55DF9}"/>
+                <a16:creationId xmlns:a16="http://schemas.microsoft.com/office/drawing/2014/main" id="{231870D6-0847-5A89-62EC-FE153165E651}"/>
               </a:ext>
             </a:extLst>
           </p:cNvPr>
@@ -9101,7 +9101,7 @@
           <p:cNvPr id="11" name="矩形: 圆角 10">
             <a:extLst>
               <a:ext uri="{FF2B5EF4-FFF2-40B4-BE49-F238E27FC236}">
-                <a16:creationId xmlns:a16="http://schemas.microsoft.com/office/drawing/2014/main" id="{51366FB0-C79C-2F52-B4B7-D28DB915D56B}"/>
+                <a16:creationId xmlns:a16="http://schemas.microsoft.com/office/drawing/2014/main" id="{D029C169-CC5C-BE05-9B6F-EA8A09BAD36B}"/>
               </a:ext>
             </a:extLst>
           </p:cNvPr>
@@ -9163,7 +9163,7 @@
           <p:cNvPr id="12" name="矩形: 圆角 11">
             <a:extLst>
               <a:ext uri="{FF2B5EF4-FFF2-40B4-BE49-F238E27FC236}">
-                <a16:creationId xmlns:a16="http://schemas.microsoft.com/office/drawing/2014/main" id="{674CC7A5-08C9-F7CD-8AB5-0D3168E94805}"/>
+                <a16:creationId xmlns:a16="http://schemas.microsoft.com/office/drawing/2014/main" id="{27F4DC96-13A1-8904-A702-7D8D2275B6C3}"/>
               </a:ext>
             </a:extLst>
           </p:cNvPr>
@@ -9231,7 +9231,7 @@
           <p:cNvPr id="13" name="矩形: 圆角 12">
             <a:extLst>
               <a:ext uri="{FF2B5EF4-FFF2-40B4-BE49-F238E27FC236}">
-                <a16:creationId xmlns:a16="http://schemas.microsoft.com/office/drawing/2014/main" id="{966352F6-7D80-854D-F492-EA3BCDDACF1A}"/>
+                <a16:creationId xmlns:a16="http://schemas.microsoft.com/office/drawing/2014/main" id="{29DDEB89-2B91-99E8-326F-9340E2422BA8}"/>
               </a:ext>
             </a:extLst>
           </p:cNvPr>
@@ -9293,7 +9293,7 @@
           <p:cNvPr id="14" name="矩形: 圆角 13">
             <a:extLst>
               <a:ext uri="{FF2B5EF4-FFF2-40B4-BE49-F238E27FC236}">
-                <a16:creationId xmlns:a16="http://schemas.microsoft.com/office/drawing/2014/main" id="{026BC49F-EAE4-FF36-241D-71C00A4A43C3}"/>
+                <a16:creationId xmlns:a16="http://schemas.microsoft.com/office/drawing/2014/main" id="{4E7F06C1-1BBE-7FD5-6B4A-8791B390F004}"/>
               </a:ext>
             </a:extLst>
           </p:cNvPr>
@@ -9373,7 +9373,7 @@
           <p:cNvPr id="15" name="矩形: 圆角 14">
             <a:extLst>
               <a:ext uri="{FF2B5EF4-FFF2-40B4-BE49-F238E27FC236}">
-                <a16:creationId xmlns:a16="http://schemas.microsoft.com/office/drawing/2014/main" id="{85A99F91-ECEE-2CD5-C860-ECBF47CB1180}"/>
+                <a16:creationId xmlns:a16="http://schemas.microsoft.com/office/drawing/2014/main" id="{E44C3A04-39AF-9B6C-BB13-C2265B3D0B48}"/>
               </a:ext>
             </a:extLst>
           </p:cNvPr>
@@ -9466,7 +9466,7 @@
     </p:spTree>
     <p:extLst>
       <p:ext uri="{BB962C8B-B14F-4D97-AF65-F5344CB8AC3E}">
-        <p14:creationId xmlns:p14="http://schemas.microsoft.com/office/powerpoint/2010/main" val="3426855196"/>
+        <p14:creationId xmlns:p14="http://schemas.microsoft.com/office/powerpoint/2010/main" val="468148330"/>
       </p:ext>
     </p:extLst>
   </p:cSld>
@@ -9498,7 +9498,7 @@
           <p:cNvPr id="2" name="矩形 1">
             <a:extLst>
               <a:ext uri="{FF2B5EF4-FFF2-40B4-BE49-F238E27FC236}">
-                <a16:creationId xmlns:a16="http://schemas.microsoft.com/office/drawing/2014/main" id="{D0B166DB-0E6E-B19E-9286-484041F910B9}"/>
+                <a16:creationId xmlns:a16="http://schemas.microsoft.com/office/drawing/2014/main" id="{2900E464-1E47-3773-AEA1-CE6EF84D3B61}"/>
               </a:ext>
             </a:extLst>
           </p:cNvPr>
@@ -9552,7 +9552,7 @@
           <p:cNvPr id="3" name="矩形 2">
             <a:extLst>
               <a:ext uri="{FF2B5EF4-FFF2-40B4-BE49-F238E27FC236}">
-                <a16:creationId xmlns:a16="http://schemas.microsoft.com/office/drawing/2014/main" id="{A4DEBEEA-46E7-E90C-66AB-E053AC7597FD}"/>
+                <a16:creationId xmlns:a16="http://schemas.microsoft.com/office/drawing/2014/main" id="{54CE156B-222E-80B5-A6F0-B3FF9553D95A}"/>
               </a:ext>
             </a:extLst>
           </p:cNvPr>
@@ -9606,7 +9606,7 @@
           <p:cNvPr id="4" name="矩形 3">
             <a:extLst>
               <a:ext uri="{FF2B5EF4-FFF2-40B4-BE49-F238E27FC236}">
-                <a16:creationId xmlns:a16="http://schemas.microsoft.com/office/drawing/2014/main" id="{AAEA8178-D74C-AC16-931D-6A6FF9BB21D5}"/>
+                <a16:creationId xmlns:a16="http://schemas.microsoft.com/office/drawing/2014/main" id="{EBEAAD23-DB28-61B7-255F-19738985EACD}"/>
               </a:ext>
             </a:extLst>
           </p:cNvPr>
@@ -9660,7 +9660,7 @@
           <p:cNvPr id="5" name="文本框 4">
             <a:extLst>
               <a:ext uri="{FF2B5EF4-FFF2-40B4-BE49-F238E27FC236}">
-                <a16:creationId xmlns:a16="http://schemas.microsoft.com/office/drawing/2014/main" id="{25D7CE64-2F04-D4C3-5D2C-DF95B79A11A1}"/>
+                <a16:creationId xmlns:a16="http://schemas.microsoft.com/office/drawing/2014/main" id="{883D3D0A-C414-6BC7-2CEE-36F2A9DE0FE1}"/>
               </a:ext>
             </a:extLst>
           </p:cNvPr>
@@ -9700,7 +9700,7 @@
           <p:cNvPr id="6" name="文本框 5">
             <a:extLst>
               <a:ext uri="{FF2B5EF4-FFF2-40B4-BE49-F238E27FC236}">
-                <a16:creationId xmlns:a16="http://schemas.microsoft.com/office/drawing/2014/main" id="{70AACDF1-19A8-14EC-2A17-7D5788E3AE65}"/>
+                <a16:creationId xmlns:a16="http://schemas.microsoft.com/office/drawing/2014/main" id="{F03C5457-466D-AB3F-D0A2-555D70C1B513}"/>
               </a:ext>
             </a:extLst>
           </p:cNvPr>
@@ -9747,7 +9747,7 @@
           <p:cNvPr id="7" name="文本框 6">
             <a:extLst>
               <a:ext uri="{FF2B5EF4-FFF2-40B4-BE49-F238E27FC236}">
-                <a16:creationId xmlns:a16="http://schemas.microsoft.com/office/drawing/2014/main" id="{39BCE635-0551-729F-91BF-290E2E651937}"/>
+                <a16:creationId xmlns:a16="http://schemas.microsoft.com/office/drawing/2014/main" id="{31159B1B-E527-4992-0ED8-07B5EC87478B}"/>
               </a:ext>
             </a:extLst>
           </p:cNvPr>
@@ -9823,7 +9823,7 @@
           <p:cNvPr id="8" name="矩形: 圆角 7">
             <a:extLst>
               <a:ext uri="{FF2B5EF4-FFF2-40B4-BE49-F238E27FC236}">
-                <a16:creationId xmlns:a16="http://schemas.microsoft.com/office/drawing/2014/main" id="{EE55043A-4983-1E53-77AB-5ABA4ADCBED3}"/>
+                <a16:creationId xmlns:a16="http://schemas.microsoft.com/office/drawing/2014/main" id="{7D45BDB7-6C8F-4597-679F-54E6AF68619A}"/>
               </a:ext>
             </a:extLst>
           </p:cNvPr>
@@ -9885,7 +9885,7 @@
           <p:cNvPr id="9" name="矩形: 圆角 8">
             <a:extLst>
               <a:ext uri="{FF2B5EF4-FFF2-40B4-BE49-F238E27FC236}">
-                <a16:creationId xmlns:a16="http://schemas.microsoft.com/office/drawing/2014/main" id="{1098E7BB-E8B9-9793-2E2D-AB7AF59BF0A5}"/>
+                <a16:creationId xmlns:a16="http://schemas.microsoft.com/office/drawing/2014/main" id="{D9E9C293-F50F-689B-F65E-0F78FB505CFE}"/>
               </a:ext>
             </a:extLst>
           </p:cNvPr>
@@ -10055,7 +10055,7 @@
           <p:cNvPr id="10" name="矩形: 圆角 9">
             <a:extLst>
               <a:ext uri="{FF2B5EF4-FFF2-40B4-BE49-F238E27FC236}">
-                <a16:creationId xmlns:a16="http://schemas.microsoft.com/office/drawing/2014/main" id="{02DD9E41-4BA7-79CA-C170-41F7CD69BCF1}"/>
+                <a16:creationId xmlns:a16="http://schemas.microsoft.com/office/drawing/2014/main" id="{05016F74-C9C3-3393-F6A0-77EC49186E3A}"/>
               </a:ext>
             </a:extLst>
           </p:cNvPr>
@@ -10123,7 +10123,7 @@
           <p:cNvPr id="11" name="矩形: 圆角 10">
             <a:extLst>
               <a:ext uri="{FF2B5EF4-FFF2-40B4-BE49-F238E27FC236}">
-                <a16:creationId xmlns:a16="http://schemas.microsoft.com/office/drawing/2014/main" id="{A5DFC9E6-289B-1497-DC6C-0989098CFECE}"/>
+                <a16:creationId xmlns:a16="http://schemas.microsoft.com/office/drawing/2014/main" id="{E45365C6-83D8-E8B6-287B-E6794BDD2CEC}"/>
               </a:ext>
             </a:extLst>
           </p:cNvPr>
@@ -10209,7 +10209,7 @@
           <p:cNvPr id="12" name="矩形: 圆角 11">
             <a:extLst>
               <a:ext uri="{FF2B5EF4-FFF2-40B4-BE49-F238E27FC236}">
-                <a16:creationId xmlns:a16="http://schemas.microsoft.com/office/drawing/2014/main" id="{80598EA2-CA62-E673-8F63-8DB7DA11683A}"/>
+                <a16:creationId xmlns:a16="http://schemas.microsoft.com/office/drawing/2014/main" id="{9A685125-F65E-4D88-2CD1-B2F2266322B9}"/>
               </a:ext>
             </a:extLst>
           </p:cNvPr>
@@ -10271,7 +10271,7 @@
           <p:cNvPr id="13" name="矩形: 圆角 12">
             <a:extLst>
               <a:ext uri="{FF2B5EF4-FFF2-40B4-BE49-F238E27FC236}">
-                <a16:creationId xmlns:a16="http://schemas.microsoft.com/office/drawing/2014/main" id="{AC4A0E5D-F227-63B1-FDBA-E3E621D3677B}"/>
+                <a16:creationId xmlns:a16="http://schemas.microsoft.com/office/drawing/2014/main" id="{E51B59A5-8ADF-10B3-8910-76BE66A5C2CD}"/>
               </a:ext>
             </a:extLst>
           </p:cNvPr>
@@ -10378,7 +10378,7 @@
           <p:cNvPr id="14" name="矩形: 圆角 13">
             <a:extLst>
               <a:ext uri="{FF2B5EF4-FFF2-40B4-BE49-F238E27FC236}">
-                <a16:creationId xmlns:a16="http://schemas.microsoft.com/office/drawing/2014/main" id="{C0D8D224-CC7D-D000-B59C-EEA4F39E2E00}"/>
+                <a16:creationId xmlns:a16="http://schemas.microsoft.com/office/drawing/2014/main" id="{656DAAF8-AEF1-DE3D-C84D-CDB34202FA5B}"/>
               </a:ext>
             </a:extLst>
           </p:cNvPr>
@@ -10447,7 +10447,7 @@
     </p:spTree>
     <p:extLst>
       <p:ext uri="{BB962C8B-B14F-4D97-AF65-F5344CB8AC3E}">
-        <p14:creationId xmlns:p14="http://schemas.microsoft.com/office/powerpoint/2010/main" val="3637271509"/>
+        <p14:creationId xmlns:p14="http://schemas.microsoft.com/office/powerpoint/2010/main" val="3059291699"/>
       </p:ext>
     </p:extLst>
   </p:cSld>
@@ -10479,7 +10479,7 @@
           <p:cNvPr id="2" name="矩形 1">
             <a:extLst>
               <a:ext uri="{FF2B5EF4-FFF2-40B4-BE49-F238E27FC236}">
-                <a16:creationId xmlns:a16="http://schemas.microsoft.com/office/drawing/2014/main" id="{206A6C8C-250B-0CFE-059B-1E2750F066CF}"/>
+                <a16:creationId xmlns:a16="http://schemas.microsoft.com/office/drawing/2014/main" id="{CD19BA31-6EE6-0BC7-86D3-074AD54A88F0}"/>
               </a:ext>
             </a:extLst>
           </p:cNvPr>
@@ -10533,7 +10533,7 @@
           <p:cNvPr id="3" name="矩形 2">
             <a:extLst>
               <a:ext uri="{FF2B5EF4-FFF2-40B4-BE49-F238E27FC236}">
-                <a16:creationId xmlns:a16="http://schemas.microsoft.com/office/drawing/2014/main" id="{9EB82A33-4EAD-21FE-BB33-199205F2020D}"/>
+                <a16:creationId xmlns:a16="http://schemas.microsoft.com/office/drawing/2014/main" id="{172C5414-014E-035D-692F-3D35DA6ABAAA}"/>
               </a:ext>
             </a:extLst>
           </p:cNvPr>
@@ -10587,7 +10587,7 @@
           <p:cNvPr id="4" name="矩形 3">
             <a:extLst>
               <a:ext uri="{FF2B5EF4-FFF2-40B4-BE49-F238E27FC236}">
-                <a16:creationId xmlns:a16="http://schemas.microsoft.com/office/drawing/2014/main" id="{BC17FBE5-6F7D-FCE8-3F7D-E6CC7E447129}"/>
+                <a16:creationId xmlns:a16="http://schemas.microsoft.com/office/drawing/2014/main" id="{22462EFC-AA76-8768-A1CF-B94E30FE4F9E}"/>
               </a:ext>
             </a:extLst>
           </p:cNvPr>
@@ -10641,7 +10641,7 @@
           <p:cNvPr id="5" name="文本框 4">
             <a:extLst>
               <a:ext uri="{FF2B5EF4-FFF2-40B4-BE49-F238E27FC236}">
-                <a16:creationId xmlns:a16="http://schemas.microsoft.com/office/drawing/2014/main" id="{7CDFF329-8C14-2BE6-2BFF-5FF55B5D9C74}"/>
+                <a16:creationId xmlns:a16="http://schemas.microsoft.com/office/drawing/2014/main" id="{1F370486-911F-6B0B-63F0-3658B8AE9D59}"/>
               </a:ext>
             </a:extLst>
           </p:cNvPr>
@@ -10699,7 +10699,7 @@
           <p:cNvPr id="6" name="文本框 5">
             <a:extLst>
               <a:ext uri="{FF2B5EF4-FFF2-40B4-BE49-F238E27FC236}">
-                <a16:creationId xmlns:a16="http://schemas.microsoft.com/office/drawing/2014/main" id="{79FB97AF-0EBD-34AF-F276-B2BAA51D3B53}"/>
+                <a16:creationId xmlns:a16="http://schemas.microsoft.com/office/drawing/2014/main" id="{46063CA3-8905-9C65-6F99-2F6FB2EB6732}"/>
               </a:ext>
             </a:extLst>
           </p:cNvPr>
@@ -10746,7 +10746,7 @@
           <p:cNvPr id="7" name="文本框 6">
             <a:extLst>
               <a:ext uri="{FF2B5EF4-FFF2-40B4-BE49-F238E27FC236}">
-                <a16:creationId xmlns:a16="http://schemas.microsoft.com/office/drawing/2014/main" id="{3D688512-BF21-B8B7-23D0-C721114717DB}"/>
+                <a16:creationId xmlns:a16="http://schemas.microsoft.com/office/drawing/2014/main" id="{0049AA37-A0F5-7FD5-E2EC-A6FB386BCB51}"/>
               </a:ext>
             </a:extLst>
           </p:cNvPr>
@@ -10840,7 +10840,7 @@
           <p:cNvPr id="8" name="矩形: 圆角 7">
             <a:extLst>
               <a:ext uri="{FF2B5EF4-FFF2-40B4-BE49-F238E27FC236}">
-                <a16:creationId xmlns:a16="http://schemas.microsoft.com/office/drawing/2014/main" id="{306631F9-DAC5-4037-B429-9170994CD0E7}"/>
+                <a16:creationId xmlns:a16="http://schemas.microsoft.com/office/drawing/2014/main" id="{8D01DC89-6D4F-C675-68E5-9A7BE8B671A6}"/>
               </a:ext>
             </a:extLst>
           </p:cNvPr>
@@ -10902,7 +10902,7 @@
           <p:cNvPr id="9" name="矩形: 圆角 8">
             <a:extLst>
               <a:ext uri="{FF2B5EF4-FFF2-40B4-BE49-F238E27FC236}">
-                <a16:creationId xmlns:a16="http://schemas.microsoft.com/office/drawing/2014/main" id="{4087ED18-126D-749F-9EF2-9BE1F0F908E6}"/>
+                <a16:creationId xmlns:a16="http://schemas.microsoft.com/office/drawing/2014/main" id="{4233330D-E3EE-6212-085B-E77345A4C104}"/>
               </a:ext>
             </a:extLst>
           </p:cNvPr>
@@ -10964,7 +10964,7 @@
           <p:cNvPr id="10" name="矩形: 圆角 9">
             <a:extLst>
               <a:ext uri="{FF2B5EF4-FFF2-40B4-BE49-F238E27FC236}">
-                <a16:creationId xmlns:a16="http://schemas.microsoft.com/office/drawing/2014/main" id="{822FF61F-800F-98F9-77CE-A8C7086A1A73}"/>
+                <a16:creationId xmlns:a16="http://schemas.microsoft.com/office/drawing/2014/main" id="{682FA602-FA84-0FA1-9456-CCA299338C7C}"/>
               </a:ext>
             </a:extLst>
           </p:cNvPr>
@@ -11026,7 +11026,7 @@
           <p:cNvPr id="11" name="矩形: 圆角 10">
             <a:extLst>
               <a:ext uri="{FF2B5EF4-FFF2-40B4-BE49-F238E27FC236}">
-                <a16:creationId xmlns:a16="http://schemas.microsoft.com/office/drawing/2014/main" id="{405EE246-4EE1-F66D-B3AA-9A952E4A3997}"/>
+                <a16:creationId xmlns:a16="http://schemas.microsoft.com/office/drawing/2014/main" id="{F1F58EB8-8822-B5FB-5F9E-C63189F32F40}"/>
               </a:ext>
             </a:extLst>
           </p:cNvPr>
@@ -11088,7 +11088,7 @@
           <p:cNvPr id="12" name="矩形: 圆角 11">
             <a:extLst>
               <a:ext uri="{FF2B5EF4-FFF2-40B4-BE49-F238E27FC236}">
-                <a16:creationId xmlns:a16="http://schemas.microsoft.com/office/drawing/2014/main" id="{F02DD48F-BD88-4224-4269-6EC9521D6A3C}"/>
+                <a16:creationId xmlns:a16="http://schemas.microsoft.com/office/drawing/2014/main" id="{05866D31-F3FE-BE37-2382-29DB597FA05C}"/>
               </a:ext>
             </a:extLst>
           </p:cNvPr>
@@ -11150,7 +11150,7 @@
           <p:cNvPr id="13" name="矩形: 圆角 12">
             <a:extLst>
               <a:ext uri="{FF2B5EF4-FFF2-40B4-BE49-F238E27FC236}">
-                <a16:creationId xmlns:a16="http://schemas.microsoft.com/office/drawing/2014/main" id="{A22F496F-D8EF-B1AB-7319-FF7C6DFC8C09}"/>
+                <a16:creationId xmlns:a16="http://schemas.microsoft.com/office/drawing/2014/main" id="{6D31B65F-50D2-D690-221C-E79976454F01}"/>
               </a:ext>
             </a:extLst>
           </p:cNvPr>
@@ -11212,7 +11212,7 @@
           <p:cNvPr id="14" name="矩形: 圆角 13">
             <a:extLst>
               <a:ext uri="{FF2B5EF4-FFF2-40B4-BE49-F238E27FC236}">
-                <a16:creationId xmlns:a16="http://schemas.microsoft.com/office/drawing/2014/main" id="{747B8D2C-3AD1-D4A0-E5EE-DD42157D8B33}"/>
+                <a16:creationId xmlns:a16="http://schemas.microsoft.com/office/drawing/2014/main" id="{5FFBE2D4-A2BD-0F7C-6E04-3EE463098C81}"/>
               </a:ext>
             </a:extLst>
           </p:cNvPr>
@@ -11359,7 +11359,7 @@
     </p:spTree>
     <p:extLst>
       <p:ext uri="{BB962C8B-B14F-4D97-AF65-F5344CB8AC3E}">
-        <p14:creationId xmlns:p14="http://schemas.microsoft.com/office/powerpoint/2010/main" val="1098303654"/>
+        <p14:creationId xmlns:p14="http://schemas.microsoft.com/office/powerpoint/2010/main" val="4229091664"/>
       </p:ext>
     </p:extLst>
   </p:cSld>
@@ -11391,7 +11391,7 @@
           <p:cNvPr id="2" name="矩形 1">
             <a:extLst>
               <a:ext uri="{FF2B5EF4-FFF2-40B4-BE49-F238E27FC236}">
-                <a16:creationId xmlns:a16="http://schemas.microsoft.com/office/drawing/2014/main" id="{EEF54E83-CA98-2BE5-2BC1-F07125319EB0}"/>
+                <a16:creationId xmlns:a16="http://schemas.microsoft.com/office/drawing/2014/main" id="{B0102F28-9E6D-49A5-139B-FAA62D8D97FB}"/>
               </a:ext>
             </a:extLst>
           </p:cNvPr>
@@ -11445,7 +11445,7 @@
           <p:cNvPr id="3" name="矩形 2">
             <a:extLst>
               <a:ext uri="{FF2B5EF4-FFF2-40B4-BE49-F238E27FC236}">
-                <a16:creationId xmlns:a16="http://schemas.microsoft.com/office/drawing/2014/main" id="{6069DB9C-DF5B-0070-22F1-B538679B9FF2}"/>
+                <a16:creationId xmlns:a16="http://schemas.microsoft.com/office/drawing/2014/main" id="{418A8322-CC84-ED95-2132-F60A6C935EE7}"/>
               </a:ext>
             </a:extLst>
           </p:cNvPr>
@@ -11499,7 +11499,7 @@
           <p:cNvPr id="4" name="矩形 3">
             <a:extLst>
               <a:ext uri="{FF2B5EF4-FFF2-40B4-BE49-F238E27FC236}">
-                <a16:creationId xmlns:a16="http://schemas.microsoft.com/office/drawing/2014/main" id="{5AC42705-1FB7-2A33-0B40-D9526861EFB1}"/>
+                <a16:creationId xmlns:a16="http://schemas.microsoft.com/office/drawing/2014/main" id="{5480BE55-E5C4-C068-8923-A7711CD820CC}"/>
               </a:ext>
             </a:extLst>
           </p:cNvPr>
@@ -11553,7 +11553,7 @@
           <p:cNvPr id="5" name="文本框 4">
             <a:extLst>
               <a:ext uri="{FF2B5EF4-FFF2-40B4-BE49-F238E27FC236}">
-                <a16:creationId xmlns:a16="http://schemas.microsoft.com/office/drawing/2014/main" id="{B4FC390B-0F95-E712-AB7D-B7571AB96F0B}"/>
+                <a16:creationId xmlns:a16="http://schemas.microsoft.com/office/drawing/2014/main" id="{1763BC96-B916-27F5-276C-6E5FE5BC9AA2}"/>
               </a:ext>
             </a:extLst>
           </p:cNvPr>
@@ -11593,7 +11593,7 @@
           <p:cNvPr id="6" name="文本框 5">
             <a:extLst>
               <a:ext uri="{FF2B5EF4-FFF2-40B4-BE49-F238E27FC236}">
-                <a16:creationId xmlns:a16="http://schemas.microsoft.com/office/drawing/2014/main" id="{4651AA81-5CE9-55F7-EA75-D1688970EC9E}"/>
+                <a16:creationId xmlns:a16="http://schemas.microsoft.com/office/drawing/2014/main" id="{45E56C4A-103E-156A-0FA3-4EA80E7FB2D7}"/>
               </a:ext>
             </a:extLst>
           </p:cNvPr>
@@ -11640,7 +11640,7 @@
           <p:cNvPr id="7" name="文本框 6">
             <a:extLst>
               <a:ext uri="{FF2B5EF4-FFF2-40B4-BE49-F238E27FC236}">
-                <a16:creationId xmlns:a16="http://schemas.microsoft.com/office/drawing/2014/main" id="{17CA93F3-A2A9-6E37-1467-97A1A84151D8}"/>
+                <a16:creationId xmlns:a16="http://schemas.microsoft.com/office/drawing/2014/main" id="{3614F213-1089-1FCD-723D-4F1679313DED}"/>
               </a:ext>
             </a:extLst>
           </p:cNvPr>
@@ -11680,7 +11680,7 @@
           <p:cNvPr id="8" name="矩形: 圆角 7">
             <a:extLst>
               <a:ext uri="{FF2B5EF4-FFF2-40B4-BE49-F238E27FC236}">
-                <a16:creationId xmlns:a16="http://schemas.microsoft.com/office/drawing/2014/main" id="{0A8FB2D9-7F04-5446-BF93-346B894AD0F3}"/>
+                <a16:creationId xmlns:a16="http://schemas.microsoft.com/office/drawing/2014/main" id="{323C39AE-4597-94CE-4C95-FB1B2B23CB1C}"/>
               </a:ext>
             </a:extLst>
           </p:cNvPr>
@@ -11742,7 +11742,7 @@
           <p:cNvPr id="9" name="矩形: 圆角 8">
             <a:extLst>
               <a:ext uri="{FF2B5EF4-FFF2-40B4-BE49-F238E27FC236}">
-                <a16:creationId xmlns:a16="http://schemas.microsoft.com/office/drawing/2014/main" id="{D9B9DAD1-FCA5-627A-05E6-EB7F7B167BDE}"/>
+                <a16:creationId xmlns:a16="http://schemas.microsoft.com/office/drawing/2014/main" id="{FE6C270F-FA5B-9D37-C69C-111BB0723B97}"/>
               </a:ext>
             </a:extLst>
           </p:cNvPr>
@@ -11813,7 +11813,7 @@
           <p:cNvPr id="10" name="矩形: 圆角 9">
             <a:extLst>
               <a:ext uri="{FF2B5EF4-FFF2-40B4-BE49-F238E27FC236}">
-                <a16:creationId xmlns:a16="http://schemas.microsoft.com/office/drawing/2014/main" id="{BA604C46-E707-6E30-01BA-61D7C84C3C57}"/>
+                <a16:creationId xmlns:a16="http://schemas.microsoft.com/office/drawing/2014/main" id="{B62EF70A-D74A-BF50-BA97-1C67B2DFCEE5}"/>
               </a:ext>
             </a:extLst>
           </p:cNvPr>
@@ -11875,7 +11875,7 @@
           <p:cNvPr id="11" name="矩形: 圆角 10">
             <a:extLst>
               <a:ext uri="{FF2B5EF4-FFF2-40B4-BE49-F238E27FC236}">
-                <a16:creationId xmlns:a16="http://schemas.microsoft.com/office/drawing/2014/main" id="{C29DAF71-D7B3-FA61-E14F-B99B91EE3CE9}"/>
+                <a16:creationId xmlns:a16="http://schemas.microsoft.com/office/drawing/2014/main" id="{95B21866-89C6-9122-B786-4AFDF13FF194}"/>
               </a:ext>
             </a:extLst>
           </p:cNvPr>
@@ -11937,7 +11937,7 @@
           <p:cNvPr id="12" name="矩形: 圆角 11">
             <a:extLst>
               <a:ext uri="{FF2B5EF4-FFF2-40B4-BE49-F238E27FC236}">
-                <a16:creationId xmlns:a16="http://schemas.microsoft.com/office/drawing/2014/main" id="{2DBD55EA-45AE-5034-FB46-F7E12F337091}"/>
+                <a16:creationId xmlns:a16="http://schemas.microsoft.com/office/drawing/2014/main" id="{58994A1C-C830-E270-C283-0F5E874C6166}"/>
               </a:ext>
             </a:extLst>
           </p:cNvPr>
@@ -11999,7 +11999,7 @@
           <p:cNvPr id="13" name="矩形: 圆角 12">
             <a:extLst>
               <a:ext uri="{FF2B5EF4-FFF2-40B4-BE49-F238E27FC236}">
-                <a16:creationId xmlns:a16="http://schemas.microsoft.com/office/drawing/2014/main" id="{88C09052-C740-95DE-686B-131EBF95BF7A}"/>
+                <a16:creationId xmlns:a16="http://schemas.microsoft.com/office/drawing/2014/main" id="{A70E9356-66B9-9D56-6A7B-4D875D1C3A30}"/>
               </a:ext>
             </a:extLst>
           </p:cNvPr>
@@ -12059,7 +12059,7 @@
     </p:spTree>
     <p:extLst>
       <p:ext uri="{BB962C8B-B14F-4D97-AF65-F5344CB8AC3E}">
-        <p14:creationId xmlns:p14="http://schemas.microsoft.com/office/powerpoint/2010/main" val="2013697404"/>
+        <p14:creationId xmlns:p14="http://schemas.microsoft.com/office/powerpoint/2010/main" val="2660854401"/>
       </p:ext>
     </p:extLst>
   </p:cSld>
@@ -12091,7 +12091,7 @@
           <p:cNvPr id="2" name="矩形 1">
             <a:extLst>
               <a:ext uri="{FF2B5EF4-FFF2-40B4-BE49-F238E27FC236}">
-                <a16:creationId xmlns:a16="http://schemas.microsoft.com/office/drawing/2014/main" id="{5FDFD445-7A41-D118-0583-D455D023E9F4}"/>
+                <a16:creationId xmlns:a16="http://schemas.microsoft.com/office/drawing/2014/main" id="{6962DA8C-5898-3DFF-A961-076C0794285A}"/>
               </a:ext>
             </a:extLst>
           </p:cNvPr>
@@ -12145,7 +12145,7 @@
           <p:cNvPr id="3" name="矩形 2">
             <a:extLst>
               <a:ext uri="{FF2B5EF4-FFF2-40B4-BE49-F238E27FC236}">
-                <a16:creationId xmlns:a16="http://schemas.microsoft.com/office/drawing/2014/main" id="{8A5DF01A-437C-3393-F429-D3C259DD7E2A}"/>
+                <a16:creationId xmlns:a16="http://schemas.microsoft.com/office/drawing/2014/main" id="{FFC62E8F-BF21-AE62-286A-4E50C70F1459}"/>
               </a:ext>
             </a:extLst>
           </p:cNvPr>
@@ -12199,7 +12199,7 @@
           <p:cNvPr id="4" name="矩形 3">
             <a:extLst>
               <a:ext uri="{FF2B5EF4-FFF2-40B4-BE49-F238E27FC236}">
-                <a16:creationId xmlns:a16="http://schemas.microsoft.com/office/drawing/2014/main" id="{2DDBED0F-596B-98A9-8C9F-2C381F1208F2}"/>
+                <a16:creationId xmlns:a16="http://schemas.microsoft.com/office/drawing/2014/main" id="{90B9F4F6-46AE-089B-8411-83BCDCD153E0}"/>
               </a:ext>
             </a:extLst>
           </p:cNvPr>
@@ -12253,7 +12253,7 @@
           <p:cNvPr id="5" name="文本框 4">
             <a:extLst>
               <a:ext uri="{FF2B5EF4-FFF2-40B4-BE49-F238E27FC236}">
-                <a16:creationId xmlns:a16="http://schemas.microsoft.com/office/drawing/2014/main" id="{8C8B1F01-DBFF-73A0-2E82-67B5DB594325}"/>
+                <a16:creationId xmlns:a16="http://schemas.microsoft.com/office/drawing/2014/main" id="{241BB989-5942-167E-2F02-21DB95C6C8E4}"/>
               </a:ext>
             </a:extLst>
           </p:cNvPr>
@@ -12293,7 +12293,7 @@
           <p:cNvPr id="6" name="文本框 5">
             <a:extLst>
               <a:ext uri="{FF2B5EF4-FFF2-40B4-BE49-F238E27FC236}">
-                <a16:creationId xmlns:a16="http://schemas.microsoft.com/office/drawing/2014/main" id="{95DE15A8-3B7F-8ACB-514E-76B8B76D42E2}"/>
+                <a16:creationId xmlns:a16="http://schemas.microsoft.com/office/drawing/2014/main" id="{AD689393-40DF-CEEA-E92D-E8CD32E28CAA}"/>
               </a:ext>
             </a:extLst>
           </p:cNvPr>
@@ -12340,7 +12340,7 @@
           <p:cNvPr id="7" name="文本框 6">
             <a:extLst>
               <a:ext uri="{FF2B5EF4-FFF2-40B4-BE49-F238E27FC236}">
-                <a16:creationId xmlns:a16="http://schemas.microsoft.com/office/drawing/2014/main" id="{C2D03E13-9DC9-804C-A6CB-9C8A09A87F62}"/>
+                <a16:creationId xmlns:a16="http://schemas.microsoft.com/office/drawing/2014/main" id="{8289F75C-3128-D741-D4F5-D54B0E98AAB0}"/>
               </a:ext>
             </a:extLst>
           </p:cNvPr>
@@ -12380,7 +12380,7 @@
           <p:cNvPr id="8" name="矩形: 圆角 7">
             <a:extLst>
               <a:ext uri="{FF2B5EF4-FFF2-40B4-BE49-F238E27FC236}">
-                <a16:creationId xmlns:a16="http://schemas.microsoft.com/office/drawing/2014/main" id="{1BE4324C-F196-E932-9A23-E5B7FAE2F223}"/>
+                <a16:creationId xmlns:a16="http://schemas.microsoft.com/office/drawing/2014/main" id="{CF43F142-6037-7A11-7A85-F1DD1045B1EC}"/>
               </a:ext>
             </a:extLst>
           </p:cNvPr>
@@ -12490,7 +12490,7 @@
           <p:cNvPr id="9" name="矩形: 圆角 8">
             <a:extLst>
               <a:ext uri="{FF2B5EF4-FFF2-40B4-BE49-F238E27FC236}">
-                <a16:creationId xmlns:a16="http://schemas.microsoft.com/office/drawing/2014/main" id="{C1150211-6874-524B-2AE0-C04DBD8BB98E}"/>
+                <a16:creationId xmlns:a16="http://schemas.microsoft.com/office/drawing/2014/main" id="{AE0567E1-79B8-1F78-6E80-0F22BAABABE8}"/>
               </a:ext>
             </a:extLst>
           </p:cNvPr>
@@ -12597,7 +12597,7 @@
           <p:cNvPr id="10" name="矩形: 圆角 9">
             <a:extLst>
               <a:ext uri="{FF2B5EF4-FFF2-40B4-BE49-F238E27FC236}">
-                <a16:creationId xmlns:a16="http://schemas.microsoft.com/office/drawing/2014/main" id="{518633BE-27C6-C730-1C05-F218D5E784D5}"/>
+                <a16:creationId xmlns:a16="http://schemas.microsoft.com/office/drawing/2014/main" id="{1F78002D-312C-E476-B3F9-470E513BB519}"/>
               </a:ext>
             </a:extLst>
           </p:cNvPr>
@@ -12689,7 +12689,7 @@
           <p:cNvPr id="11" name="矩形: 圆角 10">
             <a:extLst>
               <a:ext uri="{FF2B5EF4-FFF2-40B4-BE49-F238E27FC236}">
-                <a16:creationId xmlns:a16="http://schemas.microsoft.com/office/drawing/2014/main" id="{95BC7F9D-EB15-33A9-E652-3A7C068F2CE5}"/>
+                <a16:creationId xmlns:a16="http://schemas.microsoft.com/office/drawing/2014/main" id="{37CEC11B-9024-A64B-23F3-EE82E38D50EC}"/>
               </a:ext>
             </a:extLst>
           </p:cNvPr>
@@ -12799,7 +12799,7 @@
           <p:cNvPr id="12" name="矩形: 圆角 11">
             <a:extLst>
               <a:ext uri="{FF2B5EF4-FFF2-40B4-BE49-F238E27FC236}">
-                <a16:creationId xmlns:a16="http://schemas.microsoft.com/office/drawing/2014/main" id="{F97CB929-C239-5904-70F0-E6EE6C03A4A6}"/>
+                <a16:creationId xmlns:a16="http://schemas.microsoft.com/office/drawing/2014/main" id="{4B705075-ECB6-0583-A51F-77155DC7A6A0}"/>
               </a:ext>
             </a:extLst>
           </p:cNvPr>
@@ -12909,7 +12909,7 @@
           <p:cNvPr id="13" name="矩形: 圆角 12">
             <a:extLst>
               <a:ext uri="{FF2B5EF4-FFF2-40B4-BE49-F238E27FC236}">
-                <a16:creationId xmlns:a16="http://schemas.microsoft.com/office/drawing/2014/main" id="{39B5FF1E-5EBA-F69B-C5B3-65C63A34F2EE}"/>
+                <a16:creationId xmlns:a16="http://schemas.microsoft.com/office/drawing/2014/main" id="{045F0FA1-96D3-58ED-6EE7-0D1C3FB74B03}"/>
               </a:ext>
             </a:extLst>
           </p:cNvPr>
@@ -13005,7 +13005,7 @@
     </p:spTree>
     <p:extLst>
       <p:ext uri="{BB962C8B-B14F-4D97-AF65-F5344CB8AC3E}">
-        <p14:creationId xmlns:p14="http://schemas.microsoft.com/office/powerpoint/2010/main" val="1042310129"/>
+        <p14:creationId xmlns:p14="http://schemas.microsoft.com/office/powerpoint/2010/main" val="195174598"/>
       </p:ext>
     </p:extLst>
   </p:cSld>
@@ -13037,7 +13037,7 @@
           <p:cNvPr id="2" name="矩形 1">
             <a:extLst>
               <a:ext uri="{FF2B5EF4-FFF2-40B4-BE49-F238E27FC236}">
-                <a16:creationId xmlns:a16="http://schemas.microsoft.com/office/drawing/2014/main" id="{49D83675-E0A0-236C-CF6E-52909B95C4F5}"/>
+                <a16:creationId xmlns:a16="http://schemas.microsoft.com/office/drawing/2014/main" id="{B964BE7C-D6FB-E4CD-901F-6148AB895124}"/>
               </a:ext>
             </a:extLst>
           </p:cNvPr>
@@ -13091,7 +13091,7 @@
           <p:cNvPr id="3" name="矩形 2">
             <a:extLst>
               <a:ext uri="{FF2B5EF4-FFF2-40B4-BE49-F238E27FC236}">
-                <a16:creationId xmlns:a16="http://schemas.microsoft.com/office/drawing/2014/main" id="{6FA2BE58-B7D2-C670-CEAC-BC7815E1BD01}"/>
+                <a16:creationId xmlns:a16="http://schemas.microsoft.com/office/drawing/2014/main" id="{A0C40138-0782-6DB6-29CE-6AAEFBFE511A}"/>
               </a:ext>
             </a:extLst>
           </p:cNvPr>
@@ -13145,7 +13145,7 @@
           <p:cNvPr id="4" name="矩形 3">
             <a:extLst>
               <a:ext uri="{FF2B5EF4-FFF2-40B4-BE49-F238E27FC236}">
-                <a16:creationId xmlns:a16="http://schemas.microsoft.com/office/drawing/2014/main" id="{42635A55-ACF1-F470-BAB8-C2AB1AA77ED0}"/>
+                <a16:creationId xmlns:a16="http://schemas.microsoft.com/office/drawing/2014/main" id="{7E292ADB-3B40-F76B-4A11-AF63123F4076}"/>
               </a:ext>
             </a:extLst>
           </p:cNvPr>
@@ -13199,7 +13199,7 @@
           <p:cNvPr id="5" name="文本框 4">
             <a:extLst>
               <a:ext uri="{FF2B5EF4-FFF2-40B4-BE49-F238E27FC236}">
-                <a16:creationId xmlns:a16="http://schemas.microsoft.com/office/drawing/2014/main" id="{13EE4469-EA96-7C3A-E938-F161D31B8CC3}"/>
+                <a16:creationId xmlns:a16="http://schemas.microsoft.com/office/drawing/2014/main" id="{4D9A4A3A-F4D2-01CB-1BA8-08A731F1AAD6}"/>
               </a:ext>
             </a:extLst>
           </p:cNvPr>
@@ -13239,7 +13239,7 @@
           <p:cNvPr id="6" name="文本框 5">
             <a:extLst>
               <a:ext uri="{FF2B5EF4-FFF2-40B4-BE49-F238E27FC236}">
-                <a16:creationId xmlns:a16="http://schemas.microsoft.com/office/drawing/2014/main" id="{D17BA5F8-D9D4-7EFD-D798-EFA929FD2503}"/>
+                <a16:creationId xmlns:a16="http://schemas.microsoft.com/office/drawing/2014/main" id="{F1811AB0-A805-D9AA-5A6A-93A29C6B4920}"/>
               </a:ext>
             </a:extLst>
           </p:cNvPr>
@@ -13286,7 +13286,7 @@
           <p:cNvPr id="7" name="文本框 6">
             <a:extLst>
               <a:ext uri="{FF2B5EF4-FFF2-40B4-BE49-F238E27FC236}">
-                <a16:creationId xmlns:a16="http://schemas.microsoft.com/office/drawing/2014/main" id="{81986F58-B2C5-918D-E87C-C258090996C5}"/>
+                <a16:creationId xmlns:a16="http://schemas.microsoft.com/office/drawing/2014/main" id="{1065CB2C-B668-E2A8-264B-83ED7B88DF81}"/>
               </a:ext>
             </a:extLst>
           </p:cNvPr>
@@ -13344,7 +13344,7 @@
           <p:cNvPr id="8" name="矩形: 圆角 7">
             <a:extLst>
               <a:ext uri="{FF2B5EF4-FFF2-40B4-BE49-F238E27FC236}">
-                <a16:creationId xmlns:a16="http://schemas.microsoft.com/office/drawing/2014/main" id="{213A9D80-C89E-08AB-6057-E8D230270740}"/>
+                <a16:creationId xmlns:a16="http://schemas.microsoft.com/office/drawing/2014/main" id="{6EC76297-CB02-3D27-024A-FAD15530F9C2}"/>
               </a:ext>
             </a:extLst>
           </p:cNvPr>
@@ -13406,7 +13406,7 @@
           <p:cNvPr id="9" name="矩形: 圆角 8">
             <a:extLst>
               <a:ext uri="{FF2B5EF4-FFF2-40B4-BE49-F238E27FC236}">
-                <a16:creationId xmlns:a16="http://schemas.microsoft.com/office/drawing/2014/main" id="{FE15E8DD-6089-9F4D-C7AE-F2519B12FDF0}"/>
+                <a16:creationId xmlns:a16="http://schemas.microsoft.com/office/drawing/2014/main" id="{7F528F1F-99F3-7F56-B0E7-7DDAA9CC3D03}"/>
               </a:ext>
             </a:extLst>
           </p:cNvPr>
@@ -13504,7 +13504,7 @@
           <p:cNvPr id="10" name="矩形: 圆角 9">
             <a:extLst>
               <a:ext uri="{FF2B5EF4-FFF2-40B4-BE49-F238E27FC236}">
-                <a16:creationId xmlns:a16="http://schemas.microsoft.com/office/drawing/2014/main" id="{C208BB2D-50E4-353B-0D5B-A9B4FC30A29B}"/>
+                <a16:creationId xmlns:a16="http://schemas.microsoft.com/office/drawing/2014/main" id="{C70BED6F-DC2E-3580-9B35-D218D8AC22A3}"/>
               </a:ext>
             </a:extLst>
           </p:cNvPr>
@@ -13566,7 +13566,7 @@
           <p:cNvPr id="11" name="矩形: 圆角 10">
             <a:extLst>
               <a:ext uri="{FF2B5EF4-FFF2-40B4-BE49-F238E27FC236}">
-                <a16:creationId xmlns:a16="http://schemas.microsoft.com/office/drawing/2014/main" id="{C9D5C731-B6EA-976A-E343-A7D4804B600B}"/>
+                <a16:creationId xmlns:a16="http://schemas.microsoft.com/office/drawing/2014/main" id="{A7144813-899A-2ACA-74FA-75A7477C15DD}"/>
               </a:ext>
             </a:extLst>
           </p:cNvPr>
@@ -13664,7 +13664,7 @@
           <p:cNvPr id="12" name="矩形: 圆角 11">
             <a:extLst>
               <a:ext uri="{FF2B5EF4-FFF2-40B4-BE49-F238E27FC236}">
-                <a16:creationId xmlns:a16="http://schemas.microsoft.com/office/drawing/2014/main" id="{04C5FC0D-D1FF-0FF6-B0F0-17BA01586394}"/>
+                <a16:creationId xmlns:a16="http://schemas.microsoft.com/office/drawing/2014/main" id="{0FC1CFE0-3714-6274-4720-FE91CB5419F1}"/>
               </a:ext>
             </a:extLst>
           </p:cNvPr>
@@ -13726,7 +13726,7 @@
           <p:cNvPr id="13" name="矩形: 圆角 12">
             <a:extLst>
               <a:ext uri="{FF2B5EF4-FFF2-40B4-BE49-F238E27FC236}">
-                <a16:creationId xmlns:a16="http://schemas.microsoft.com/office/drawing/2014/main" id="{3B34170F-11EA-FE97-D9A6-FE4C8E86347D}"/>
+                <a16:creationId xmlns:a16="http://schemas.microsoft.com/office/drawing/2014/main" id="{1FE0F413-EA7D-1BD5-1E63-6BACE99F12D4}"/>
               </a:ext>
             </a:extLst>
           </p:cNvPr>
@@ -13899,7 +13899,7 @@
           <p:cNvPr id="14" name="矩形: 圆角 13">
             <a:extLst>
               <a:ext uri="{FF2B5EF4-FFF2-40B4-BE49-F238E27FC236}">
-                <a16:creationId xmlns:a16="http://schemas.microsoft.com/office/drawing/2014/main" id="{92A4F831-B355-9E84-E630-71D0805158BC}"/>
+                <a16:creationId xmlns:a16="http://schemas.microsoft.com/office/drawing/2014/main" id="{8E614C5D-42F1-C28A-6360-BEF791AC8F46}"/>
               </a:ext>
             </a:extLst>
           </p:cNvPr>
@@ -13959,7 +13959,7 @@
     </p:spTree>
     <p:extLst>
       <p:ext uri="{BB962C8B-B14F-4D97-AF65-F5344CB8AC3E}">
-        <p14:creationId xmlns:p14="http://schemas.microsoft.com/office/powerpoint/2010/main" val="1252256392"/>
+        <p14:creationId xmlns:p14="http://schemas.microsoft.com/office/powerpoint/2010/main" val="2238016430"/>
       </p:ext>
     </p:extLst>
   </p:cSld>
@@ -13991,7 +13991,7 @@
           <p:cNvPr id="2" name="矩形 1">
             <a:extLst>
               <a:ext uri="{FF2B5EF4-FFF2-40B4-BE49-F238E27FC236}">
-                <a16:creationId xmlns:a16="http://schemas.microsoft.com/office/drawing/2014/main" id="{3DA79FE8-CF63-F07D-78C6-7F8DB786D69A}"/>
+                <a16:creationId xmlns:a16="http://schemas.microsoft.com/office/drawing/2014/main" id="{7882FBA7-8A94-23EC-0010-4460C43B08DC}"/>
               </a:ext>
             </a:extLst>
           </p:cNvPr>
@@ -14045,7 +14045,7 @@
           <p:cNvPr id="3" name="矩形 2">
             <a:extLst>
               <a:ext uri="{FF2B5EF4-FFF2-40B4-BE49-F238E27FC236}">
-                <a16:creationId xmlns:a16="http://schemas.microsoft.com/office/drawing/2014/main" id="{DD0B7127-AD90-552C-CDE1-D871933482F7}"/>
+                <a16:creationId xmlns:a16="http://schemas.microsoft.com/office/drawing/2014/main" id="{B03893D7-E412-16D8-5A0B-277A61807FF3}"/>
               </a:ext>
             </a:extLst>
           </p:cNvPr>
@@ -14099,7 +14099,7 @@
           <p:cNvPr id="4" name="矩形 3">
             <a:extLst>
               <a:ext uri="{FF2B5EF4-FFF2-40B4-BE49-F238E27FC236}">
-                <a16:creationId xmlns:a16="http://schemas.microsoft.com/office/drawing/2014/main" id="{0853E130-C83B-B40B-F38B-B82F0C120E9D}"/>
+                <a16:creationId xmlns:a16="http://schemas.microsoft.com/office/drawing/2014/main" id="{D4661D43-52ED-71C6-59AB-336B14C70E92}"/>
               </a:ext>
             </a:extLst>
           </p:cNvPr>
@@ -14153,7 +14153,7 @@
           <p:cNvPr id="5" name="文本框 4">
             <a:extLst>
               <a:ext uri="{FF2B5EF4-FFF2-40B4-BE49-F238E27FC236}">
-                <a16:creationId xmlns:a16="http://schemas.microsoft.com/office/drawing/2014/main" id="{2DA31D88-0FED-4201-E86A-D9E39297B5ED}"/>
+                <a16:creationId xmlns:a16="http://schemas.microsoft.com/office/drawing/2014/main" id="{53700FA2-C6E5-FACE-036A-4425155823A6}"/>
               </a:ext>
             </a:extLst>
           </p:cNvPr>
@@ -14193,7 +14193,7 @@
           <p:cNvPr id="6" name="文本框 5">
             <a:extLst>
               <a:ext uri="{FF2B5EF4-FFF2-40B4-BE49-F238E27FC236}">
-                <a16:creationId xmlns:a16="http://schemas.microsoft.com/office/drawing/2014/main" id="{2ABD4BF3-E626-EE23-A2B5-267FE8B2E02B}"/>
+                <a16:creationId xmlns:a16="http://schemas.microsoft.com/office/drawing/2014/main" id="{FBC9244F-8E59-D44F-027B-3A9CD4DCEFE5}"/>
               </a:ext>
             </a:extLst>
           </p:cNvPr>
@@ -14240,7 +14240,7 @@
           <p:cNvPr id="7" name="文本框 6">
             <a:extLst>
               <a:ext uri="{FF2B5EF4-FFF2-40B4-BE49-F238E27FC236}">
-                <a16:creationId xmlns:a16="http://schemas.microsoft.com/office/drawing/2014/main" id="{99F1F51B-AD60-546F-7008-92D6F22106E7}"/>
+                <a16:creationId xmlns:a16="http://schemas.microsoft.com/office/drawing/2014/main" id="{AFD5019C-4694-DB6F-B0E4-5B36DD80485E}"/>
               </a:ext>
             </a:extLst>
           </p:cNvPr>
@@ -14298,7 +14298,7 @@
           <p:cNvPr id="8" name="矩形: 圆角 7">
             <a:extLst>
               <a:ext uri="{FF2B5EF4-FFF2-40B4-BE49-F238E27FC236}">
-                <a16:creationId xmlns:a16="http://schemas.microsoft.com/office/drawing/2014/main" id="{83F0A11D-81F6-8F21-DFA2-6E09F50EB218}"/>
+                <a16:creationId xmlns:a16="http://schemas.microsoft.com/office/drawing/2014/main" id="{E7918798-E9D2-0CEF-2528-A462595C4185}"/>
               </a:ext>
             </a:extLst>
           </p:cNvPr>
@@ -14360,7 +14360,7 @@
           <p:cNvPr id="9" name="矩形: 圆角 8">
             <a:extLst>
               <a:ext uri="{FF2B5EF4-FFF2-40B4-BE49-F238E27FC236}">
-                <a16:creationId xmlns:a16="http://schemas.microsoft.com/office/drawing/2014/main" id="{9247DC42-9A99-F829-9CDC-560471E1F09B}"/>
+                <a16:creationId xmlns:a16="http://schemas.microsoft.com/office/drawing/2014/main" id="{06940EA1-840A-F45F-2C4F-44FF99CE4424}"/>
               </a:ext>
             </a:extLst>
           </p:cNvPr>
@@ -14476,7 +14476,7 @@
           <p:cNvPr id="10" name="矩形: 圆角 9">
             <a:extLst>
               <a:ext uri="{FF2B5EF4-FFF2-40B4-BE49-F238E27FC236}">
-                <a16:creationId xmlns:a16="http://schemas.microsoft.com/office/drawing/2014/main" id="{2ABE4BAE-DEF5-A8F3-B282-5214C704E558}"/>
+                <a16:creationId xmlns:a16="http://schemas.microsoft.com/office/drawing/2014/main" id="{2A99E0AA-2E66-838A-FD5D-1F89444FF313}"/>
               </a:ext>
             </a:extLst>
           </p:cNvPr>
@@ -14538,7 +14538,7 @@
           <p:cNvPr id="11" name="矩形: 圆角 10">
             <a:extLst>
               <a:ext uri="{FF2B5EF4-FFF2-40B4-BE49-F238E27FC236}">
-                <a16:creationId xmlns:a16="http://schemas.microsoft.com/office/drawing/2014/main" id="{3A2B0BB8-D7BF-5906-5922-B1A7A54B5F3D}"/>
+                <a16:creationId xmlns:a16="http://schemas.microsoft.com/office/drawing/2014/main" id="{17335F00-1951-8E42-B805-49AD8EB0C37E}"/>
               </a:ext>
             </a:extLst>
           </p:cNvPr>
@@ -14600,7 +14600,7 @@
           <p:cNvPr id="12" name="矩形: 圆角 11">
             <a:extLst>
               <a:ext uri="{FF2B5EF4-FFF2-40B4-BE49-F238E27FC236}">
-                <a16:creationId xmlns:a16="http://schemas.microsoft.com/office/drawing/2014/main" id="{2B9FBC85-4639-BC25-0CB4-AD2929CC727D}"/>
+                <a16:creationId xmlns:a16="http://schemas.microsoft.com/office/drawing/2014/main" id="{5EAFB63B-A450-6B93-8CE3-0636FA9683EC}"/>
               </a:ext>
             </a:extLst>
           </p:cNvPr>
@@ -14662,7 +14662,7 @@
           <p:cNvPr id="13" name="矩形: 圆角 12">
             <a:extLst>
               <a:ext uri="{FF2B5EF4-FFF2-40B4-BE49-F238E27FC236}">
-                <a16:creationId xmlns:a16="http://schemas.microsoft.com/office/drawing/2014/main" id="{DFC09D55-2B83-8E37-8C4B-73C1102FFE8A}"/>
+                <a16:creationId xmlns:a16="http://schemas.microsoft.com/office/drawing/2014/main" id="{3A6B8D55-EA38-AAEA-F80B-2D6905738758}"/>
               </a:ext>
             </a:extLst>
           </p:cNvPr>
@@ -14760,7 +14760,7 @@
           <p:cNvPr id="14" name="矩形: 圆角 13">
             <a:extLst>
               <a:ext uri="{FF2B5EF4-FFF2-40B4-BE49-F238E27FC236}">
-                <a16:creationId xmlns:a16="http://schemas.microsoft.com/office/drawing/2014/main" id="{53F6AE69-620C-B027-0DB4-6D818F3C1ABD}"/>
+                <a16:creationId xmlns:a16="http://schemas.microsoft.com/office/drawing/2014/main" id="{B916A5AC-7F77-75DD-75FB-402E48ABC1DF}"/>
               </a:ext>
             </a:extLst>
           </p:cNvPr>
@@ -14822,7 +14822,7 @@
           <p:cNvPr id="15" name="矩形: 圆角 14">
             <a:extLst>
               <a:ext uri="{FF2B5EF4-FFF2-40B4-BE49-F238E27FC236}">
-                <a16:creationId xmlns:a16="http://schemas.microsoft.com/office/drawing/2014/main" id="{072A8661-A487-D17A-CFA1-3CECF2480107}"/>
+                <a16:creationId xmlns:a16="http://schemas.microsoft.com/office/drawing/2014/main" id="{CC4F40D1-89D2-F2CC-E66D-A2AD6D1912F2}"/>
               </a:ext>
             </a:extLst>
           </p:cNvPr>
@@ -14899,7 +14899,7 @@
           <p:cNvPr id="16" name="矩形: 圆角 15">
             <a:extLst>
               <a:ext uri="{FF2B5EF4-FFF2-40B4-BE49-F238E27FC236}">
-                <a16:creationId xmlns:a16="http://schemas.microsoft.com/office/drawing/2014/main" id="{DB06E10F-01AF-F793-55D8-30DF975A814D}"/>
+                <a16:creationId xmlns:a16="http://schemas.microsoft.com/office/drawing/2014/main" id="{63E7C6DE-504D-E36A-B1D5-32E0B90D4995}"/>
               </a:ext>
             </a:extLst>
           </p:cNvPr>
@@ -14961,7 +14961,7 @@
           <p:cNvPr id="17" name="文本框 16">
             <a:extLst>
               <a:ext uri="{FF2B5EF4-FFF2-40B4-BE49-F238E27FC236}">
-                <a16:creationId xmlns:a16="http://schemas.microsoft.com/office/drawing/2014/main" id="{E9C13F2D-F3CE-B251-98C5-88E6CAB41F11}"/>
+                <a16:creationId xmlns:a16="http://schemas.microsoft.com/office/drawing/2014/main" id="{2776018D-12FE-EA6B-9142-4AF8C2393208}"/>
               </a:ext>
             </a:extLst>
           </p:cNvPr>
@@ -15008,7 +15008,7 @@
           <p:cNvPr id="18" name="矩形: 圆角 17">
             <a:extLst>
               <a:ext uri="{FF2B5EF4-FFF2-40B4-BE49-F238E27FC236}">
-                <a16:creationId xmlns:a16="http://schemas.microsoft.com/office/drawing/2014/main" id="{2E7146E6-1467-70BB-A666-B2569CBEF283}"/>
+                <a16:creationId xmlns:a16="http://schemas.microsoft.com/office/drawing/2014/main" id="{2BBB5FB2-892F-088C-2E67-B3B84DF79813}"/>
               </a:ext>
             </a:extLst>
           </p:cNvPr>
@@ -15070,7 +15070,7 @@
           <p:cNvPr id="19" name="文本框 18">
             <a:extLst>
               <a:ext uri="{FF2B5EF4-FFF2-40B4-BE49-F238E27FC236}">
-                <a16:creationId xmlns:a16="http://schemas.microsoft.com/office/drawing/2014/main" id="{B260A40D-0B7B-021D-484E-9CFC778453E6}"/>
+                <a16:creationId xmlns:a16="http://schemas.microsoft.com/office/drawing/2014/main" id="{4796AA4D-E1B4-8AE5-322F-2613EA71B518}"/>
               </a:ext>
             </a:extLst>
           </p:cNvPr>
@@ -15117,7 +15117,7 @@
           <p:cNvPr id="20" name="矩形: 圆角 19">
             <a:extLst>
               <a:ext uri="{FF2B5EF4-FFF2-40B4-BE49-F238E27FC236}">
-                <a16:creationId xmlns:a16="http://schemas.microsoft.com/office/drawing/2014/main" id="{7890C9C4-1AE6-5EFF-14A6-A15D18E355B3}"/>
+                <a16:creationId xmlns:a16="http://schemas.microsoft.com/office/drawing/2014/main" id="{CD939DCB-F33A-2C01-B619-80F29D6C3380}"/>
               </a:ext>
             </a:extLst>
           </p:cNvPr>
@@ -15179,7 +15179,7 @@
           <p:cNvPr id="21" name="文本框 20">
             <a:extLst>
               <a:ext uri="{FF2B5EF4-FFF2-40B4-BE49-F238E27FC236}">
-                <a16:creationId xmlns:a16="http://schemas.microsoft.com/office/drawing/2014/main" id="{447C5875-1E3D-526E-3267-8AE90249075C}"/>
+                <a16:creationId xmlns:a16="http://schemas.microsoft.com/office/drawing/2014/main" id="{6EE85CDA-607E-3947-40C0-9B483D228E6A}"/>
               </a:ext>
             </a:extLst>
           </p:cNvPr>
@@ -15226,7 +15226,7 @@
           <p:cNvPr id="22" name="矩形: 圆角 21">
             <a:extLst>
               <a:ext uri="{FF2B5EF4-FFF2-40B4-BE49-F238E27FC236}">
-                <a16:creationId xmlns:a16="http://schemas.microsoft.com/office/drawing/2014/main" id="{6019AE57-97CC-56AB-A6F0-8F0C2AB88A42}"/>
+                <a16:creationId xmlns:a16="http://schemas.microsoft.com/office/drawing/2014/main" id="{5CFF501D-D648-398A-4742-7EB3034B9B6E}"/>
               </a:ext>
             </a:extLst>
           </p:cNvPr>
@@ -15288,7 +15288,7 @@
           <p:cNvPr id="23" name="文本框 22">
             <a:extLst>
               <a:ext uri="{FF2B5EF4-FFF2-40B4-BE49-F238E27FC236}">
-                <a16:creationId xmlns:a16="http://schemas.microsoft.com/office/drawing/2014/main" id="{3E836B7E-ED5A-C8BE-FA6B-4F26C0974542}"/>
+                <a16:creationId xmlns:a16="http://schemas.microsoft.com/office/drawing/2014/main" id="{71882751-FF59-21E3-C602-16617A14CC2C}"/>
               </a:ext>
             </a:extLst>
           </p:cNvPr>
@@ -15335,7 +15335,7 @@
           <p:cNvPr id="24" name="矩形: 圆角 23">
             <a:extLst>
               <a:ext uri="{FF2B5EF4-FFF2-40B4-BE49-F238E27FC236}">
-                <a16:creationId xmlns:a16="http://schemas.microsoft.com/office/drawing/2014/main" id="{36AF84E5-8C7D-65C8-C12A-A0A014DF3489}"/>
+                <a16:creationId xmlns:a16="http://schemas.microsoft.com/office/drawing/2014/main" id="{7F02F620-F5F9-8D02-A8F3-78798ABB8409}"/>
               </a:ext>
             </a:extLst>
           </p:cNvPr>
@@ -15395,7 +15395,7 @@
     </p:spTree>
     <p:extLst>
       <p:ext uri="{BB962C8B-B14F-4D97-AF65-F5344CB8AC3E}">
-        <p14:creationId xmlns:p14="http://schemas.microsoft.com/office/powerpoint/2010/main" val="1698543353"/>
+        <p14:creationId xmlns:p14="http://schemas.microsoft.com/office/powerpoint/2010/main" val="2303013851"/>
       </p:ext>
     </p:extLst>
   </p:cSld>
@@ -15427,7 +15427,7 @@
           <p:cNvPr id="2" name="矩形 1">
             <a:extLst>
               <a:ext uri="{FF2B5EF4-FFF2-40B4-BE49-F238E27FC236}">
-                <a16:creationId xmlns:a16="http://schemas.microsoft.com/office/drawing/2014/main" id="{C2DD82D5-8DB7-3B41-E73E-5EA7D9BBE2EF}"/>
+                <a16:creationId xmlns:a16="http://schemas.microsoft.com/office/drawing/2014/main" id="{204C2640-8C58-701D-55C9-051952B7B2C8}"/>
               </a:ext>
             </a:extLst>
           </p:cNvPr>
@@ -15481,7 +15481,7 @@
           <p:cNvPr id="3" name="矩形 2">
             <a:extLst>
               <a:ext uri="{FF2B5EF4-FFF2-40B4-BE49-F238E27FC236}">
-                <a16:creationId xmlns:a16="http://schemas.microsoft.com/office/drawing/2014/main" id="{DF29530C-1F06-ED1F-AD00-F61B97B2B734}"/>
+                <a16:creationId xmlns:a16="http://schemas.microsoft.com/office/drawing/2014/main" id="{B16CDDB7-5A4B-3EC3-C910-D354A28C7B4F}"/>
               </a:ext>
             </a:extLst>
           </p:cNvPr>
@@ -15535,7 +15535,7 @@
           <p:cNvPr id="4" name="矩形 3">
             <a:extLst>
               <a:ext uri="{FF2B5EF4-FFF2-40B4-BE49-F238E27FC236}">
-                <a16:creationId xmlns:a16="http://schemas.microsoft.com/office/drawing/2014/main" id="{DA8D2977-E2F6-D45B-7280-5E2E5F48A596}"/>
+                <a16:creationId xmlns:a16="http://schemas.microsoft.com/office/drawing/2014/main" id="{B737596F-5339-1149-6C97-4E57D33EE612}"/>
               </a:ext>
             </a:extLst>
           </p:cNvPr>
@@ -15589,7 +15589,7 @@
           <p:cNvPr id="5" name="文本框 4">
             <a:extLst>
               <a:ext uri="{FF2B5EF4-FFF2-40B4-BE49-F238E27FC236}">
-                <a16:creationId xmlns:a16="http://schemas.microsoft.com/office/drawing/2014/main" id="{391E46AA-62CF-1EFC-DAF9-705EBCEB81EF}"/>
+                <a16:creationId xmlns:a16="http://schemas.microsoft.com/office/drawing/2014/main" id="{5E5620CD-99BC-897F-87D0-2ABEFD60A02B}"/>
               </a:ext>
             </a:extLst>
           </p:cNvPr>
@@ -15629,7 +15629,7 @@
           <p:cNvPr id="6" name="文本框 5">
             <a:extLst>
               <a:ext uri="{FF2B5EF4-FFF2-40B4-BE49-F238E27FC236}">
-                <a16:creationId xmlns:a16="http://schemas.microsoft.com/office/drawing/2014/main" id="{B559A0F8-F7F5-D7F5-3359-5DAFFC6111EB}"/>
+                <a16:creationId xmlns:a16="http://schemas.microsoft.com/office/drawing/2014/main" id="{EBB0F223-5462-ABC4-E7E1-B2A16F2CF35C}"/>
               </a:ext>
             </a:extLst>
           </p:cNvPr>
@@ -15676,7 +15676,7 @@
           <p:cNvPr id="7" name="文本框 6">
             <a:extLst>
               <a:ext uri="{FF2B5EF4-FFF2-40B4-BE49-F238E27FC236}">
-                <a16:creationId xmlns:a16="http://schemas.microsoft.com/office/drawing/2014/main" id="{6E81F967-9D1C-B88A-2276-2625B109BE66}"/>
+                <a16:creationId xmlns:a16="http://schemas.microsoft.com/office/drawing/2014/main" id="{99FFF895-B476-E1BE-CB16-8078FDE99FD9}"/>
               </a:ext>
             </a:extLst>
           </p:cNvPr>
@@ -15716,7 +15716,7 @@
           <p:cNvPr id="8" name="矩形: 圆角 7">
             <a:extLst>
               <a:ext uri="{FF2B5EF4-FFF2-40B4-BE49-F238E27FC236}">
-                <a16:creationId xmlns:a16="http://schemas.microsoft.com/office/drawing/2014/main" id="{8D7A5063-97C4-1248-4440-3631C8E15160}"/>
+                <a16:creationId xmlns:a16="http://schemas.microsoft.com/office/drawing/2014/main" id="{A5FC47E3-5AC6-C3BF-A056-7F4CDF812B7E}"/>
               </a:ext>
             </a:extLst>
           </p:cNvPr>
@@ -15787,7 +15787,7 @@
           <p:cNvPr id="9" name="矩形: 圆角 8">
             <a:extLst>
               <a:ext uri="{FF2B5EF4-FFF2-40B4-BE49-F238E27FC236}">
-                <a16:creationId xmlns:a16="http://schemas.microsoft.com/office/drawing/2014/main" id="{5DE843AF-60CB-0F3D-728D-7DC6745AAC0A}"/>
+                <a16:creationId xmlns:a16="http://schemas.microsoft.com/office/drawing/2014/main" id="{6BE435D4-B095-BFEB-73B7-C20BA5C717E8}"/>
               </a:ext>
             </a:extLst>
           </p:cNvPr>
@@ -15849,7 +15849,7 @@
           <p:cNvPr id="10" name="矩形: 圆角 9">
             <a:extLst>
               <a:ext uri="{FF2B5EF4-FFF2-40B4-BE49-F238E27FC236}">
-                <a16:creationId xmlns:a16="http://schemas.microsoft.com/office/drawing/2014/main" id="{E389DC9A-E733-590E-7880-D660D9D682D9}"/>
+                <a16:creationId xmlns:a16="http://schemas.microsoft.com/office/drawing/2014/main" id="{B2AE3D8A-DF6A-FE80-55AE-CA727BBF92ED}"/>
               </a:ext>
             </a:extLst>
           </p:cNvPr>
@@ -15965,7 +15965,7 @@
           <p:cNvPr id="11" name="矩形: 圆角 10">
             <a:extLst>
               <a:ext uri="{FF2B5EF4-FFF2-40B4-BE49-F238E27FC236}">
-                <a16:creationId xmlns:a16="http://schemas.microsoft.com/office/drawing/2014/main" id="{710D2C95-0E57-4EBE-91D0-373ADE35C176}"/>
+                <a16:creationId xmlns:a16="http://schemas.microsoft.com/office/drawing/2014/main" id="{70077585-A5F7-4D11-55EA-0ED8C08DCD5B}"/>
               </a:ext>
             </a:extLst>
           </p:cNvPr>
@@ -16027,7 +16027,7 @@
           <p:cNvPr id="12" name="矩形: 圆角 11">
             <a:extLst>
               <a:ext uri="{FF2B5EF4-FFF2-40B4-BE49-F238E27FC236}">
-                <a16:creationId xmlns:a16="http://schemas.microsoft.com/office/drawing/2014/main" id="{61B51659-B39E-B966-7E8C-D139EA40AAD5}"/>
+                <a16:creationId xmlns:a16="http://schemas.microsoft.com/office/drawing/2014/main" id="{97E22ADA-9CF0-9566-2BF3-859E1D5DD6C9}"/>
               </a:ext>
             </a:extLst>
           </p:cNvPr>
@@ -16122,7 +16122,7 @@
           <p:cNvPr id="13" name="矩形: 圆角 12">
             <a:extLst>
               <a:ext uri="{FF2B5EF4-FFF2-40B4-BE49-F238E27FC236}">
-                <a16:creationId xmlns:a16="http://schemas.microsoft.com/office/drawing/2014/main" id="{35027F12-CC2C-E307-766C-35F43548E97B}"/>
+                <a16:creationId xmlns:a16="http://schemas.microsoft.com/office/drawing/2014/main" id="{1C1D19B7-C959-299C-BC5E-432781AA72FE}"/>
               </a:ext>
             </a:extLst>
           </p:cNvPr>
@@ -16184,7 +16184,7 @@
           <p:cNvPr id="14" name="矩形: 圆角 13">
             <a:extLst>
               <a:ext uri="{FF2B5EF4-FFF2-40B4-BE49-F238E27FC236}">
-                <a16:creationId xmlns:a16="http://schemas.microsoft.com/office/drawing/2014/main" id="{F3998BBD-89F8-F3B4-DB15-D1924B87B570}"/>
+                <a16:creationId xmlns:a16="http://schemas.microsoft.com/office/drawing/2014/main" id="{ADC11F14-93A0-0B3D-0B9B-846F7D656960}"/>
               </a:ext>
             </a:extLst>
           </p:cNvPr>
@@ -16279,7 +16279,7 @@
           <p:cNvPr id="15" name="矩形: 圆角 14">
             <a:extLst>
               <a:ext uri="{FF2B5EF4-FFF2-40B4-BE49-F238E27FC236}">
-                <a16:creationId xmlns:a16="http://schemas.microsoft.com/office/drawing/2014/main" id="{CE390067-2D6F-FFF8-A0A0-E104AA247072}"/>
+                <a16:creationId xmlns:a16="http://schemas.microsoft.com/office/drawing/2014/main" id="{64703367-D1E1-DE6F-09F4-8E9A11EB039C}"/>
               </a:ext>
             </a:extLst>
           </p:cNvPr>
@@ -16341,7 +16341,7 @@
           <p:cNvPr id="16" name="矩形: 圆角 15">
             <a:extLst>
               <a:ext uri="{FF2B5EF4-FFF2-40B4-BE49-F238E27FC236}">
-                <a16:creationId xmlns:a16="http://schemas.microsoft.com/office/drawing/2014/main" id="{40C8ECD2-0C48-9290-AAA4-CE57253C5185}"/>
+                <a16:creationId xmlns:a16="http://schemas.microsoft.com/office/drawing/2014/main" id="{0B166831-2576-F03D-194B-2916FDC87EAF}"/>
               </a:ext>
             </a:extLst>
           </p:cNvPr>
@@ -16419,7 +16419,7 @@
     </p:spTree>
     <p:extLst>
       <p:ext uri="{BB962C8B-B14F-4D97-AF65-F5344CB8AC3E}">
-        <p14:creationId xmlns:p14="http://schemas.microsoft.com/office/powerpoint/2010/main" val="2048422869"/>
+        <p14:creationId xmlns:p14="http://schemas.microsoft.com/office/powerpoint/2010/main" val="4171671995"/>
       </p:ext>
     </p:extLst>
   </p:cSld>
@@ -16451,7 +16451,7 @@
           <p:cNvPr id="2" name="矩形 1">
             <a:extLst>
               <a:ext uri="{FF2B5EF4-FFF2-40B4-BE49-F238E27FC236}">
-                <a16:creationId xmlns:a16="http://schemas.microsoft.com/office/drawing/2014/main" id="{F048C080-2990-A098-21CE-3C320ED9B697}"/>
+                <a16:creationId xmlns:a16="http://schemas.microsoft.com/office/drawing/2014/main" id="{D95A1A8D-F3CE-8A85-54EA-5744C268BCA1}"/>
               </a:ext>
             </a:extLst>
           </p:cNvPr>
@@ -16505,7 +16505,7 @@
           <p:cNvPr id="3" name="矩形 2">
             <a:extLst>
               <a:ext uri="{FF2B5EF4-FFF2-40B4-BE49-F238E27FC236}">
-                <a16:creationId xmlns:a16="http://schemas.microsoft.com/office/drawing/2014/main" id="{B0C189B0-E30A-714E-2584-B86929D090FB}"/>
+                <a16:creationId xmlns:a16="http://schemas.microsoft.com/office/drawing/2014/main" id="{DD2E92AF-A16F-487B-3A8C-7E5CC6F68B1A}"/>
               </a:ext>
             </a:extLst>
           </p:cNvPr>
@@ -16559,7 +16559,7 @@
           <p:cNvPr id="4" name="矩形 3">
             <a:extLst>
               <a:ext uri="{FF2B5EF4-FFF2-40B4-BE49-F238E27FC236}">
-                <a16:creationId xmlns:a16="http://schemas.microsoft.com/office/drawing/2014/main" id="{D8BF5BFD-F0DA-EFED-54C9-1745505E888D}"/>
+                <a16:creationId xmlns:a16="http://schemas.microsoft.com/office/drawing/2014/main" id="{E503D659-325D-D81D-A05D-BB48EDDE059D}"/>
               </a:ext>
             </a:extLst>
           </p:cNvPr>
@@ -16613,7 +16613,7 @@
           <p:cNvPr id="5" name="文本框 4">
             <a:extLst>
               <a:ext uri="{FF2B5EF4-FFF2-40B4-BE49-F238E27FC236}">
-                <a16:creationId xmlns:a16="http://schemas.microsoft.com/office/drawing/2014/main" id="{0D25A788-ED5F-3E41-BEBE-A25E2348A1C2}"/>
+                <a16:creationId xmlns:a16="http://schemas.microsoft.com/office/drawing/2014/main" id="{007BCAE0-A3D7-91FE-9548-8DB65A348A1E}"/>
               </a:ext>
             </a:extLst>
           </p:cNvPr>
@@ -16653,7 +16653,7 @@
           <p:cNvPr id="6" name="文本框 5">
             <a:extLst>
               <a:ext uri="{FF2B5EF4-FFF2-40B4-BE49-F238E27FC236}">
-                <a16:creationId xmlns:a16="http://schemas.microsoft.com/office/drawing/2014/main" id="{1DB5863E-84AC-F138-9078-A11F9902B78A}"/>
+                <a16:creationId xmlns:a16="http://schemas.microsoft.com/office/drawing/2014/main" id="{83FD063C-826A-0468-D4EC-B6134CD1C1C5}"/>
               </a:ext>
             </a:extLst>
           </p:cNvPr>
@@ -16700,7 +16700,7 @@
           <p:cNvPr id="7" name="文本框 6">
             <a:extLst>
               <a:ext uri="{FF2B5EF4-FFF2-40B4-BE49-F238E27FC236}">
-                <a16:creationId xmlns:a16="http://schemas.microsoft.com/office/drawing/2014/main" id="{E76CEA43-50B7-A70B-86DB-0E6FB45E65B1}"/>
+                <a16:creationId xmlns:a16="http://schemas.microsoft.com/office/drawing/2014/main" id="{C3669C74-E420-2222-6799-B26A811EFB6C}"/>
               </a:ext>
             </a:extLst>
           </p:cNvPr>
@@ -16758,7 +16758,7 @@
           <p:cNvPr id="8" name="矩形: 圆角 7">
             <a:extLst>
               <a:ext uri="{FF2B5EF4-FFF2-40B4-BE49-F238E27FC236}">
-                <a16:creationId xmlns:a16="http://schemas.microsoft.com/office/drawing/2014/main" id="{5E935D74-4C2C-D115-3F5B-CE3DABE5DDA0}"/>
+                <a16:creationId xmlns:a16="http://schemas.microsoft.com/office/drawing/2014/main" id="{A48F1912-0C88-A238-A884-67BA39E6E07A}"/>
               </a:ext>
             </a:extLst>
           </p:cNvPr>
@@ -16820,7 +16820,7 @@
           <p:cNvPr id="9" name="文本框 8">
             <a:extLst>
               <a:ext uri="{FF2B5EF4-FFF2-40B4-BE49-F238E27FC236}">
-                <a16:creationId xmlns:a16="http://schemas.microsoft.com/office/drawing/2014/main" id="{637983ED-D64F-A578-9611-EE9E38970046}"/>
+                <a16:creationId xmlns:a16="http://schemas.microsoft.com/office/drawing/2014/main" id="{7F004278-5891-E156-B6A7-32F2918CCC11}"/>
               </a:ext>
             </a:extLst>
           </p:cNvPr>
@@ -16867,7 +16867,7 @@
           <p:cNvPr id="10" name="矩形: 圆角 9">
             <a:extLst>
               <a:ext uri="{FF2B5EF4-FFF2-40B4-BE49-F238E27FC236}">
-                <a16:creationId xmlns:a16="http://schemas.microsoft.com/office/drawing/2014/main" id="{9EB280CF-6BFC-E7C5-39EB-1143C4DE39AD}"/>
+                <a16:creationId xmlns:a16="http://schemas.microsoft.com/office/drawing/2014/main" id="{DF03EFE8-C50D-2534-0986-D6F68A875C38}"/>
               </a:ext>
             </a:extLst>
           </p:cNvPr>
@@ -16929,7 +16929,7 @@
           <p:cNvPr id="11" name="文本框 10">
             <a:extLst>
               <a:ext uri="{FF2B5EF4-FFF2-40B4-BE49-F238E27FC236}">
-                <a16:creationId xmlns:a16="http://schemas.microsoft.com/office/drawing/2014/main" id="{90E4AEB0-3AFF-15A7-C23C-74EA0224557F}"/>
+                <a16:creationId xmlns:a16="http://schemas.microsoft.com/office/drawing/2014/main" id="{66674EBD-F5E2-E5FC-7EDD-026E075C88E8}"/>
               </a:ext>
             </a:extLst>
           </p:cNvPr>
@@ -16976,7 +16976,7 @@
           <p:cNvPr id="12" name="矩形: 圆角 11">
             <a:extLst>
               <a:ext uri="{FF2B5EF4-FFF2-40B4-BE49-F238E27FC236}">
-                <a16:creationId xmlns:a16="http://schemas.microsoft.com/office/drawing/2014/main" id="{D036D0CC-2BE9-2B89-6084-1A9BEB1CA3D6}"/>
+                <a16:creationId xmlns:a16="http://schemas.microsoft.com/office/drawing/2014/main" id="{A9A9C059-05C4-A9D8-30F4-222A713DE21F}"/>
               </a:ext>
             </a:extLst>
           </p:cNvPr>
@@ -17053,7 +17053,7 @@
           <p:cNvPr id="13" name="文本框 12">
             <a:extLst>
               <a:ext uri="{FF2B5EF4-FFF2-40B4-BE49-F238E27FC236}">
-                <a16:creationId xmlns:a16="http://schemas.microsoft.com/office/drawing/2014/main" id="{5DA4028F-4B8C-B79E-F8F8-905FD800D893}"/>
+                <a16:creationId xmlns:a16="http://schemas.microsoft.com/office/drawing/2014/main" id="{B8EC16CC-8C79-08B3-3733-30F55A6E6D8A}"/>
               </a:ext>
             </a:extLst>
           </p:cNvPr>
@@ -17100,7 +17100,7 @@
           <p:cNvPr id="14" name="矩形: 圆角 13">
             <a:extLst>
               <a:ext uri="{FF2B5EF4-FFF2-40B4-BE49-F238E27FC236}">
-                <a16:creationId xmlns:a16="http://schemas.microsoft.com/office/drawing/2014/main" id="{16BD6A9A-5B88-46D0-C2BC-FA68C03EB12F}"/>
+                <a16:creationId xmlns:a16="http://schemas.microsoft.com/office/drawing/2014/main" id="{9755081E-A9D7-A660-1C96-524A514640D4}"/>
               </a:ext>
             </a:extLst>
           </p:cNvPr>
@@ -17171,7 +17171,7 @@
           <p:cNvPr id="15" name="文本框 14">
             <a:extLst>
               <a:ext uri="{FF2B5EF4-FFF2-40B4-BE49-F238E27FC236}">
-                <a16:creationId xmlns:a16="http://schemas.microsoft.com/office/drawing/2014/main" id="{2F11D09F-B762-D2AA-16E1-37941B1278D0}"/>
+                <a16:creationId xmlns:a16="http://schemas.microsoft.com/office/drawing/2014/main" id="{39586D7A-135C-EE3C-CDCC-8E59BC3B8B65}"/>
               </a:ext>
             </a:extLst>
           </p:cNvPr>
@@ -17218,7 +17218,7 @@
           <p:cNvPr id="16" name="矩形: 圆角 15">
             <a:extLst>
               <a:ext uri="{FF2B5EF4-FFF2-40B4-BE49-F238E27FC236}">
-                <a16:creationId xmlns:a16="http://schemas.microsoft.com/office/drawing/2014/main" id="{C92C179D-75FF-58E2-F570-EAD0B5724C51}"/>
+                <a16:creationId xmlns:a16="http://schemas.microsoft.com/office/drawing/2014/main" id="{9CF5707B-D012-7DF8-F619-23D2F1C5835C}"/>
               </a:ext>
             </a:extLst>
           </p:cNvPr>
@@ -17298,7 +17298,7 @@
           <p:cNvPr id="17" name="文本框 16">
             <a:extLst>
               <a:ext uri="{FF2B5EF4-FFF2-40B4-BE49-F238E27FC236}">
-                <a16:creationId xmlns:a16="http://schemas.microsoft.com/office/drawing/2014/main" id="{36677F0C-B5EC-826E-5743-FCF03779BA87}"/>
+                <a16:creationId xmlns:a16="http://schemas.microsoft.com/office/drawing/2014/main" id="{1A445AB6-E66A-52B5-4DAE-DBD094BA5BC0}"/>
               </a:ext>
             </a:extLst>
           </p:cNvPr>
@@ -17345,7 +17345,7 @@
           <p:cNvPr id="18" name="矩形: 圆角 17">
             <a:extLst>
               <a:ext uri="{FF2B5EF4-FFF2-40B4-BE49-F238E27FC236}">
-                <a16:creationId xmlns:a16="http://schemas.microsoft.com/office/drawing/2014/main" id="{A00196DC-BEE3-D176-59E3-0DD07ABEEBE7}"/>
+                <a16:creationId xmlns:a16="http://schemas.microsoft.com/office/drawing/2014/main" id="{2D28FDD7-F2A0-14A1-0D2D-EDCF8C0F6E98}"/>
               </a:ext>
             </a:extLst>
           </p:cNvPr>
@@ -17407,7 +17407,7 @@
           <p:cNvPr id="19" name="矩形: 圆角 18">
             <a:extLst>
               <a:ext uri="{FF2B5EF4-FFF2-40B4-BE49-F238E27FC236}">
-                <a16:creationId xmlns:a16="http://schemas.microsoft.com/office/drawing/2014/main" id="{7459C7F2-0A48-B88C-2173-4584BA1D77EC}"/>
+                <a16:creationId xmlns:a16="http://schemas.microsoft.com/office/drawing/2014/main" id="{8DB600EA-B45D-FA09-54B3-2DEB75324824}"/>
               </a:ext>
             </a:extLst>
           </p:cNvPr>
@@ -17488,7 +17488,7 @@
     </p:spTree>
     <p:extLst>
       <p:ext uri="{BB962C8B-B14F-4D97-AF65-F5344CB8AC3E}">
-        <p14:creationId xmlns:p14="http://schemas.microsoft.com/office/powerpoint/2010/main" val="582548579"/>
+        <p14:creationId xmlns:p14="http://schemas.microsoft.com/office/powerpoint/2010/main" val="1576216926"/>
       </p:ext>
     </p:extLst>
   </p:cSld>
@@ -17520,7 +17520,7 @@
           <p:cNvPr id="2" name="矩形 1">
             <a:extLst>
               <a:ext uri="{FF2B5EF4-FFF2-40B4-BE49-F238E27FC236}">
-                <a16:creationId xmlns:a16="http://schemas.microsoft.com/office/drawing/2014/main" id="{5797DBF7-C6BF-E57D-3DC0-1B7C7678D788}"/>
+                <a16:creationId xmlns:a16="http://schemas.microsoft.com/office/drawing/2014/main" id="{2B26D736-F528-1E99-0BA0-FE832244F035}"/>
               </a:ext>
             </a:extLst>
           </p:cNvPr>
@@ -17574,7 +17574,7 @@
           <p:cNvPr id="3" name="矩形 2">
             <a:extLst>
               <a:ext uri="{FF2B5EF4-FFF2-40B4-BE49-F238E27FC236}">
-                <a16:creationId xmlns:a16="http://schemas.microsoft.com/office/drawing/2014/main" id="{2BAF8B06-5681-AE7E-D334-53FE91C22380}"/>
+                <a16:creationId xmlns:a16="http://schemas.microsoft.com/office/drawing/2014/main" id="{5E4EDAF9-9B64-2A8D-6F49-681D87A52CB2}"/>
               </a:ext>
             </a:extLst>
           </p:cNvPr>
@@ -17628,7 +17628,7 @@
           <p:cNvPr id="4" name="矩形 3">
             <a:extLst>
               <a:ext uri="{FF2B5EF4-FFF2-40B4-BE49-F238E27FC236}">
-                <a16:creationId xmlns:a16="http://schemas.microsoft.com/office/drawing/2014/main" id="{FD034EBD-5C3B-6566-06C1-A2A5E137E9A0}"/>
+                <a16:creationId xmlns:a16="http://schemas.microsoft.com/office/drawing/2014/main" id="{7B7A15BD-72C2-3894-2062-83CE46C5BA04}"/>
               </a:ext>
             </a:extLst>
           </p:cNvPr>
@@ -17682,7 +17682,7 @@
           <p:cNvPr id="5" name="文本框 4">
             <a:extLst>
               <a:ext uri="{FF2B5EF4-FFF2-40B4-BE49-F238E27FC236}">
-                <a16:creationId xmlns:a16="http://schemas.microsoft.com/office/drawing/2014/main" id="{2EF9EC36-3FDA-F4A6-A796-A29FABFA3D1D}"/>
+                <a16:creationId xmlns:a16="http://schemas.microsoft.com/office/drawing/2014/main" id="{9F9D1EDC-D705-EE81-A5F4-10F5C9B235B8}"/>
               </a:ext>
             </a:extLst>
           </p:cNvPr>
@@ -17731,7 +17731,7 @@
           <p:cNvPr id="6" name="文本框 5">
             <a:extLst>
               <a:ext uri="{FF2B5EF4-FFF2-40B4-BE49-F238E27FC236}">
-                <a16:creationId xmlns:a16="http://schemas.microsoft.com/office/drawing/2014/main" id="{BDB931A5-AC89-BEB7-8E3E-795B2BFD4878}"/>
+                <a16:creationId xmlns:a16="http://schemas.microsoft.com/office/drawing/2014/main" id="{A66E4435-8AC5-A22D-3DF3-C9CCF6D0BECE}"/>
               </a:ext>
             </a:extLst>
           </p:cNvPr>
@@ -17778,7 +17778,7 @@
           <p:cNvPr id="7" name="文本框 6">
             <a:extLst>
               <a:ext uri="{FF2B5EF4-FFF2-40B4-BE49-F238E27FC236}">
-                <a16:creationId xmlns:a16="http://schemas.microsoft.com/office/drawing/2014/main" id="{430178FE-8494-0D58-0391-554C05EFF4EE}"/>
+                <a16:creationId xmlns:a16="http://schemas.microsoft.com/office/drawing/2014/main" id="{FF2DA455-339F-F89D-35F1-CC7ACE6A56B2}"/>
               </a:ext>
             </a:extLst>
           </p:cNvPr>
@@ -17845,7 +17845,7 @@
           <p:cNvPr id="8" name="矩形: 圆角 7">
             <a:extLst>
               <a:ext uri="{FF2B5EF4-FFF2-40B4-BE49-F238E27FC236}">
-                <a16:creationId xmlns:a16="http://schemas.microsoft.com/office/drawing/2014/main" id="{00E13656-9DAE-7ABF-ACB2-0DBD73997DDC}"/>
+                <a16:creationId xmlns:a16="http://schemas.microsoft.com/office/drawing/2014/main" id="{461BE647-4FE7-C281-DB50-97EB17F63CE4}"/>
               </a:ext>
             </a:extLst>
           </p:cNvPr>
@@ -17899,7 +17899,7 @@
           <p:cNvPr id="9" name="文本框 8">
             <a:extLst>
               <a:ext uri="{FF2B5EF4-FFF2-40B4-BE49-F238E27FC236}">
-                <a16:creationId xmlns:a16="http://schemas.microsoft.com/office/drawing/2014/main" id="{1137ADC4-1423-F9EB-A693-2296BB9CCF80}"/>
+                <a16:creationId xmlns:a16="http://schemas.microsoft.com/office/drawing/2014/main" id="{9A50F954-0D25-0B4C-F532-F0E5733E640C}"/>
               </a:ext>
             </a:extLst>
           </p:cNvPr>
@@ -17940,7 +17940,7 @@
           <p:cNvPr id="10" name="矩形: 圆角 9">
             <a:extLst>
               <a:ext uri="{FF2B5EF4-FFF2-40B4-BE49-F238E27FC236}">
-                <a16:creationId xmlns:a16="http://schemas.microsoft.com/office/drawing/2014/main" id="{E42269B1-DDBD-2875-088B-90C0BD2596B6}"/>
+                <a16:creationId xmlns:a16="http://schemas.microsoft.com/office/drawing/2014/main" id="{67DF412A-F5D9-99D1-4255-926EEB610608}"/>
               </a:ext>
             </a:extLst>
           </p:cNvPr>
@@ -17994,7 +17994,7 @@
           <p:cNvPr id="11" name="文本框 10">
             <a:extLst>
               <a:ext uri="{FF2B5EF4-FFF2-40B4-BE49-F238E27FC236}">
-                <a16:creationId xmlns:a16="http://schemas.microsoft.com/office/drawing/2014/main" id="{8E4D7B98-4A4A-5D92-6A51-871D585061B3}"/>
+                <a16:creationId xmlns:a16="http://schemas.microsoft.com/office/drawing/2014/main" id="{768FF874-9E11-C022-0B53-79DF5881AC84}"/>
               </a:ext>
             </a:extLst>
           </p:cNvPr>
@@ -18035,7 +18035,7 @@
           <p:cNvPr id="12" name="矩形: 圆角 11">
             <a:extLst>
               <a:ext uri="{FF2B5EF4-FFF2-40B4-BE49-F238E27FC236}">
-                <a16:creationId xmlns:a16="http://schemas.microsoft.com/office/drawing/2014/main" id="{CDCB650E-67FC-350A-8CF2-28AF1D56BF72}"/>
+                <a16:creationId xmlns:a16="http://schemas.microsoft.com/office/drawing/2014/main" id="{CFDD318B-52B1-EF29-FF0B-B732FA7DFB48}"/>
               </a:ext>
             </a:extLst>
           </p:cNvPr>
@@ -18089,7 +18089,7 @@
           <p:cNvPr id="13" name="文本框 12">
             <a:extLst>
               <a:ext uri="{FF2B5EF4-FFF2-40B4-BE49-F238E27FC236}">
-                <a16:creationId xmlns:a16="http://schemas.microsoft.com/office/drawing/2014/main" id="{82D22EDD-53A9-3052-9464-424D53AD1921}"/>
+                <a16:creationId xmlns:a16="http://schemas.microsoft.com/office/drawing/2014/main" id="{57B46CA5-A380-1A06-2EAD-85AB4DE1905F}"/>
               </a:ext>
             </a:extLst>
           </p:cNvPr>
@@ -18130,7 +18130,7 @@
           <p:cNvPr id="14" name="矩形: 圆角 13">
             <a:extLst>
               <a:ext uri="{FF2B5EF4-FFF2-40B4-BE49-F238E27FC236}">
-                <a16:creationId xmlns:a16="http://schemas.microsoft.com/office/drawing/2014/main" id="{F4AE2D3C-71C5-4128-EAA1-A3414C6A3258}"/>
+                <a16:creationId xmlns:a16="http://schemas.microsoft.com/office/drawing/2014/main" id="{04E8C5DA-C208-4CEC-E79E-D144EE22BAFE}"/>
               </a:ext>
             </a:extLst>
           </p:cNvPr>
@@ -18184,7 +18184,7 @@
           <p:cNvPr id="15" name="文本框 14">
             <a:extLst>
               <a:ext uri="{FF2B5EF4-FFF2-40B4-BE49-F238E27FC236}">
-                <a16:creationId xmlns:a16="http://schemas.microsoft.com/office/drawing/2014/main" id="{8D8C65D9-77C0-E6C2-4411-5D31BED12A8B}"/>
+                <a16:creationId xmlns:a16="http://schemas.microsoft.com/office/drawing/2014/main" id="{940066EF-4BC0-5193-9325-6195136BCC7A}"/>
               </a:ext>
             </a:extLst>
           </p:cNvPr>
@@ -18231,7 +18231,7 @@
           <p:cNvPr id="16" name="矩形: 圆角 15">
             <a:extLst>
               <a:ext uri="{FF2B5EF4-FFF2-40B4-BE49-F238E27FC236}">
-                <a16:creationId xmlns:a16="http://schemas.microsoft.com/office/drawing/2014/main" id="{E845404B-AA89-5075-4826-DD902AFD9518}"/>
+                <a16:creationId xmlns:a16="http://schemas.microsoft.com/office/drawing/2014/main" id="{768D47BE-FC98-EAAB-190F-E9FD81FBAC34}"/>
               </a:ext>
             </a:extLst>
           </p:cNvPr>
@@ -18285,7 +18285,7 @@
           <p:cNvPr id="17" name="文本框 16">
             <a:extLst>
               <a:ext uri="{FF2B5EF4-FFF2-40B4-BE49-F238E27FC236}">
-                <a16:creationId xmlns:a16="http://schemas.microsoft.com/office/drawing/2014/main" id="{A3193A8F-6F23-042B-9369-A02EF2B2CADA}"/>
+                <a16:creationId xmlns:a16="http://schemas.microsoft.com/office/drawing/2014/main" id="{FAA5C23C-C4C9-1FCF-67F2-F6C6CE62A1C8}"/>
               </a:ext>
             </a:extLst>
           </p:cNvPr>
@@ -18326,7 +18326,7 @@
           <p:cNvPr id="18" name="矩形: 圆角 17">
             <a:extLst>
               <a:ext uri="{FF2B5EF4-FFF2-40B4-BE49-F238E27FC236}">
-                <a16:creationId xmlns:a16="http://schemas.microsoft.com/office/drawing/2014/main" id="{D1591C9F-D7CD-7CC5-89FE-B61B19BFD9B8}"/>
+                <a16:creationId xmlns:a16="http://schemas.microsoft.com/office/drawing/2014/main" id="{874A5D80-00AF-7CE2-932F-CBC3172A5C1D}"/>
               </a:ext>
             </a:extLst>
           </p:cNvPr>
@@ -18380,7 +18380,7 @@
           <p:cNvPr id="19" name="文本框 18">
             <a:extLst>
               <a:ext uri="{FF2B5EF4-FFF2-40B4-BE49-F238E27FC236}">
-                <a16:creationId xmlns:a16="http://schemas.microsoft.com/office/drawing/2014/main" id="{7CE2D3D1-484C-DFCD-F612-395FABE659AF}"/>
+                <a16:creationId xmlns:a16="http://schemas.microsoft.com/office/drawing/2014/main" id="{0F81BA0B-1A4D-89B6-9462-F7F88EAAF75F}"/>
               </a:ext>
             </a:extLst>
           </p:cNvPr>
@@ -18427,7 +18427,7 @@
           <p:cNvPr id="20" name="矩形: 圆角 19">
             <a:extLst>
               <a:ext uri="{FF2B5EF4-FFF2-40B4-BE49-F238E27FC236}">
-                <a16:creationId xmlns:a16="http://schemas.microsoft.com/office/drawing/2014/main" id="{F5FFA4D3-A636-4227-7E6E-C83004E36D8E}"/>
+                <a16:creationId xmlns:a16="http://schemas.microsoft.com/office/drawing/2014/main" id="{4827E6A4-1456-DFE4-BD7E-C1A859AF15F9}"/>
               </a:ext>
             </a:extLst>
           </p:cNvPr>
@@ -18481,7 +18481,7 @@
           <p:cNvPr id="21" name="文本框 20">
             <a:extLst>
               <a:ext uri="{FF2B5EF4-FFF2-40B4-BE49-F238E27FC236}">
-                <a16:creationId xmlns:a16="http://schemas.microsoft.com/office/drawing/2014/main" id="{7F8527FC-9AC6-1A41-8E3B-3635F0676876}"/>
+                <a16:creationId xmlns:a16="http://schemas.microsoft.com/office/drawing/2014/main" id="{F1288EC8-8371-2710-EDA2-D18C5B547DDD}"/>
               </a:ext>
             </a:extLst>
           </p:cNvPr>
@@ -18528,7 +18528,7 @@
           <p:cNvPr id="22" name="矩形: 圆角 21">
             <a:extLst>
               <a:ext uri="{FF2B5EF4-FFF2-40B4-BE49-F238E27FC236}">
-                <a16:creationId xmlns:a16="http://schemas.microsoft.com/office/drawing/2014/main" id="{1B01C8A7-F845-0CAF-B237-B4C2DB1F352C}"/>
+                <a16:creationId xmlns:a16="http://schemas.microsoft.com/office/drawing/2014/main" id="{B77C74FE-F5AA-18F5-A332-52D4F5DAC123}"/>
               </a:ext>
             </a:extLst>
           </p:cNvPr>
@@ -18582,7 +18582,7 @@
           <p:cNvPr id="23" name="文本框 22">
             <a:extLst>
               <a:ext uri="{FF2B5EF4-FFF2-40B4-BE49-F238E27FC236}">
-                <a16:creationId xmlns:a16="http://schemas.microsoft.com/office/drawing/2014/main" id="{6837514C-38E9-137E-A9CB-F1F2D4E2BF89}"/>
+                <a16:creationId xmlns:a16="http://schemas.microsoft.com/office/drawing/2014/main" id="{2CFCC83F-1E73-275F-D99A-8739EE190FFC}"/>
               </a:ext>
             </a:extLst>
           </p:cNvPr>
@@ -18623,7 +18623,7 @@
           <p:cNvPr id="24" name="矩形: 圆角 23">
             <a:extLst>
               <a:ext uri="{FF2B5EF4-FFF2-40B4-BE49-F238E27FC236}">
-                <a16:creationId xmlns:a16="http://schemas.microsoft.com/office/drawing/2014/main" id="{23531F6C-5CCD-5601-76C6-F65C19ECBBE4}"/>
+                <a16:creationId xmlns:a16="http://schemas.microsoft.com/office/drawing/2014/main" id="{07D81DC7-CCEC-2218-24C8-87013A14A693}"/>
               </a:ext>
             </a:extLst>
           </p:cNvPr>
@@ -18677,7 +18677,7 @@
           <p:cNvPr id="25" name="文本框 24">
             <a:extLst>
               <a:ext uri="{FF2B5EF4-FFF2-40B4-BE49-F238E27FC236}">
-                <a16:creationId xmlns:a16="http://schemas.microsoft.com/office/drawing/2014/main" id="{7C9822ED-037B-7C7F-9A0F-D2444292692D}"/>
+                <a16:creationId xmlns:a16="http://schemas.microsoft.com/office/drawing/2014/main" id="{D1811E81-32E8-74B1-8061-829D980CB038}"/>
               </a:ext>
             </a:extLst>
           </p:cNvPr>
@@ -18724,7 +18724,7 @@
           <p:cNvPr id="26" name="矩形: 圆角 25">
             <a:extLst>
               <a:ext uri="{FF2B5EF4-FFF2-40B4-BE49-F238E27FC236}">
-                <a16:creationId xmlns:a16="http://schemas.microsoft.com/office/drawing/2014/main" id="{653C4DC3-EA3F-A3A9-2A08-31628895428E}"/>
+                <a16:creationId xmlns:a16="http://schemas.microsoft.com/office/drawing/2014/main" id="{D8701C5D-C3A2-657A-439C-38A5824A1E1A}"/>
               </a:ext>
             </a:extLst>
           </p:cNvPr>
@@ -18778,7 +18778,7 @@
           <p:cNvPr id="27" name="文本框 26">
             <a:extLst>
               <a:ext uri="{FF2B5EF4-FFF2-40B4-BE49-F238E27FC236}">
-                <a16:creationId xmlns:a16="http://schemas.microsoft.com/office/drawing/2014/main" id="{553301D0-CB6D-6A2A-F89B-C3DB85D4932A}"/>
+                <a16:creationId xmlns:a16="http://schemas.microsoft.com/office/drawing/2014/main" id="{A99A8E97-A233-48D0-1134-BE57999E83A8}"/>
               </a:ext>
             </a:extLst>
           </p:cNvPr>
@@ -18825,7 +18825,7 @@
           <p:cNvPr id="28" name="矩形: 圆角 27">
             <a:extLst>
               <a:ext uri="{FF2B5EF4-FFF2-40B4-BE49-F238E27FC236}">
-                <a16:creationId xmlns:a16="http://schemas.microsoft.com/office/drawing/2014/main" id="{3967EFE5-38C0-0777-1A0A-08640A1F126A}"/>
+                <a16:creationId xmlns:a16="http://schemas.microsoft.com/office/drawing/2014/main" id="{3190AFAC-FC30-D4B4-5EF1-E1AE60BA8654}"/>
               </a:ext>
             </a:extLst>
           </p:cNvPr>
@@ -18879,7 +18879,7 @@
           <p:cNvPr id="29" name="文本框 28">
             <a:extLst>
               <a:ext uri="{FF2B5EF4-FFF2-40B4-BE49-F238E27FC236}">
-                <a16:creationId xmlns:a16="http://schemas.microsoft.com/office/drawing/2014/main" id="{1446868A-E30F-1A1C-2B7C-21BD17F93AF3}"/>
+                <a16:creationId xmlns:a16="http://schemas.microsoft.com/office/drawing/2014/main" id="{A35E3808-B5B9-D447-06CB-20594A4FEB37}"/>
               </a:ext>
             </a:extLst>
           </p:cNvPr>
@@ -18920,7 +18920,7 @@
           <p:cNvPr id="30" name="矩形: 圆角 29">
             <a:extLst>
               <a:ext uri="{FF2B5EF4-FFF2-40B4-BE49-F238E27FC236}">
-                <a16:creationId xmlns:a16="http://schemas.microsoft.com/office/drawing/2014/main" id="{3223FD6B-6728-3861-4A8D-5541E4D8B8A7}"/>
+                <a16:creationId xmlns:a16="http://schemas.microsoft.com/office/drawing/2014/main" id="{B3C41CF4-73DA-C538-1A90-D01136480246}"/>
               </a:ext>
             </a:extLst>
           </p:cNvPr>
@@ -18974,7 +18974,7 @@
           <p:cNvPr id="31" name="文本框 30">
             <a:extLst>
               <a:ext uri="{FF2B5EF4-FFF2-40B4-BE49-F238E27FC236}">
-                <a16:creationId xmlns:a16="http://schemas.microsoft.com/office/drawing/2014/main" id="{AEB17E6D-A807-430E-BEB0-376B3B612BC0}"/>
+                <a16:creationId xmlns:a16="http://schemas.microsoft.com/office/drawing/2014/main" id="{92318DD4-F98F-9031-7DB3-04C01D86B986}"/>
               </a:ext>
             </a:extLst>
           </p:cNvPr>
@@ -19021,7 +19021,7 @@
           <p:cNvPr id="32" name="矩形: 圆角 31">
             <a:extLst>
               <a:ext uri="{FF2B5EF4-FFF2-40B4-BE49-F238E27FC236}">
-                <a16:creationId xmlns:a16="http://schemas.microsoft.com/office/drawing/2014/main" id="{D07246B6-2CAF-FE58-73EC-638DF3140A5D}"/>
+                <a16:creationId xmlns:a16="http://schemas.microsoft.com/office/drawing/2014/main" id="{B147C553-6018-4BDB-CCE4-E20759B1D141}"/>
               </a:ext>
             </a:extLst>
           </p:cNvPr>
@@ -19075,7 +19075,7 @@
           <p:cNvPr id="33" name="文本框 32">
             <a:extLst>
               <a:ext uri="{FF2B5EF4-FFF2-40B4-BE49-F238E27FC236}">
-                <a16:creationId xmlns:a16="http://schemas.microsoft.com/office/drawing/2014/main" id="{A7844AC0-900F-22A9-EABB-BE51726F9790}"/>
+                <a16:creationId xmlns:a16="http://schemas.microsoft.com/office/drawing/2014/main" id="{8C83103C-2B62-7818-57EC-EE3060EDCAA6}"/>
               </a:ext>
             </a:extLst>
           </p:cNvPr>
@@ -19122,7 +19122,7 @@
           <p:cNvPr id="34" name="矩形: 圆角 33">
             <a:extLst>
               <a:ext uri="{FF2B5EF4-FFF2-40B4-BE49-F238E27FC236}">
-                <a16:creationId xmlns:a16="http://schemas.microsoft.com/office/drawing/2014/main" id="{5F343455-1D39-1353-C367-3FCB6324C720}"/>
+                <a16:creationId xmlns:a16="http://schemas.microsoft.com/office/drawing/2014/main" id="{113809B0-CB62-A24E-3703-4B10D1A3DA4D}"/>
               </a:ext>
             </a:extLst>
           </p:cNvPr>
@@ -19176,7 +19176,7 @@
           <p:cNvPr id="35" name="文本框 34">
             <a:extLst>
               <a:ext uri="{FF2B5EF4-FFF2-40B4-BE49-F238E27FC236}">
-                <a16:creationId xmlns:a16="http://schemas.microsoft.com/office/drawing/2014/main" id="{D6B7DE3E-A3DB-AB26-E367-C9846DD9E638}"/>
+                <a16:creationId xmlns:a16="http://schemas.microsoft.com/office/drawing/2014/main" id="{96392719-658C-F45B-9C0F-29BF29DD48C1}"/>
               </a:ext>
             </a:extLst>
           </p:cNvPr>
@@ -19232,7 +19232,7 @@
           <p:cNvPr id="36" name="矩形: 圆角 35">
             <a:extLst>
               <a:ext uri="{FF2B5EF4-FFF2-40B4-BE49-F238E27FC236}">
-                <a16:creationId xmlns:a16="http://schemas.microsoft.com/office/drawing/2014/main" id="{608EE805-C997-526F-0ACF-2AFEBABB3C03}"/>
+                <a16:creationId xmlns:a16="http://schemas.microsoft.com/office/drawing/2014/main" id="{F41B36C9-27AF-EAE3-E5D2-E1844D54A8C1}"/>
               </a:ext>
             </a:extLst>
           </p:cNvPr>
@@ -19286,7 +19286,7 @@
           <p:cNvPr id="37" name="文本框 36">
             <a:extLst>
               <a:ext uri="{FF2B5EF4-FFF2-40B4-BE49-F238E27FC236}">
-                <a16:creationId xmlns:a16="http://schemas.microsoft.com/office/drawing/2014/main" id="{CFC1907D-A57A-DDBF-F39E-72562CEE433B}"/>
+                <a16:creationId xmlns:a16="http://schemas.microsoft.com/office/drawing/2014/main" id="{789D3870-5BC9-2452-747A-EBADC9E96FD0}"/>
               </a:ext>
             </a:extLst>
           </p:cNvPr>
@@ -19333,7 +19333,7 @@
           <p:cNvPr id="38" name="矩形: 圆角 37">
             <a:extLst>
               <a:ext uri="{FF2B5EF4-FFF2-40B4-BE49-F238E27FC236}">
-                <a16:creationId xmlns:a16="http://schemas.microsoft.com/office/drawing/2014/main" id="{BF60151A-6B3E-0EC8-8E91-EE2917919605}"/>
+                <a16:creationId xmlns:a16="http://schemas.microsoft.com/office/drawing/2014/main" id="{01BC7046-FD05-25FC-F23F-1CCA2AD44E18}"/>
               </a:ext>
             </a:extLst>
           </p:cNvPr>
@@ -19387,7 +19387,7 @@
           <p:cNvPr id="39" name="文本框 38">
             <a:extLst>
               <a:ext uri="{FF2B5EF4-FFF2-40B4-BE49-F238E27FC236}">
-                <a16:creationId xmlns:a16="http://schemas.microsoft.com/office/drawing/2014/main" id="{C7FAF9D0-2901-059E-DD5F-CF7C27B3597F}"/>
+                <a16:creationId xmlns:a16="http://schemas.microsoft.com/office/drawing/2014/main" id="{EBB5771D-ADAB-FD82-2C1E-45021E69A7AB}"/>
               </a:ext>
             </a:extLst>
           </p:cNvPr>
@@ -19434,7 +19434,7 @@
           <p:cNvPr id="40" name="矩形: 圆角 39">
             <a:extLst>
               <a:ext uri="{FF2B5EF4-FFF2-40B4-BE49-F238E27FC236}">
-                <a16:creationId xmlns:a16="http://schemas.microsoft.com/office/drawing/2014/main" id="{B7058C76-1804-832C-5AA6-6550B13B9B93}"/>
+                <a16:creationId xmlns:a16="http://schemas.microsoft.com/office/drawing/2014/main" id="{20921A23-2CBC-F1C3-C8BF-D6586F907398}"/>
               </a:ext>
             </a:extLst>
           </p:cNvPr>
@@ -19488,7 +19488,7 @@
           <p:cNvPr id="41" name="文本框 40">
             <a:extLst>
               <a:ext uri="{FF2B5EF4-FFF2-40B4-BE49-F238E27FC236}">
-                <a16:creationId xmlns:a16="http://schemas.microsoft.com/office/drawing/2014/main" id="{A9B9DBC3-5E54-C0AC-B978-2BF4F2A65AA5}"/>
+                <a16:creationId xmlns:a16="http://schemas.microsoft.com/office/drawing/2014/main" id="{A08EA999-93EF-695C-4863-AC929AF8D0D3}"/>
               </a:ext>
             </a:extLst>
           </p:cNvPr>
@@ -19553,7 +19553,7 @@
           <p:cNvPr id="42" name="矩形: 圆角 41">
             <a:extLst>
               <a:ext uri="{FF2B5EF4-FFF2-40B4-BE49-F238E27FC236}">
-                <a16:creationId xmlns:a16="http://schemas.microsoft.com/office/drawing/2014/main" id="{3858D396-B2F8-0F3A-585D-BB9A145BEE95}"/>
+                <a16:creationId xmlns:a16="http://schemas.microsoft.com/office/drawing/2014/main" id="{052E673A-3102-00DA-46C2-2DB23CDDAC1C}"/>
               </a:ext>
             </a:extLst>
           </p:cNvPr>
@@ -19607,7 +19607,7 @@
           <p:cNvPr id="43" name="文本框 42">
             <a:extLst>
               <a:ext uri="{FF2B5EF4-FFF2-40B4-BE49-F238E27FC236}">
-                <a16:creationId xmlns:a16="http://schemas.microsoft.com/office/drawing/2014/main" id="{6DF2A841-4722-0CD0-794C-1CDA473C3116}"/>
+                <a16:creationId xmlns:a16="http://schemas.microsoft.com/office/drawing/2014/main" id="{29A2987D-11D6-45CD-4D8D-376EA7C8C359}"/>
               </a:ext>
             </a:extLst>
           </p:cNvPr>
@@ -19654,7 +19654,7 @@
           <p:cNvPr id="44" name="矩形: 圆角 43">
             <a:extLst>
               <a:ext uri="{FF2B5EF4-FFF2-40B4-BE49-F238E27FC236}">
-                <a16:creationId xmlns:a16="http://schemas.microsoft.com/office/drawing/2014/main" id="{1819C80F-235B-8A6A-F842-AAD3E1EE1718}"/>
+                <a16:creationId xmlns:a16="http://schemas.microsoft.com/office/drawing/2014/main" id="{90744D4F-7422-CA3D-5FDD-E2ADAADF9FFA}"/>
               </a:ext>
             </a:extLst>
           </p:cNvPr>
@@ -19708,7 +19708,7 @@
           <p:cNvPr id="45" name="文本框 44">
             <a:extLst>
               <a:ext uri="{FF2B5EF4-FFF2-40B4-BE49-F238E27FC236}">
-                <a16:creationId xmlns:a16="http://schemas.microsoft.com/office/drawing/2014/main" id="{97B7F6F4-0A69-0476-DD01-CDF9807DFB18}"/>
+                <a16:creationId xmlns:a16="http://schemas.microsoft.com/office/drawing/2014/main" id="{B3F74FBF-17CB-2524-471E-3580C8D3D67E}"/>
               </a:ext>
             </a:extLst>
           </p:cNvPr>
@@ -19755,7 +19755,7 @@
           <p:cNvPr id="46" name="矩形: 圆角 45">
             <a:extLst>
               <a:ext uri="{FF2B5EF4-FFF2-40B4-BE49-F238E27FC236}">
-                <a16:creationId xmlns:a16="http://schemas.microsoft.com/office/drawing/2014/main" id="{4CC9AE7F-A69F-2473-D293-345F06412E16}"/>
+                <a16:creationId xmlns:a16="http://schemas.microsoft.com/office/drawing/2014/main" id="{AC101968-2CB0-134B-4052-8EC70BF00636}"/>
               </a:ext>
             </a:extLst>
           </p:cNvPr>
@@ -19809,7 +19809,7 @@
           <p:cNvPr id="47" name="文本框 46">
             <a:extLst>
               <a:ext uri="{FF2B5EF4-FFF2-40B4-BE49-F238E27FC236}">
-                <a16:creationId xmlns:a16="http://schemas.microsoft.com/office/drawing/2014/main" id="{305EA2D1-913A-8F9C-F661-E62130CFCF9D}"/>
+                <a16:creationId xmlns:a16="http://schemas.microsoft.com/office/drawing/2014/main" id="{5718BC67-2EC2-5D82-FD38-CCAFAC33F98B}"/>
               </a:ext>
             </a:extLst>
           </p:cNvPr>
@@ -19850,7 +19850,7 @@
           <p:cNvPr id="48" name="矩形: 圆角 47">
             <a:extLst>
               <a:ext uri="{FF2B5EF4-FFF2-40B4-BE49-F238E27FC236}">
-                <a16:creationId xmlns:a16="http://schemas.microsoft.com/office/drawing/2014/main" id="{986D0943-1086-6908-EA63-28AB9224E25B}"/>
+                <a16:creationId xmlns:a16="http://schemas.microsoft.com/office/drawing/2014/main" id="{207B0FD8-D5F3-B836-2A5A-AF07D5EDADF0}"/>
               </a:ext>
             </a:extLst>
           </p:cNvPr>
@@ -19904,7 +19904,7 @@
           <p:cNvPr id="49" name="文本框 48">
             <a:extLst>
               <a:ext uri="{FF2B5EF4-FFF2-40B4-BE49-F238E27FC236}">
-                <a16:creationId xmlns:a16="http://schemas.microsoft.com/office/drawing/2014/main" id="{94C3CF41-CBD4-D726-9301-9E239D8557FE}"/>
+                <a16:creationId xmlns:a16="http://schemas.microsoft.com/office/drawing/2014/main" id="{52EA0D99-3297-FAE9-C081-5655C833FDA8}"/>
               </a:ext>
             </a:extLst>
           </p:cNvPr>
@@ -19943,7 +19943,7 @@
     </p:spTree>
     <p:extLst>
       <p:ext uri="{BB962C8B-B14F-4D97-AF65-F5344CB8AC3E}">
-        <p14:creationId xmlns:p14="http://schemas.microsoft.com/office/powerpoint/2010/main" val="4048136120"/>
+        <p14:creationId xmlns:p14="http://schemas.microsoft.com/office/powerpoint/2010/main" val="1421720076"/>
       </p:ext>
     </p:extLst>
   </p:cSld>
@@ -19975,7 +19975,7 @@
           <p:cNvPr id="2" name="矩形 1">
             <a:extLst>
               <a:ext uri="{FF2B5EF4-FFF2-40B4-BE49-F238E27FC236}">
-                <a16:creationId xmlns:a16="http://schemas.microsoft.com/office/drawing/2014/main" id="{BF38D550-A8FE-4CFB-6667-B194B860B062}"/>
+                <a16:creationId xmlns:a16="http://schemas.microsoft.com/office/drawing/2014/main" id="{5C72C6AC-1F1A-006C-BB77-D9B7E644CC38}"/>
               </a:ext>
             </a:extLst>
           </p:cNvPr>
@@ -20029,7 +20029,7 @@
           <p:cNvPr id="3" name="矩形 2">
             <a:extLst>
               <a:ext uri="{FF2B5EF4-FFF2-40B4-BE49-F238E27FC236}">
-                <a16:creationId xmlns:a16="http://schemas.microsoft.com/office/drawing/2014/main" id="{5E7EACE8-5DF9-8FD0-2CB7-8071E0774EB5}"/>
+                <a16:creationId xmlns:a16="http://schemas.microsoft.com/office/drawing/2014/main" id="{88CB65B2-840F-E142-D68F-650EE84B2E2E}"/>
               </a:ext>
             </a:extLst>
           </p:cNvPr>
@@ -20083,7 +20083,7 @@
           <p:cNvPr id="4" name="矩形 3">
             <a:extLst>
               <a:ext uri="{FF2B5EF4-FFF2-40B4-BE49-F238E27FC236}">
-                <a16:creationId xmlns:a16="http://schemas.microsoft.com/office/drawing/2014/main" id="{AC5AF92E-EEAE-68BF-BD26-F66CA85FB733}"/>
+                <a16:creationId xmlns:a16="http://schemas.microsoft.com/office/drawing/2014/main" id="{080A7E6F-0901-8E83-DC49-9383DBD9A9F1}"/>
               </a:ext>
             </a:extLst>
           </p:cNvPr>
@@ -20137,7 +20137,7 @@
           <p:cNvPr id="5" name="文本框 4">
             <a:extLst>
               <a:ext uri="{FF2B5EF4-FFF2-40B4-BE49-F238E27FC236}">
-                <a16:creationId xmlns:a16="http://schemas.microsoft.com/office/drawing/2014/main" id="{053D74C7-9048-D208-D246-429580331750}"/>
+                <a16:creationId xmlns:a16="http://schemas.microsoft.com/office/drawing/2014/main" id="{7F8E708A-B99C-606F-21D1-4823869067AD}"/>
               </a:ext>
             </a:extLst>
           </p:cNvPr>
@@ -20186,7 +20186,7 @@
           <p:cNvPr id="6" name="文本框 5">
             <a:extLst>
               <a:ext uri="{FF2B5EF4-FFF2-40B4-BE49-F238E27FC236}">
-                <a16:creationId xmlns:a16="http://schemas.microsoft.com/office/drawing/2014/main" id="{DB26F40A-91E3-1251-B426-55972E1DEA1E}"/>
+                <a16:creationId xmlns:a16="http://schemas.microsoft.com/office/drawing/2014/main" id="{3D1E5363-E129-285D-A649-F423D33FA008}"/>
               </a:ext>
             </a:extLst>
           </p:cNvPr>
@@ -20233,7 +20233,7 @@
           <p:cNvPr id="7" name="文本框 6">
             <a:extLst>
               <a:ext uri="{FF2B5EF4-FFF2-40B4-BE49-F238E27FC236}">
-                <a16:creationId xmlns:a16="http://schemas.microsoft.com/office/drawing/2014/main" id="{B5E1EF20-882D-3D10-03F0-9A9B93D462C2}"/>
+                <a16:creationId xmlns:a16="http://schemas.microsoft.com/office/drawing/2014/main" id="{A01310FB-91F1-94C4-823E-C277664B3257}"/>
               </a:ext>
             </a:extLst>
           </p:cNvPr>
@@ -20282,7 +20282,7 @@
           <p:cNvPr id="8" name="矩形: 圆角 7">
             <a:extLst>
               <a:ext uri="{FF2B5EF4-FFF2-40B4-BE49-F238E27FC236}">
-                <a16:creationId xmlns:a16="http://schemas.microsoft.com/office/drawing/2014/main" id="{C2763EF1-AC8F-02B6-87D2-7438DC030C18}"/>
+                <a16:creationId xmlns:a16="http://schemas.microsoft.com/office/drawing/2014/main" id="{246C1E81-E3FC-D7AF-BC79-6B72D285F2FB}"/>
               </a:ext>
             </a:extLst>
           </p:cNvPr>
@@ -20344,7 +20344,7 @@
           <p:cNvPr id="9" name="文本框 8">
             <a:extLst>
               <a:ext uri="{FF2B5EF4-FFF2-40B4-BE49-F238E27FC236}">
-                <a16:creationId xmlns:a16="http://schemas.microsoft.com/office/drawing/2014/main" id="{1D6CBD6B-0944-3785-C4B0-F0F13B0F9A84}"/>
+                <a16:creationId xmlns:a16="http://schemas.microsoft.com/office/drawing/2014/main" id="{34EEFAB9-32E7-08D5-1DD4-95F19613840E}"/>
               </a:ext>
             </a:extLst>
           </p:cNvPr>
@@ -20391,7 +20391,7 @@
           <p:cNvPr id="10" name="矩形: 圆角 9">
             <a:extLst>
               <a:ext uri="{FF2B5EF4-FFF2-40B4-BE49-F238E27FC236}">
-                <a16:creationId xmlns:a16="http://schemas.microsoft.com/office/drawing/2014/main" id="{0905E7C2-375B-CB8A-516D-E846B58F315A}"/>
+                <a16:creationId xmlns:a16="http://schemas.microsoft.com/office/drawing/2014/main" id="{8C6E26F4-DBA2-ACA3-62F0-CCEE718510AA}"/>
               </a:ext>
             </a:extLst>
           </p:cNvPr>
@@ -20459,7 +20459,7 @@
           <p:cNvPr id="11" name="文本框 10">
             <a:extLst>
               <a:ext uri="{FF2B5EF4-FFF2-40B4-BE49-F238E27FC236}">
-                <a16:creationId xmlns:a16="http://schemas.microsoft.com/office/drawing/2014/main" id="{24D47909-9A03-9106-C733-DC42CC7E3DB6}"/>
+                <a16:creationId xmlns:a16="http://schemas.microsoft.com/office/drawing/2014/main" id="{2149C444-A0B3-5E2E-2F14-C30209ABA2B1}"/>
               </a:ext>
             </a:extLst>
           </p:cNvPr>
@@ -20506,7 +20506,7 @@
           <p:cNvPr id="12" name="矩形: 圆角 11">
             <a:extLst>
               <a:ext uri="{FF2B5EF4-FFF2-40B4-BE49-F238E27FC236}">
-                <a16:creationId xmlns:a16="http://schemas.microsoft.com/office/drawing/2014/main" id="{1E814D49-7D69-AFA7-BF30-2A4F7BD4EAC9}"/>
+                <a16:creationId xmlns:a16="http://schemas.microsoft.com/office/drawing/2014/main" id="{02B498B6-972A-1706-00C8-DE1BC797DA7C}"/>
               </a:ext>
             </a:extLst>
           </p:cNvPr>
@@ -20574,7 +20574,7 @@
           <p:cNvPr id="13" name="文本框 12">
             <a:extLst>
               <a:ext uri="{FF2B5EF4-FFF2-40B4-BE49-F238E27FC236}">
-                <a16:creationId xmlns:a16="http://schemas.microsoft.com/office/drawing/2014/main" id="{C31DC655-C1C4-23D5-51D9-874391FAFBF3}"/>
+                <a16:creationId xmlns:a16="http://schemas.microsoft.com/office/drawing/2014/main" id="{33298127-27F5-8F7D-9EEF-96DA03E8E046}"/>
               </a:ext>
             </a:extLst>
           </p:cNvPr>
@@ -20621,7 +20621,7 @@
           <p:cNvPr id="14" name="矩形: 圆角 13">
             <a:extLst>
               <a:ext uri="{FF2B5EF4-FFF2-40B4-BE49-F238E27FC236}">
-                <a16:creationId xmlns:a16="http://schemas.microsoft.com/office/drawing/2014/main" id="{39CFE8B6-687D-9C1F-E606-DF2D65FD1421}"/>
+                <a16:creationId xmlns:a16="http://schemas.microsoft.com/office/drawing/2014/main" id="{60BED2AB-86B5-D8AC-52EE-62B8EDD7C2E6}"/>
               </a:ext>
             </a:extLst>
           </p:cNvPr>
@@ -20689,7 +20689,7 @@
           <p:cNvPr id="15" name="文本框 14">
             <a:extLst>
               <a:ext uri="{FF2B5EF4-FFF2-40B4-BE49-F238E27FC236}">
-                <a16:creationId xmlns:a16="http://schemas.microsoft.com/office/drawing/2014/main" id="{7F97989B-F590-51F8-F27C-7922C43F9D05}"/>
+                <a16:creationId xmlns:a16="http://schemas.microsoft.com/office/drawing/2014/main" id="{0B2F300E-6ED9-FE93-2ACE-D5130A8C825D}"/>
               </a:ext>
             </a:extLst>
           </p:cNvPr>
@@ -20736,7 +20736,7 @@
           <p:cNvPr id="16" name="矩形: 圆角 15">
             <a:extLst>
               <a:ext uri="{FF2B5EF4-FFF2-40B4-BE49-F238E27FC236}">
-                <a16:creationId xmlns:a16="http://schemas.microsoft.com/office/drawing/2014/main" id="{58633062-492C-0413-44CA-1EBF948A7A80}"/>
+                <a16:creationId xmlns:a16="http://schemas.microsoft.com/office/drawing/2014/main" id="{BAC04337-952A-30F4-8E30-E091FC22729E}"/>
               </a:ext>
             </a:extLst>
           </p:cNvPr>
@@ -20804,7 +20804,7 @@
           <p:cNvPr id="17" name="矩形: 圆角 16">
             <a:extLst>
               <a:ext uri="{FF2B5EF4-FFF2-40B4-BE49-F238E27FC236}">
-                <a16:creationId xmlns:a16="http://schemas.microsoft.com/office/drawing/2014/main" id="{102DA8FD-31FE-841B-2422-AD04C8742D78}"/>
+                <a16:creationId xmlns:a16="http://schemas.microsoft.com/office/drawing/2014/main" id="{DDF21117-6C5D-D9EA-2BFB-7D7923179C67}"/>
               </a:ext>
             </a:extLst>
           </p:cNvPr>
@@ -20866,7 +20866,7 @@
           <p:cNvPr id="18" name="矩形: 圆角 17">
             <a:extLst>
               <a:ext uri="{FF2B5EF4-FFF2-40B4-BE49-F238E27FC236}">
-                <a16:creationId xmlns:a16="http://schemas.microsoft.com/office/drawing/2014/main" id="{17E0A099-30CD-EEBF-B249-A4D91F28D879}"/>
+                <a16:creationId xmlns:a16="http://schemas.microsoft.com/office/drawing/2014/main" id="{E6E92763-8BC6-9CEA-CB6D-BD7FD02D0506}"/>
               </a:ext>
             </a:extLst>
           </p:cNvPr>
@@ -20937,7 +20937,7 @@
           <p:cNvPr id="19" name="矩形: 圆角 18">
             <a:extLst>
               <a:ext uri="{FF2B5EF4-FFF2-40B4-BE49-F238E27FC236}">
-                <a16:creationId xmlns:a16="http://schemas.microsoft.com/office/drawing/2014/main" id="{0FFB25CB-98B0-BF4B-7B8D-B6BA37F8C551}"/>
+                <a16:creationId xmlns:a16="http://schemas.microsoft.com/office/drawing/2014/main" id="{92542A87-499C-06DB-53E7-9F18F8591C06}"/>
               </a:ext>
             </a:extLst>
           </p:cNvPr>
@@ -20997,7 +20997,7 @@
     </p:spTree>
     <p:extLst>
       <p:ext uri="{BB962C8B-B14F-4D97-AF65-F5344CB8AC3E}">
-        <p14:creationId xmlns:p14="http://schemas.microsoft.com/office/powerpoint/2010/main" val="4245473320"/>
+        <p14:creationId xmlns:p14="http://schemas.microsoft.com/office/powerpoint/2010/main" val="4004200068"/>
       </p:ext>
     </p:extLst>
   </p:cSld>
@@ -21029,7 +21029,7 @@
           <p:cNvPr id="2" name="矩形 1">
             <a:extLst>
               <a:ext uri="{FF2B5EF4-FFF2-40B4-BE49-F238E27FC236}">
-                <a16:creationId xmlns:a16="http://schemas.microsoft.com/office/drawing/2014/main" id="{1C95DFFC-46DE-C693-E21F-C6FA2A6199C7}"/>
+                <a16:creationId xmlns:a16="http://schemas.microsoft.com/office/drawing/2014/main" id="{0021862B-111C-545E-0479-4E56A41F0D96}"/>
               </a:ext>
             </a:extLst>
           </p:cNvPr>
@@ -21083,7 +21083,7 @@
           <p:cNvPr id="3" name="矩形 2">
             <a:extLst>
               <a:ext uri="{FF2B5EF4-FFF2-40B4-BE49-F238E27FC236}">
-                <a16:creationId xmlns:a16="http://schemas.microsoft.com/office/drawing/2014/main" id="{6A433284-BA7F-9CB8-0948-5142B8402780}"/>
+                <a16:creationId xmlns:a16="http://schemas.microsoft.com/office/drawing/2014/main" id="{F6B5E4BF-1DFB-4C73-4573-02A096C05E92}"/>
               </a:ext>
             </a:extLst>
           </p:cNvPr>
@@ -21137,7 +21137,7 @@
           <p:cNvPr id="4" name="矩形 3">
             <a:extLst>
               <a:ext uri="{FF2B5EF4-FFF2-40B4-BE49-F238E27FC236}">
-                <a16:creationId xmlns:a16="http://schemas.microsoft.com/office/drawing/2014/main" id="{17DE1820-2C96-3896-DB3E-B527E1F9E02A}"/>
+                <a16:creationId xmlns:a16="http://schemas.microsoft.com/office/drawing/2014/main" id="{90D2E749-D62A-633E-7B35-E73FEBC72384}"/>
               </a:ext>
             </a:extLst>
           </p:cNvPr>
@@ -21191,7 +21191,7 @@
           <p:cNvPr id="5" name="文本框 4">
             <a:extLst>
               <a:ext uri="{FF2B5EF4-FFF2-40B4-BE49-F238E27FC236}">
-                <a16:creationId xmlns:a16="http://schemas.microsoft.com/office/drawing/2014/main" id="{05EBBE16-1957-4C71-3C76-E28E43C74BDD}"/>
+                <a16:creationId xmlns:a16="http://schemas.microsoft.com/office/drawing/2014/main" id="{720D0066-53FC-B850-D391-020D50882742}"/>
               </a:ext>
             </a:extLst>
           </p:cNvPr>
@@ -21255,7 +21255,7 @@
           <p:cNvPr id="6" name="文本框 5">
             <a:extLst>
               <a:ext uri="{FF2B5EF4-FFF2-40B4-BE49-F238E27FC236}">
-                <a16:creationId xmlns:a16="http://schemas.microsoft.com/office/drawing/2014/main" id="{8B6AE7C9-508C-B553-5A6F-FE03A3F5D3CD}"/>
+                <a16:creationId xmlns:a16="http://schemas.microsoft.com/office/drawing/2014/main" id="{2BC6F622-A4D3-50F8-748D-69A9E4FDE56B}"/>
               </a:ext>
             </a:extLst>
           </p:cNvPr>
@@ -21302,7 +21302,7 @@
           <p:cNvPr id="7" name="文本框 6">
             <a:extLst>
               <a:ext uri="{FF2B5EF4-FFF2-40B4-BE49-F238E27FC236}">
-                <a16:creationId xmlns:a16="http://schemas.microsoft.com/office/drawing/2014/main" id="{571A4016-4CE9-8317-188A-574338819006}"/>
+                <a16:creationId xmlns:a16="http://schemas.microsoft.com/office/drawing/2014/main" id="{3115F3ED-4CA8-C5FC-7ECC-1F0ED8334F24}"/>
               </a:ext>
             </a:extLst>
           </p:cNvPr>
@@ -21387,7 +21387,7 @@
           <p:cNvPr id="8" name="矩形: 圆角 7">
             <a:extLst>
               <a:ext uri="{FF2B5EF4-FFF2-40B4-BE49-F238E27FC236}">
-                <a16:creationId xmlns:a16="http://schemas.microsoft.com/office/drawing/2014/main" id="{7663D9D9-1828-7F40-4343-7517517C931E}"/>
+                <a16:creationId xmlns:a16="http://schemas.microsoft.com/office/drawing/2014/main" id="{47661345-3C26-9CF0-85CB-5D06F2CAEC83}"/>
               </a:ext>
             </a:extLst>
           </p:cNvPr>
@@ -21455,7 +21455,7 @@
           <p:cNvPr id="9" name="矩形: 圆角 8">
             <a:extLst>
               <a:ext uri="{FF2B5EF4-FFF2-40B4-BE49-F238E27FC236}">
-                <a16:creationId xmlns:a16="http://schemas.microsoft.com/office/drawing/2014/main" id="{9455E2DF-A5D5-E8CA-2FFB-D24F672178CC}"/>
+                <a16:creationId xmlns:a16="http://schemas.microsoft.com/office/drawing/2014/main" id="{B8035775-DAE6-1262-5362-2D034E9151C6}"/>
               </a:ext>
             </a:extLst>
           </p:cNvPr>
@@ -21535,7 +21535,7 @@
           <p:cNvPr id="10" name="矩形: 圆角 9">
             <a:extLst>
               <a:ext uri="{FF2B5EF4-FFF2-40B4-BE49-F238E27FC236}">
-                <a16:creationId xmlns:a16="http://schemas.microsoft.com/office/drawing/2014/main" id="{08447280-1F63-BB5B-6F6A-AA847594AF4E}"/>
+                <a16:creationId xmlns:a16="http://schemas.microsoft.com/office/drawing/2014/main" id="{052F133C-F95F-C1B9-8726-C2A0D866FCE5}"/>
               </a:ext>
             </a:extLst>
           </p:cNvPr>
@@ -21603,7 +21603,7 @@
           <p:cNvPr id="11" name="矩形: 圆角 10">
             <a:extLst>
               <a:ext uri="{FF2B5EF4-FFF2-40B4-BE49-F238E27FC236}">
-                <a16:creationId xmlns:a16="http://schemas.microsoft.com/office/drawing/2014/main" id="{121F8BDF-0A0A-E7DC-DF24-3D28B3D0524E}"/>
+                <a16:creationId xmlns:a16="http://schemas.microsoft.com/office/drawing/2014/main" id="{5C7C6C26-1510-CD91-B198-98E678B7635E}"/>
               </a:ext>
             </a:extLst>
           </p:cNvPr>
@@ -21689,7 +21689,7 @@
           <p:cNvPr id="12" name="矩形: 圆角 11">
             <a:extLst>
               <a:ext uri="{FF2B5EF4-FFF2-40B4-BE49-F238E27FC236}">
-                <a16:creationId xmlns:a16="http://schemas.microsoft.com/office/drawing/2014/main" id="{1B1FC52C-DCBF-4D92-0292-3D234EDF4A41}"/>
+                <a16:creationId xmlns:a16="http://schemas.microsoft.com/office/drawing/2014/main" id="{95124688-FC2C-9772-67B8-266C5268E265}"/>
               </a:ext>
             </a:extLst>
           </p:cNvPr>
@@ -21775,7 +21775,7 @@
           <p:cNvPr id="13" name="矩形: 圆角 12">
             <a:extLst>
               <a:ext uri="{FF2B5EF4-FFF2-40B4-BE49-F238E27FC236}">
-                <a16:creationId xmlns:a16="http://schemas.microsoft.com/office/drawing/2014/main" id="{CC670CC3-887F-E658-F25E-A2A7FDB16CB2}"/>
+                <a16:creationId xmlns:a16="http://schemas.microsoft.com/office/drawing/2014/main" id="{8E2E7F25-AEE1-7F27-EB07-4C5A3B60CDCF}"/>
               </a:ext>
             </a:extLst>
           </p:cNvPr>
@@ -21843,7 +21843,7 @@
           <p:cNvPr id="14" name="文本框 13">
             <a:extLst>
               <a:ext uri="{FF2B5EF4-FFF2-40B4-BE49-F238E27FC236}">
-                <a16:creationId xmlns:a16="http://schemas.microsoft.com/office/drawing/2014/main" id="{DD22757D-7C60-D813-7487-0BB8A9D568EC}"/>
+                <a16:creationId xmlns:a16="http://schemas.microsoft.com/office/drawing/2014/main" id="{7A3AB283-C1E0-C43C-B514-9B4300721BD5}"/>
               </a:ext>
             </a:extLst>
           </p:cNvPr>
@@ -21890,7 +21890,7 @@
           <p:cNvPr id="15" name="矩形: 圆角 14">
             <a:extLst>
               <a:ext uri="{FF2B5EF4-FFF2-40B4-BE49-F238E27FC236}">
-                <a16:creationId xmlns:a16="http://schemas.microsoft.com/office/drawing/2014/main" id="{4034AD1E-3FE6-AF01-EC7F-55BA2080446E}"/>
+                <a16:creationId xmlns:a16="http://schemas.microsoft.com/office/drawing/2014/main" id="{B111A846-D13C-38B9-5C18-4113FBC2B8C2}"/>
               </a:ext>
             </a:extLst>
           </p:cNvPr>
@@ -21958,7 +21958,7 @@
           <p:cNvPr id="16" name="文本框 15">
             <a:extLst>
               <a:ext uri="{FF2B5EF4-FFF2-40B4-BE49-F238E27FC236}">
-                <a16:creationId xmlns:a16="http://schemas.microsoft.com/office/drawing/2014/main" id="{20AC813A-E4B4-F9C8-B6D9-95DAFCF7AAF5}"/>
+                <a16:creationId xmlns:a16="http://schemas.microsoft.com/office/drawing/2014/main" id="{503EF1EF-CA6E-C90F-912B-AF4BD22A3F91}"/>
               </a:ext>
             </a:extLst>
           </p:cNvPr>
@@ -22005,7 +22005,7 @@
           <p:cNvPr id="17" name="矩形: 圆角 16">
             <a:extLst>
               <a:ext uri="{FF2B5EF4-FFF2-40B4-BE49-F238E27FC236}">
-                <a16:creationId xmlns:a16="http://schemas.microsoft.com/office/drawing/2014/main" id="{72806305-7F19-D3D4-A98D-5AFF5E7B8E5C}"/>
+                <a16:creationId xmlns:a16="http://schemas.microsoft.com/office/drawing/2014/main" id="{4BBE2A16-5236-DD16-826C-1BB9EC1532CA}"/>
               </a:ext>
             </a:extLst>
           </p:cNvPr>
@@ -22073,7 +22073,7 @@
           <p:cNvPr id="18" name="矩形: 圆角 17">
             <a:extLst>
               <a:ext uri="{FF2B5EF4-FFF2-40B4-BE49-F238E27FC236}">
-                <a16:creationId xmlns:a16="http://schemas.microsoft.com/office/drawing/2014/main" id="{2CA6E9B0-974D-EED2-A177-40375DB8CAD1}"/>
+                <a16:creationId xmlns:a16="http://schemas.microsoft.com/office/drawing/2014/main" id="{2172FD6C-635C-0817-9382-4E9478033196}"/>
               </a:ext>
             </a:extLst>
           </p:cNvPr>
@@ -22133,7 +22133,7 @@
     </p:spTree>
     <p:extLst>
       <p:ext uri="{BB962C8B-B14F-4D97-AF65-F5344CB8AC3E}">
-        <p14:creationId xmlns:p14="http://schemas.microsoft.com/office/powerpoint/2010/main" val="3956391940"/>
+        <p14:creationId xmlns:p14="http://schemas.microsoft.com/office/powerpoint/2010/main" val="3417066823"/>
       </p:ext>
     </p:extLst>
   </p:cSld>
@@ -22165,7 +22165,7 @@
           <p:cNvPr id="2" name="矩形 1">
             <a:extLst>
               <a:ext uri="{FF2B5EF4-FFF2-40B4-BE49-F238E27FC236}">
-                <a16:creationId xmlns:a16="http://schemas.microsoft.com/office/drawing/2014/main" id="{F8A3F3F7-DBBF-8CDB-EE28-13C52E566644}"/>
+                <a16:creationId xmlns:a16="http://schemas.microsoft.com/office/drawing/2014/main" id="{9D8A6695-41D4-085D-2C81-DA427C4F5863}"/>
               </a:ext>
             </a:extLst>
           </p:cNvPr>
@@ -22219,7 +22219,7 @@
           <p:cNvPr id="3" name="矩形 2">
             <a:extLst>
               <a:ext uri="{FF2B5EF4-FFF2-40B4-BE49-F238E27FC236}">
-                <a16:creationId xmlns:a16="http://schemas.microsoft.com/office/drawing/2014/main" id="{88142B2B-6B02-0744-8BAE-A7C9CDC53629}"/>
+                <a16:creationId xmlns:a16="http://schemas.microsoft.com/office/drawing/2014/main" id="{EBC0244B-A599-E90B-FEDE-71BF401C4044}"/>
               </a:ext>
             </a:extLst>
           </p:cNvPr>
@@ -22273,7 +22273,7 @@
           <p:cNvPr id="4" name="矩形 3">
             <a:extLst>
               <a:ext uri="{FF2B5EF4-FFF2-40B4-BE49-F238E27FC236}">
-                <a16:creationId xmlns:a16="http://schemas.microsoft.com/office/drawing/2014/main" id="{1AAFE58E-7266-B473-966D-C67A6C5CD8D7}"/>
+                <a16:creationId xmlns:a16="http://schemas.microsoft.com/office/drawing/2014/main" id="{89059C5C-E407-1DF7-0C0C-B0E52C0E5A8A}"/>
               </a:ext>
             </a:extLst>
           </p:cNvPr>
@@ -22327,7 +22327,7 @@
           <p:cNvPr id="5" name="文本框 4">
             <a:extLst>
               <a:ext uri="{FF2B5EF4-FFF2-40B4-BE49-F238E27FC236}">
-                <a16:creationId xmlns:a16="http://schemas.microsoft.com/office/drawing/2014/main" id="{B470A85A-BACE-0686-C4D8-4431C81DDF71}"/>
+                <a16:creationId xmlns:a16="http://schemas.microsoft.com/office/drawing/2014/main" id="{3A1E3241-E65A-E6C7-705F-D1E64A9ABC15}"/>
               </a:ext>
             </a:extLst>
           </p:cNvPr>
@@ -22412,7 +22412,7 @@
           <p:cNvPr id="6" name="文本框 5">
             <a:extLst>
               <a:ext uri="{FF2B5EF4-FFF2-40B4-BE49-F238E27FC236}">
-                <a16:creationId xmlns:a16="http://schemas.microsoft.com/office/drawing/2014/main" id="{AB8C54CE-95FF-4F33-1493-0D8B2F8A4EE0}"/>
+                <a16:creationId xmlns:a16="http://schemas.microsoft.com/office/drawing/2014/main" id="{FABCF0EE-57C8-8E17-716E-B8351019A2F8}"/>
               </a:ext>
             </a:extLst>
           </p:cNvPr>
@@ -22459,7 +22459,7 @@
           <p:cNvPr id="7" name="文本框 6">
             <a:extLst>
               <a:ext uri="{FF2B5EF4-FFF2-40B4-BE49-F238E27FC236}">
-                <a16:creationId xmlns:a16="http://schemas.microsoft.com/office/drawing/2014/main" id="{6FCA3398-2A1E-6888-F70E-A15F58EDD3A4}"/>
+                <a16:creationId xmlns:a16="http://schemas.microsoft.com/office/drawing/2014/main" id="{0C0FE663-0E68-73DA-599C-57CE765FB676}"/>
               </a:ext>
             </a:extLst>
           </p:cNvPr>
@@ -22544,7 +22544,7 @@
           <p:cNvPr id="8" name="矩形: 圆角 7">
             <a:extLst>
               <a:ext uri="{FF2B5EF4-FFF2-40B4-BE49-F238E27FC236}">
-                <a16:creationId xmlns:a16="http://schemas.microsoft.com/office/drawing/2014/main" id="{801089B4-AF5F-7F71-FF50-9E6026EBE80F}"/>
+                <a16:creationId xmlns:a16="http://schemas.microsoft.com/office/drawing/2014/main" id="{001CFE36-EE66-B580-AC50-A79209EC915B}"/>
               </a:ext>
             </a:extLst>
           </p:cNvPr>
@@ -22633,7 +22633,7 @@
           <p:cNvPr id="9" name="文本框 8">
             <a:extLst>
               <a:ext uri="{FF2B5EF4-FFF2-40B4-BE49-F238E27FC236}">
-                <a16:creationId xmlns:a16="http://schemas.microsoft.com/office/drawing/2014/main" id="{70D74A64-70AC-80C7-95CF-702CEB63BBF0}"/>
+                <a16:creationId xmlns:a16="http://schemas.microsoft.com/office/drawing/2014/main" id="{8DA5AFFA-7EFA-1BDF-4C33-599060140949}"/>
               </a:ext>
             </a:extLst>
           </p:cNvPr>
@@ -22680,7 +22680,7 @@
           <p:cNvPr id="10" name="矩形: 圆角 9">
             <a:extLst>
               <a:ext uri="{FF2B5EF4-FFF2-40B4-BE49-F238E27FC236}">
-                <a16:creationId xmlns:a16="http://schemas.microsoft.com/office/drawing/2014/main" id="{4167F29C-8CB8-4D0C-AC67-6872FE7D20D7}"/>
+                <a16:creationId xmlns:a16="http://schemas.microsoft.com/office/drawing/2014/main" id="{A2882B6A-C7CB-66B4-A9A0-1185FE3DEF7A}"/>
               </a:ext>
             </a:extLst>
           </p:cNvPr>
@@ -22748,7 +22748,7 @@
           <p:cNvPr id="11" name="文本框 10">
             <a:extLst>
               <a:ext uri="{FF2B5EF4-FFF2-40B4-BE49-F238E27FC236}">
-                <a16:creationId xmlns:a16="http://schemas.microsoft.com/office/drawing/2014/main" id="{0388CA8A-A701-B333-9FC3-CF5001CCB376}"/>
+                <a16:creationId xmlns:a16="http://schemas.microsoft.com/office/drawing/2014/main" id="{664CFE0E-CBDD-E068-3705-B02B95450C77}"/>
               </a:ext>
             </a:extLst>
           </p:cNvPr>
@@ -22795,7 +22795,7 @@
           <p:cNvPr id="12" name="矩形: 圆角 11">
             <a:extLst>
               <a:ext uri="{FF2B5EF4-FFF2-40B4-BE49-F238E27FC236}">
-                <a16:creationId xmlns:a16="http://schemas.microsoft.com/office/drawing/2014/main" id="{6F20611B-269B-3DF3-8B86-ACCB8059911F}"/>
+                <a16:creationId xmlns:a16="http://schemas.microsoft.com/office/drawing/2014/main" id="{315EF7F5-9E23-30DC-CBF1-BA66345F3D33}"/>
               </a:ext>
             </a:extLst>
           </p:cNvPr>
@@ -22872,7 +22872,7 @@
           <p:cNvPr id="13" name="矩形: 圆角 12">
             <a:extLst>
               <a:ext uri="{FF2B5EF4-FFF2-40B4-BE49-F238E27FC236}">
-                <a16:creationId xmlns:a16="http://schemas.microsoft.com/office/drawing/2014/main" id="{AEEB12A4-B920-B85E-165F-D2F105B2F4C7}"/>
+                <a16:creationId xmlns:a16="http://schemas.microsoft.com/office/drawing/2014/main" id="{C5446630-D6A0-F3ED-736C-40C6F480CFEB}"/>
               </a:ext>
             </a:extLst>
           </p:cNvPr>
@@ -22940,7 +22940,7 @@
           <p:cNvPr id="14" name="矩形: 圆角 13">
             <a:extLst>
               <a:ext uri="{FF2B5EF4-FFF2-40B4-BE49-F238E27FC236}">
-                <a16:creationId xmlns:a16="http://schemas.microsoft.com/office/drawing/2014/main" id="{4FBF4056-4D36-F9CD-6492-F8A8C487FEBE}"/>
+                <a16:creationId xmlns:a16="http://schemas.microsoft.com/office/drawing/2014/main" id="{F3A4CF6A-7F1F-687A-B900-D6F0B722AADB}"/>
               </a:ext>
             </a:extLst>
           </p:cNvPr>
@@ -23008,7 +23008,7 @@
           <p:cNvPr id="15" name="矩形: 圆角 14">
             <a:extLst>
               <a:ext uri="{FF2B5EF4-FFF2-40B4-BE49-F238E27FC236}">
-                <a16:creationId xmlns:a16="http://schemas.microsoft.com/office/drawing/2014/main" id="{C2AB15C0-477E-000E-9F24-3B7DCA143479}"/>
+                <a16:creationId xmlns:a16="http://schemas.microsoft.com/office/drawing/2014/main" id="{03D24FF4-4BCD-DB73-7CCE-82F74B0C21E4}"/>
               </a:ext>
             </a:extLst>
           </p:cNvPr>
@@ -23076,7 +23076,7 @@
           <p:cNvPr id="16" name="矩形: 圆角 15">
             <a:extLst>
               <a:ext uri="{FF2B5EF4-FFF2-40B4-BE49-F238E27FC236}">
-                <a16:creationId xmlns:a16="http://schemas.microsoft.com/office/drawing/2014/main" id="{8BA17EBB-70A1-044B-22BD-DB8F6FDD2D1B}"/>
+                <a16:creationId xmlns:a16="http://schemas.microsoft.com/office/drawing/2014/main" id="{003854EF-4583-4F2E-0D0D-A2C44A55E5A6}"/>
               </a:ext>
             </a:extLst>
           </p:cNvPr>
@@ -23136,7 +23136,7 @@
     </p:spTree>
     <p:extLst>
       <p:ext uri="{BB962C8B-B14F-4D97-AF65-F5344CB8AC3E}">
-        <p14:creationId xmlns:p14="http://schemas.microsoft.com/office/powerpoint/2010/main" val="4237499338"/>
+        <p14:creationId xmlns:p14="http://schemas.microsoft.com/office/powerpoint/2010/main" val="2034490999"/>
       </p:ext>
     </p:extLst>
   </p:cSld>

</xml_diff>